<commit_message>
Update OS 10 Virtuálne zariadenia.pptx
</commit_message>
<xml_diff>
--- a/OS 10 Virtuálne zariadenia.pptx
+++ b/OS 10 Virtuálne zariadenia.pptx
@@ -5,10 +5,10 @@
     <p:sldMasterId id="2147483664" r:id="rId1"/>
   </p:sldMasterIdLst>
   <p:notesMasterIdLst>
-    <p:notesMasterId r:id="rId52"/>
+    <p:notesMasterId r:id="rId53"/>
   </p:notesMasterIdLst>
   <p:handoutMasterIdLst>
-    <p:handoutMasterId r:id="rId53"/>
+    <p:handoutMasterId r:id="rId54"/>
   </p:handoutMasterIdLst>
   <p:sldIdLst>
     <p:sldId id="321" r:id="rId2"/>
@@ -28,39 +28,40 @@
     <p:sldId id="352" r:id="rId16"/>
     <p:sldId id="353" r:id="rId17"/>
     <p:sldId id="325" r:id="rId18"/>
-    <p:sldId id="354" r:id="rId19"/>
-    <p:sldId id="355" r:id="rId20"/>
-    <p:sldId id="326" r:id="rId21"/>
-    <p:sldId id="356" r:id="rId22"/>
-    <p:sldId id="357" r:id="rId23"/>
-    <p:sldId id="327" r:id="rId24"/>
-    <p:sldId id="358" r:id="rId25"/>
-    <p:sldId id="364" r:id="rId26"/>
-    <p:sldId id="359" r:id="rId27"/>
-    <p:sldId id="360" r:id="rId28"/>
-    <p:sldId id="328" r:id="rId29"/>
-    <p:sldId id="361" r:id="rId30"/>
-    <p:sldId id="365" r:id="rId31"/>
-    <p:sldId id="362" r:id="rId32"/>
-    <p:sldId id="363" r:id="rId33"/>
-    <p:sldId id="329" r:id="rId34"/>
-    <p:sldId id="366" r:id="rId35"/>
-    <p:sldId id="367" r:id="rId36"/>
-    <p:sldId id="374" r:id="rId37"/>
-    <p:sldId id="368" r:id="rId38"/>
-    <p:sldId id="369" r:id="rId39"/>
-    <p:sldId id="370" r:id="rId40"/>
-    <p:sldId id="371" r:id="rId41"/>
-    <p:sldId id="330" r:id="rId42"/>
-    <p:sldId id="372" r:id="rId43"/>
-    <p:sldId id="331" r:id="rId44"/>
-    <p:sldId id="373" r:id="rId45"/>
-    <p:sldId id="332" r:id="rId46"/>
-    <p:sldId id="375" r:id="rId47"/>
-    <p:sldId id="376" r:id="rId48"/>
-    <p:sldId id="377" r:id="rId49"/>
-    <p:sldId id="378" r:id="rId50"/>
-    <p:sldId id="322" r:id="rId51"/>
+    <p:sldId id="355" r:id="rId19"/>
+    <p:sldId id="379" r:id="rId20"/>
+    <p:sldId id="354" r:id="rId21"/>
+    <p:sldId id="326" r:id="rId22"/>
+    <p:sldId id="356" r:id="rId23"/>
+    <p:sldId id="357" r:id="rId24"/>
+    <p:sldId id="327" r:id="rId25"/>
+    <p:sldId id="358" r:id="rId26"/>
+    <p:sldId id="364" r:id="rId27"/>
+    <p:sldId id="359" r:id="rId28"/>
+    <p:sldId id="360" r:id="rId29"/>
+    <p:sldId id="328" r:id="rId30"/>
+    <p:sldId id="361" r:id="rId31"/>
+    <p:sldId id="365" r:id="rId32"/>
+    <p:sldId id="362" r:id="rId33"/>
+    <p:sldId id="363" r:id="rId34"/>
+    <p:sldId id="329" r:id="rId35"/>
+    <p:sldId id="366" r:id="rId36"/>
+    <p:sldId id="367" r:id="rId37"/>
+    <p:sldId id="374" r:id="rId38"/>
+    <p:sldId id="368" r:id="rId39"/>
+    <p:sldId id="369" r:id="rId40"/>
+    <p:sldId id="370" r:id="rId41"/>
+    <p:sldId id="371" r:id="rId42"/>
+    <p:sldId id="330" r:id="rId43"/>
+    <p:sldId id="372" r:id="rId44"/>
+    <p:sldId id="331" r:id="rId45"/>
+    <p:sldId id="373" r:id="rId46"/>
+    <p:sldId id="332" r:id="rId47"/>
+    <p:sldId id="375" r:id="rId48"/>
+    <p:sldId id="376" r:id="rId49"/>
+    <p:sldId id="377" r:id="rId50"/>
+    <p:sldId id="378" r:id="rId51"/>
+    <p:sldId id="322" r:id="rId52"/>
   </p:sldIdLst>
   <p:sldSz cx="9144000" cy="6858000" type="screen4x3"/>
   <p:notesSz cx="7315200" cy="9601200"/>
@@ -214,142 +215,111 @@
 </p:cmAuthorLst>
 </file>
 
+<file path=ppt/revisionInfo.xml><?xml version="1.0" encoding="utf-8"?>
+<p1510:revInfo xmlns:a="http://schemas.openxmlformats.org/drawingml/2006/main" xmlns:r="http://schemas.openxmlformats.org/officeDocument/2006/relationships" xmlns:p1510="http://schemas.microsoft.com/office/powerpoint/2015/10/main">
+  <p1510:revLst>
+    <p1510:client id="{D0E3739B-5C95-4041-A33E-62979F4A0CDB}" v="9" dt="2026-04-08T11:59:15.235"/>
+  </p1510:revLst>
+</p1510:revInfo>
+</file>
+
 <file path=ppt/changesInfos/changesInfo1.xml><?xml version="1.0" encoding="utf-8"?>
 <pc:chgInfo xmlns:a="http://schemas.openxmlformats.org/drawingml/2006/main" xmlns:r="http://schemas.openxmlformats.org/officeDocument/2006/relationships" xmlns:ac="http://schemas.microsoft.com/office/drawing/2013/main/command" xmlns:pc="http://schemas.microsoft.com/office/powerpoint/2013/main/command">
   <pc:docChgLst>
-    <pc:chgData name="Baráth, Július" userId="aebde9b9-dccc-4475-a9ac-c05e78323d7a" providerId="ADAL" clId="{9191FEAF-F4D4-A645-846E-876D0BEDC323}"/>
-    <pc:docChg chg="undo custSel addSld delSld modSld">
-      <pc:chgData name="Baráth, Július" userId="aebde9b9-dccc-4475-a9ac-c05e78323d7a" providerId="ADAL" clId="{9191FEAF-F4D4-A645-846E-876D0BEDC323}" dt="2024-04-10T08:34:12.232" v="533" actId="14"/>
+    <pc:chgData name="Baráth, Július" userId="aebde9b9-dccc-4475-a9ac-c05e78323d7a" providerId="ADAL" clId="{4A0811C8-ED2F-505E-B787-C8270CED5046}"/>
+    <pc:docChg chg="undo custSel addSld modSld sldOrd">
+      <pc:chgData name="Baráth, Július" userId="aebde9b9-dccc-4475-a9ac-c05e78323d7a" providerId="ADAL" clId="{4A0811C8-ED2F-505E-B787-C8270CED5046}" dt="2026-04-08T12:13:25.991" v="262" actId="20577"/>
       <pc:docMkLst>
         <pc:docMk/>
       </pc:docMkLst>
-      <pc:sldChg chg="modSp mod">
-        <pc:chgData name="Baráth, Július" userId="aebde9b9-dccc-4475-a9ac-c05e78323d7a" providerId="ADAL" clId="{9191FEAF-F4D4-A645-846E-876D0BEDC323}" dt="2024-04-10T08:14:30.297" v="127" actId="20577"/>
+      <pc:sldChg chg="addSp modSp mod">
+        <pc:chgData name="Baráth, Július" userId="aebde9b9-dccc-4475-a9ac-c05e78323d7a" providerId="ADAL" clId="{4A0811C8-ED2F-505E-B787-C8270CED5046}" dt="2026-04-08T11:55:41.239" v="156" actId="20577"/>
         <pc:sldMkLst>
           <pc:docMk/>
-          <pc:sldMk cId="0" sldId="344"/>
+          <pc:sldMk cId="0" sldId="326"/>
         </pc:sldMkLst>
+        <pc:spChg chg="add mod">
+          <ac:chgData name="Baráth, Július" userId="aebde9b9-dccc-4475-a9ac-c05e78323d7a" providerId="ADAL" clId="{4A0811C8-ED2F-505E-B787-C8270CED5046}" dt="2026-04-08T11:55:41.239" v="156" actId="20577"/>
+          <ac:spMkLst>
+            <pc:docMk/>
+            <pc:sldMk cId="0" sldId="326"/>
+            <ac:spMk id="2" creationId="{83D4EE32-F5FB-3E13-F118-F95C26593B4F}"/>
+          </ac:spMkLst>
+        </pc:spChg>
+        <pc:picChg chg="mod">
+          <ac:chgData name="Baráth, Július" userId="aebde9b9-dccc-4475-a9ac-c05e78323d7a" providerId="ADAL" clId="{4A0811C8-ED2F-505E-B787-C8270CED5046}" dt="2026-04-08T11:55:25.493" v="152" actId="1076"/>
+          <ac:picMkLst>
+            <pc:docMk/>
+            <pc:sldMk cId="0" sldId="326"/>
+            <ac:picMk id="26626" creationId="{431FD52F-C635-152B-3BDF-554AC3327838}"/>
+          </ac:picMkLst>
+        </pc:picChg>
       </pc:sldChg>
-      <pc:sldChg chg="addSp modSp mod">
-        <pc:chgData name="Baráth, Július" userId="aebde9b9-dccc-4475-a9ac-c05e78323d7a" providerId="ADAL" clId="{9191FEAF-F4D4-A645-846E-876D0BEDC323}" dt="2024-04-10T07:06:59.212" v="1" actId="1076"/>
+      <pc:sldChg chg="ord">
+        <pc:chgData name="Baráth, Július" userId="aebde9b9-dccc-4475-a9ac-c05e78323d7a" providerId="ADAL" clId="{4A0811C8-ED2F-505E-B787-C8270CED5046}" dt="2026-04-08T11:57:37.847" v="158" actId="20578"/>
         <pc:sldMkLst>
           <pc:docMk/>
-          <pc:sldMk cId="0" sldId="350"/>
+          <pc:sldMk cId="0" sldId="354"/>
         </pc:sldMkLst>
       </pc:sldChg>
       <pc:sldChg chg="modSp mod">
-        <pc:chgData name="Baráth, Július" userId="aebde9b9-dccc-4475-a9ac-c05e78323d7a" providerId="ADAL" clId="{9191FEAF-F4D4-A645-846E-876D0BEDC323}" dt="2024-04-10T07:09:01.193" v="2" actId="115"/>
+        <pc:chgData name="Baráth, Július" userId="aebde9b9-dccc-4475-a9ac-c05e78323d7a" providerId="ADAL" clId="{4A0811C8-ED2F-505E-B787-C8270CED5046}" dt="2026-04-08T12:13:25.991" v="262" actId="20577"/>
         <pc:sldMkLst>
           <pc:docMk/>
-          <pc:sldMk cId="0" sldId="357"/>
+          <pc:sldMk cId="0" sldId="372"/>
         </pc:sldMkLst>
+        <pc:spChg chg="mod">
+          <ac:chgData name="Baráth, Július" userId="aebde9b9-dccc-4475-a9ac-c05e78323d7a" providerId="ADAL" clId="{4A0811C8-ED2F-505E-B787-C8270CED5046}" dt="2026-04-08T12:13:25.991" v="262" actId="20577"/>
+          <ac:spMkLst>
+            <pc:docMk/>
+            <pc:sldMk cId="0" sldId="372"/>
+            <ac:spMk id="40962" creationId="{84C2715E-3BB3-9564-FE6A-771622347A5E}"/>
+          </ac:spMkLst>
+        </pc:spChg>
       </pc:sldChg>
       <pc:sldChg chg="modSp mod">
-        <pc:chgData name="Baráth, Július" userId="aebde9b9-dccc-4475-a9ac-c05e78323d7a" providerId="ADAL" clId="{9191FEAF-F4D4-A645-846E-876D0BEDC323}" dt="2024-04-10T08:17:17.780" v="187" actId="20577"/>
-        <pc:sldMkLst>
-          <pc:docMk/>
-          <pc:sldMk cId="0" sldId="358"/>
-        </pc:sldMkLst>
-      </pc:sldChg>
-      <pc:sldChg chg="modSp mod">
-        <pc:chgData name="Baráth, Július" userId="aebde9b9-dccc-4475-a9ac-c05e78323d7a" providerId="ADAL" clId="{9191FEAF-F4D4-A645-846E-876D0BEDC323}" dt="2024-04-10T08:34:12.232" v="533" actId="14"/>
-        <pc:sldMkLst>
-          <pc:docMk/>
-          <pc:sldMk cId="0" sldId="359"/>
-        </pc:sldMkLst>
-      </pc:sldChg>
-      <pc:sldChg chg="modSp mod">
-        <pc:chgData name="Baráth, Július" userId="aebde9b9-dccc-4475-a9ac-c05e78323d7a" providerId="ADAL" clId="{9191FEAF-F4D4-A645-846E-876D0BEDC323}" dt="2024-04-10T07:10:51.485" v="13" actId="20577"/>
-        <pc:sldMkLst>
-          <pc:docMk/>
-          <pc:sldMk cId="0" sldId="360"/>
-        </pc:sldMkLst>
-      </pc:sldChg>
-      <pc:sldChg chg="modSp mod">
-        <pc:chgData name="Baráth, Július" userId="aebde9b9-dccc-4475-a9ac-c05e78323d7a" providerId="ADAL" clId="{9191FEAF-F4D4-A645-846E-876D0BEDC323}" dt="2024-04-10T08:29:08.659" v="350" actId="6549"/>
-        <pc:sldMkLst>
-          <pc:docMk/>
-          <pc:sldMk cId="0" sldId="364"/>
-        </pc:sldMkLst>
-      </pc:sldChg>
-      <pc:sldChg chg="addSp modSp mod">
-        <pc:chgData name="Baráth, Július" userId="aebde9b9-dccc-4475-a9ac-c05e78323d7a" providerId="ADAL" clId="{9191FEAF-F4D4-A645-846E-876D0BEDC323}" dt="2024-04-10T07:13:56.626" v="17" actId="1076"/>
+        <pc:chgData name="Baráth, Július" userId="aebde9b9-dccc-4475-a9ac-c05e78323d7a" providerId="ADAL" clId="{4A0811C8-ED2F-505E-B787-C8270CED5046}" dt="2026-04-08T12:11:09.476" v="251" actId="20577"/>
         <pc:sldMkLst>
           <pc:docMk/>
           <pc:sldMk cId="0" sldId="374"/>
         </pc:sldMkLst>
-      </pc:sldChg>
-      <pc:sldChg chg="addSp delSp modSp new mod chgLayout">
-        <pc:chgData name="Baráth, Július" userId="aebde9b9-dccc-4475-a9ac-c05e78323d7a" providerId="ADAL" clId="{9191FEAF-F4D4-A645-846E-876D0BEDC323}" dt="2024-04-10T07:29:09.137" v="57" actId="1076"/>
-        <pc:sldMkLst>
-          <pc:docMk/>
-          <pc:sldMk cId="3466239317" sldId="375"/>
-        </pc:sldMkLst>
-      </pc:sldChg>
-      <pc:sldChg chg="modSp new del mod">
-        <pc:chgData name="Baráth, Július" userId="aebde9b9-dccc-4475-a9ac-c05e78323d7a" providerId="ADAL" clId="{9191FEAF-F4D4-A645-846E-876D0BEDC323}" dt="2024-04-10T07:21:08.448" v="38" actId="2696"/>
-        <pc:sldMkLst>
-          <pc:docMk/>
-          <pc:sldMk cId="98744663" sldId="376"/>
-        </pc:sldMkLst>
-      </pc:sldChg>
-      <pc:sldChg chg="addSp modSp new mod">
-        <pc:chgData name="Baráth, Július" userId="aebde9b9-dccc-4475-a9ac-c05e78323d7a" providerId="ADAL" clId="{9191FEAF-F4D4-A645-846E-876D0BEDC323}" dt="2024-04-10T07:43:27.142" v="79"/>
-        <pc:sldMkLst>
-          <pc:docMk/>
-          <pc:sldMk cId="3320790268" sldId="376"/>
-        </pc:sldMkLst>
-      </pc:sldChg>
-      <pc:sldChg chg="addSp modSp new mod">
-        <pc:chgData name="Baráth, Július" userId="aebde9b9-dccc-4475-a9ac-c05e78323d7a" providerId="ADAL" clId="{9191FEAF-F4D4-A645-846E-876D0BEDC323}" dt="2024-04-10T07:43:55.014" v="85" actId="1076"/>
-        <pc:sldMkLst>
-          <pc:docMk/>
-          <pc:sldMk cId="464445010" sldId="377"/>
-        </pc:sldMkLst>
-      </pc:sldChg>
-      <pc:sldChg chg="addSp modSp new mod">
-        <pc:chgData name="Baráth, Július" userId="aebde9b9-dccc-4475-a9ac-c05e78323d7a" providerId="ADAL" clId="{9191FEAF-F4D4-A645-846E-876D0BEDC323}" dt="2024-04-10T07:46:10.972" v="98" actId="164"/>
-        <pc:sldMkLst>
-          <pc:docMk/>
-          <pc:sldMk cId="1146992309" sldId="378"/>
-        </pc:sldMkLst>
-      </pc:sldChg>
-    </pc:docChg>
-  </pc:docChgLst>
-  <pc:docChgLst>
-    <pc:chgData name="Baráth, Július" userId="aebde9b9-dccc-4475-a9ac-c05e78323d7a" providerId="ADAL" clId="{9CE87323-0AF7-5449-97E2-5A02EF3AC1D4}"/>
-    <pc:docChg chg="modSld">
-      <pc:chgData name="Baráth, Július" userId="aebde9b9-dccc-4475-a9ac-c05e78323d7a" providerId="ADAL" clId="{9CE87323-0AF7-5449-97E2-5A02EF3AC1D4}" dt="2025-04-15T04:57:13.649" v="4" actId="20577"/>
-      <pc:docMkLst>
-        <pc:docMk/>
-      </pc:docMkLst>
-      <pc:sldChg chg="modSp mod">
-        <pc:chgData name="Baráth, Július" userId="aebde9b9-dccc-4475-a9ac-c05e78323d7a" providerId="ADAL" clId="{9CE87323-0AF7-5449-97E2-5A02EF3AC1D4}" dt="2025-04-15T04:50:11.886" v="0" actId="108"/>
-        <pc:sldMkLst>
-          <pc:docMk/>
-          <pc:sldMk cId="0" sldId="343"/>
-        </pc:sldMkLst>
         <pc:spChg chg="mod">
-          <ac:chgData name="Baráth, Július" userId="aebde9b9-dccc-4475-a9ac-c05e78323d7a" providerId="ADAL" clId="{9CE87323-0AF7-5449-97E2-5A02EF3AC1D4}" dt="2025-04-15T04:50:11.886" v="0" actId="108"/>
+          <ac:chgData name="Baráth, Július" userId="aebde9b9-dccc-4475-a9ac-c05e78323d7a" providerId="ADAL" clId="{4A0811C8-ED2F-505E-B787-C8270CED5046}" dt="2026-04-08T12:11:09.476" v="251" actId="20577"/>
           <ac:spMkLst>
             <pc:docMk/>
-            <pc:sldMk cId="0" sldId="343"/>
-            <ac:spMk id="13315" creationId="{0A471A76-63AA-6EA7-0D1A-0FDFC7E57021}"/>
+            <pc:sldMk cId="0" sldId="374"/>
+            <ac:spMk id="43010" creationId="{514859F2-D828-4DEF-9DA8-1E3179D19916}"/>
           </ac:spMkLst>
         </pc:spChg>
       </pc:sldChg>
-      <pc:sldChg chg="modSp mod">
-        <pc:chgData name="Baráth, Július" userId="aebde9b9-dccc-4475-a9ac-c05e78323d7a" providerId="ADAL" clId="{9CE87323-0AF7-5449-97E2-5A02EF3AC1D4}" dt="2025-04-15T04:57:13.649" v="4" actId="20577"/>
+      <pc:sldChg chg="modSp new mod ord">
+        <pc:chgData name="Baráth, Július" userId="aebde9b9-dccc-4475-a9ac-c05e78323d7a" providerId="ADAL" clId="{4A0811C8-ED2F-505E-B787-C8270CED5046}" dt="2026-04-08T12:00:52.087" v="205" actId="20577"/>
         <pc:sldMkLst>
           <pc:docMk/>
-          <pc:sldMk cId="0" sldId="345"/>
+          <pc:sldMk cId="2092384274" sldId="379"/>
         </pc:sldMkLst>
         <pc:spChg chg="mod">
-          <ac:chgData name="Baráth, Július" userId="aebde9b9-dccc-4475-a9ac-c05e78323d7a" providerId="ADAL" clId="{9CE87323-0AF7-5449-97E2-5A02EF3AC1D4}" dt="2025-04-15T04:57:13.649" v="4" actId="20577"/>
+          <ac:chgData name="Baráth, Július" userId="aebde9b9-dccc-4475-a9ac-c05e78323d7a" providerId="ADAL" clId="{4A0811C8-ED2F-505E-B787-C8270CED5046}" dt="2026-04-08T11:42:49.430" v="54" actId="20577"/>
           <ac:spMkLst>
             <pc:docMk/>
-            <pc:sldMk cId="0" sldId="345"/>
-            <ac:spMk id="18434" creationId="{39AB2FC3-095F-81F4-CD3D-538AB5310800}"/>
+            <pc:sldMk cId="2092384274" sldId="379"/>
+            <ac:spMk id="2" creationId="{94E4D1C3-CB83-D9F2-6F7E-9A6BA25C159A}"/>
+          </ac:spMkLst>
+        </pc:spChg>
+        <pc:spChg chg="mod">
+          <ac:chgData name="Baráth, Július" userId="aebde9b9-dccc-4475-a9ac-c05e78323d7a" providerId="ADAL" clId="{4A0811C8-ED2F-505E-B787-C8270CED5046}" dt="2026-04-08T11:59:09.472" v="172" actId="27636"/>
+          <ac:spMkLst>
+            <pc:docMk/>
+            <pc:sldMk cId="2092384274" sldId="379"/>
+            <ac:spMk id="3" creationId="{72F1F2BC-3F11-9FAB-1422-7BBD39C77C03}"/>
+          </ac:spMkLst>
+        </pc:spChg>
+        <pc:spChg chg="mod">
+          <ac:chgData name="Baráth, Július" userId="aebde9b9-dccc-4475-a9ac-c05e78323d7a" providerId="ADAL" clId="{4A0811C8-ED2F-505E-B787-C8270CED5046}" dt="2026-04-08T12:00:52.087" v="205" actId="20577"/>
+          <ac:spMkLst>
+            <pc:docMk/>
+            <pc:sldMk cId="2092384274" sldId="379"/>
+            <ac:spMk id="4" creationId="{2F6E88E2-87C3-25BE-7606-C73EDBD2CC72}"/>
           </ac:spMkLst>
         </pc:spChg>
       </pc:sldChg>
@@ -1925,6 +1895,186 @@
       </p:grpSpPr>
       <p:sp>
         <p:nvSpPr>
+          <p:cNvPr id="2" name="Zástupný objekt pre obrázok snímky 1"/>
+          <p:cNvSpPr>
+            <a:spLocks noGrp="1" noRot="1" noChangeAspect="1"/>
+          </p:cNvSpPr>
+          <p:nvPr>
+            <p:ph type="sldImg"/>
+          </p:nvPr>
+        </p:nvSpPr>
+        <p:spPr/>
+      </p:sp>
+      <p:sp>
+        <p:nvSpPr>
+          <p:cNvPr id="3" name="Zástupný objekt pre poznámky 2"/>
+          <p:cNvSpPr>
+            <a:spLocks noGrp="1"/>
+          </p:cNvSpPr>
+          <p:nvPr>
+            <p:ph type="body" idx="1"/>
+          </p:nvPr>
+        </p:nvSpPr>
+        <p:spPr/>
+        <p:txBody>
+          <a:bodyPr/>
+          <a:lstStyle/>
+          <a:p>
+            <a:endParaRPr lang="sk-SK" dirty="0"/>
+          </a:p>
+        </p:txBody>
+      </p:sp>
+      <p:sp>
+        <p:nvSpPr>
+          <p:cNvPr id="4" name="Zástupný objekt pre číslo snímky 3"/>
+          <p:cNvSpPr>
+            <a:spLocks noGrp="1"/>
+          </p:cNvSpPr>
+          <p:nvPr>
+            <p:ph type="sldNum" sz="quarter" idx="5"/>
+          </p:nvPr>
+        </p:nvSpPr>
+        <p:spPr/>
+        <p:txBody>
+          <a:bodyPr/>
+          <a:lstStyle/>
+          <a:p>
+            <a:pPr>
+              <a:defRPr/>
+            </a:pPr>
+            <a:fld id="{84362C00-7AF2-0743-B57A-060F524756FF}" type="slidenum">
+              <a:rPr lang="en-US" altLang="sk-SK" smtClean="0"/>
+              <a:pPr>
+                <a:defRPr/>
+              </a:pPr>
+              <a:t>12</a:t>
+            </a:fld>
+            <a:endParaRPr lang="en-US" altLang="sk-SK"/>
+          </a:p>
+        </p:txBody>
+      </p:sp>
+    </p:spTree>
+    <p:extLst>
+      <p:ext uri="{BB962C8B-B14F-4D97-AF65-F5344CB8AC3E}">
+        <p14:creationId xmlns:p14="http://schemas.microsoft.com/office/powerpoint/2010/main" val="2913761491"/>
+      </p:ext>
+    </p:extLst>
+  </p:cSld>
+  <p:clrMapOvr>
+    <a:masterClrMapping/>
+  </p:clrMapOvr>
+</p:notes>
+</file>
+
+<file path=ppt/notesSlides/notesSlide5.xml><?xml version="1.0" encoding="utf-8"?>
+<p:notes xmlns:a="http://schemas.openxmlformats.org/drawingml/2006/main" xmlns:r="http://schemas.openxmlformats.org/officeDocument/2006/relationships" xmlns:p="http://schemas.openxmlformats.org/presentationml/2006/main">
+  <p:cSld>
+    <p:spTree>
+      <p:nvGrpSpPr>
+        <p:cNvPr id="1" name=""/>
+        <p:cNvGrpSpPr/>
+        <p:nvPr/>
+      </p:nvGrpSpPr>
+      <p:grpSpPr>
+        <a:xfrm>
+          <a:off x="0" y="0"/>
+          <a:ext cx="0" cy="0"/>
+          <a:chOff x="0" y="0"/>
+          <a:chExt cx="0" cy="0"/>
+        </a:xfrm>
+      </p:grpSpPr>
+      <p:sp>
+        <p:nvSpPr>
+          <p:cNvPr id="2" name="Zástupný objekt pre obrázok snímky 1"/>
+          <p:cNvSpPr>
+            <a:spLocks noGrp="1" noRot="1" noChangeAspect="1"/>
+          </p:cNvSpPr>
+          <p:nvPr>
+            <p:ph type="sldImg"/>
+          </p:nvPr>
+        </p:nvSpPr>
+        <p:spPr/>
+      </p:sp>
+      <p:sp>
+        <p:nvSpPr>
+          <p:cNvPr id="3" name="Zástupný objekt pre poznámky 2"/>
+          <p:cNvSpPr>
+            <a:spLocks noGrp="1"/>
+          </p:cNvSpPr>
+          <p:nvPr>
+            <p:ph type="body" idx="1"/>
+          </p:nvPr>
+        </p:nvSpPr>
+        <p:spPr/>
+        <p:txBody>
+          <a:bodyPr/>
+          <a:lstStyle/>
+          <a:p>
+            <a:endParaRPr lang="sk-SK" dirty="0"/>
+          </a:p>
+        </p:txBody>
+      </p:sp>
+      <p:sp>
+        <p:nvSpPr>
+          <p:cNvPr id="4" name="Zástupný objekt pre číslo snímky 3"/>
+          <p:cNvSpPr>
+            <a:spLocks noGrp="1"/>
+          </p:cNvSpPr>
+          <p:nvPr>
+            <p:ph type="sldNum" sz="quarter" idx="5"/>
+          </p:nvPr>
+        </p:nvSpPr>
+        <p:spPr/>
+        <p:txBody>
+          <a:bodyPr/>
+          <a:lstStyle/>
+          <a:p>
+            <a:pPr>
+              <a:defRPr/>
+            </a:pPr>
+            <a:fld id="{84362C00-7AF2-0743-B57A-060F524756FF}" type="slidenum">
+              <a:rPr lang="en-US" altLang="sk-SK" smtClean="0"/>
+              <a:pPr>
+                <a:defRPr/>
+              </a:pPr>
+              <a:t>19</a:t>
+            </a:fld>
+            <a:endParaRPr lang="en-US" altLang="sk-SK"/>
+          </a:p>
+        </p:txBody>
+      </p:sp>
+    </p:spTree>
+    <p:extLst>
+      <p:ext uri="{BB962C8B-B14F-4D97-AF65-F5344CB8AC3E}">
+        <p14:creationId xmlns:p14="http://schemas.microsoft.com/office/powerpoint/2010/main" val="9449597"/>
+      </p:ext>
+    </p:extLst>
+  </p:cSld>
+  <p:clrMapOvr>
+    <a:masterClrMapping/>
+  </p:clrMapOvr>
+</p:notes>
+</file>
+
+<file path=ppt/notesSlides/notesSlide6.xml><?xml version="1.0" encoding="utf-8"?>
+<p:notes xmlns:a="http://schemas.openxmlformats.org/drawingml/2006/main" xmlns:r="http://schemas.openxmlformats.org/officeDocument/2006/relationships" xmlns:p="http://schemas.openxmlformats.org/presentationml/2006/main">
+  <p:cSld>
+    <p:spTree>
+      <p:nvGrpSpPr>
+        <p:cNvPr id="1" name=""/>
+        <p:cNvGrpSpPr/>
+        <p:nvPr/>
+      </p:nvGrpSpPr>
+      <p:grpSpPr>
+        <a:xfrm>
+          <a:off x="0" y="0"/>
+          <a:ext cx="0" cy="0"/>
+          <a:chOff x="0" y="0"/>
+          <a:chExt cx="0" cy="0"/>
+        </a:xfrm>
+      </p:grpSpPr>
+      <p:sp>
+        <p:nvSpPr>
           <p:cNvPr id="54273" name="Rectangle 7">
             <a:extLst>
               <a:ext uri="{FF2B5EF4-FFF2-40B4-BE49-F238E27FC236}">
@@ -2077,7 +2227,7 @@
                 <a:latin typeface="Helvetica" pitchFamily="2" charset="0"/>
               </a:rPr>
               <a:pPr/>
-              <a:t>50</a:t>
+              <a:t>51</a:t>
             </a:fld>
             <a:endParaRPr lang="en-US" altLang="sk-SK">
               <a:latin typeface="Helvetica" pitchFamily="2" charset="0"/>
@@ -8231,10 +8381,10 @@
       </p:grpSpPr>
       <p:sp>
         <p:nvSpPr>
-          <p:cNvPr id="24577" name="Title 1">
+          <p:cNvPr id="25601" name="Title 1">
             <a:extLst>
               <a:ext uri="{FF2B5EF4-FFF2-40B4-BE49-F238E27FC236}">
-                <a16:creationId xmlns:a16="http://schemas.microsoft.com/office/drawing/2014/main" id="{A87FF3B3-BB8C-0961-E38A-9ECEE8F66166}"/>
+                <a16:creationId xmlns:a16="http://schemas.microsoft.com/office/drawing/2014/main" id="{13FD7147-FD8A-D73A-EC49-36473585A431}"/>
               </a:ext>
             </a:extLst>
           </p:cNvPr>
@@ -8251,20 +8401,20 @@
           <a:lstStyle/>
           <a:p>
             <a:r>
-              <a:rPr lang="en-US" altLang="sk-SK">
-                <a:ea typeface="ＭＳ Ｐゴシック" panose="020B0600070205080204" pitchFamily="34" charset="-128"/>
-              </a:rPr>
-              <a:t>Nested Page Tables</a:t>
+              <a:rPr lang="en-US" altLang="sk-SK" sz="2800">
+                <a:ea typeface="ＭＳ Ｐゴシック" panose="020B0600070205080204" pitchFamily="34" charset="-128"/>
+              </a:rPr>
+              <a:t>Building Blocks – Hardware Assistance</a:t>
             </a:r>
           </a:p>
         </p:txBody>
       </p:sp>
       <p:sp>
         <p:nvSpPr>
-          <p:cNvPr id="24578" name="Content Placeholder 2">
+          <p:cNvPr id="25602" name="Content Placeholder 2">
             <a:extLst>
               <a:ext uri="{FF2B5EF4-FFF2-40B4-BE49-F238E27FC236}">
-                <a16:creationId xmlns:a16="http://schemas.microsoft.com/office/drawing/2014/main" id="{B4400930-85F5-5A0D-D973-27F9B6852FD2}"/>
+                <a16:creationId xmlns:a16="http://schemas.microsoft.com/office/drawing/2014/main" id="{C932231D-95C7-3623-5E09-EE7804FC2405}"/>
               </a:ext>
             </a:extLst>
           </p:cNvPr>
@@ -8284,7 +8434,7 @@
               <a:rPr lang="en-US" altLang="sk-SK" dirty="0">
                 <a:ea typeface="ＭＳ Ｐゴシック" panose="020B0600070205080204" pitchFamily="34" charset="-128"/>
               </a:rPr>
-              <a:t>Memory management another general challenge to VMM implementations</a:t>
+              <a:t>All virtualization needs some HW support</a:t>
             </a:r>
           </a:p>
           <a:p>
@@ -8292,7 +8442,7 @@
               <a:rPr lang="en-US" altLang="sk-SK" dirty="0">
                 <a:ea typeface="ＭＳ Ｐゴシック" panose="020B0600070205080204" pitchFamily="34" charset="-128"/>
               </a:rPr>
-              <a:t>How can VMM keep page-table state for both guests believing they control the page tables and VMM that does control the tables?</a:t>
+              <a:t>More support -&gt; more feature rich, stable, better performance of guests</a:t>
             </a:r>
           </a:p>
           <a:p>
@@ -8300,7 +8450,7 @@
               <a:rPr lang="en-US" altLang="sk-SK" dirty="0">
                 <a:ea typeface="ＭＳ Ｐゴシック" panose="020B0600070205080204" pitchFamily="34" charset="-128"/>
               </a:rPr>
-              <a:t>Common method (for trap-and-emulate and binary translation) is </a:t>
+              <a:t>Intel added new </a:t>
             </a:r>
             <a:r>
               <a:rPr lang="en-US" altLang="sk-SK" b="1" dirty="0">
@@ -8309,13 +8459,13 @@
                 </a:solidFill>
                 <a:ea typeface="ＭＳ Ｐゴシック" panose="020B0600070205080204" pitchFamily="34" charset="-128"/>
               </a:rPr>
-              <a:t>nested page</a:t>
+              <a:t>VT-x</a:t>
             </a:r>
             <a:r>
               <a:rPr lang="en-US" altLang="sk-SK" dirty="0">
                 <a:ea typeface="ＭＳ Ｐゴシック" panose="020B0600070205080204" pitchFamily="34" charset="-128"/>
               </a:rPr>
-              <a:t> </a:t>
+              <a:t> instructions in 2005 and AMD the </a:t>
             </a:r>
             <a:r>
               <a:rPr lang="en-US" altLang="sk-SK" b="1" dirty="0">
@@ -8324,125 +8474,139 @@
                 </a:solidFill>
                 <a:ea typeface="ＭＳ Ｐゴシック" panose="020B0600070205080204" pitchFamily="34" charset="-128"/>
               </a:rPr>
-              <a:t>tables</a:t>
+              <a:t>AMD-V </a:t>
             </a:r>
             <a:r>
               <a:rPr lang="en-US" altLang="sk-SK" dirty="0">
                 <a:ea typeface="ＭＳ Ｐゴシック" panose="020B0600070205080204" pitchFamily="34" charset="-128"/>
               </a:rPr>
-              <a:t> (</a:t>
+              <a:t>instructions in 2006</a:t>
+            </a:r>
+          </a:p>
+          <a:p>
+            <a:pPr lvl="1"/>
+            <a:r>
+              <a:rPr lang="en-US" altLang="sk-SK" dirty="0">
+                <a:ea typeface="ＭＳ Ｐゴシック" panose="020B0600070205080204" pitchFamily="34" charset="-128"/>
+              </a:rPr>
+              <a:t>CPUs with these instructions </a:t>
             </a:r>
             <a:r>
               <a:rPr lang="en-US" altLang="sk-SK" b="1" dirty="0">
-                <a:solidFill>
-                  <a:srgbClr val="3366FF"/>
-                </a:solidFill>
-                <a:ea typeface="ＭＳ Ｐゴシック" panose="020B0600070205080204" pitchFamily="34" charset="-128"/>
-              </a:rPr>
-              <a:t>NPTs</a:t>
-            </a:r>
+                <a:ea typeface="ＭＳ Ｐゴシック" panose="020B0600070205080204" pitchFamily="34" charset="-128"/>
+              </a:rPr>
+              <a:t>remove need for binary translation</a:t>
+            </a:r>
+          </a:p>
+          <a:p>
+            <a:pPr lvl="1"/>
             <a:r>
               <a:rPr lang="en-US" altLang="sk-SK" dirty="0">
                 <a:ea typeface="ＭＳ Ｐゴシック" panose="020B0600070205080204" pitchFamily="34" charset="-128"/>
               </a:rPr>
-              <a:t>) </a:t>
-            </a:r>
-          </a:p>
-          <a:p>
-            <a:pPr lvl="1"/>
+              <a:t>Generally define more CPU modes – </a:t>
+            </a:r>
+            <a:r>
+              <a:rPr lang="en-US" altLang="en-US" dirty="0">
+                <a:ea typeface="ＭＳ Ｐゴシック" panose="020B0600070205080204" pitchFamily="34" charset="-128"/>
+              </a:rPr>
+              <a:t>“</a:t>
+            </a:r>
             <a:r>
               <a:rPr lang="en-US" altLang="sk-SK" dirty="0">
                 <a:ea typeface="ＭＳ Ｐゴシック" panose="020B0600070205080204" pitchFamily="34" charset="-128"/>
               </a:rPr>
-              <a:t>Each guest maintains page tables to translate virtual to physical addresses</a:t>
-            </a:r>
-          </a:p>
-          <a:p>
-            <a:pPr lvl="1"/>
+              <a:t>guest</a:t>
+            </a:r>
+            <a:r>
+              <a:rPr lang="en-US" altLang="en-US" dirty="0">
+                <a:ea typeface="ＭＳ Ｐゴシック" panose="020B0600070205080204" pitchFamily="34" charset="-128"/>
+              </a:rPr>
+              <a:t>”</a:t>
+            </a:r>
             <a:r>
               <a:rPr lang="en-US" altLang="sk-SK" dirty="0">
                 <a:ea typeface="ＭＳ Ｐゴシック" panose="020B0600070205080204" pitchFamily="34" charset="-128"/>
               </a:rPr>
-              <a:t>VMM maintains per guest NPTs to represent guest</a:t>
+              <a:t> and </a:t>
             </a:r>
             <a:r>
               <a:rPr lang="en-US" altLang="en-US" dirty="0">
                 <a:ea typeface="ＭＳ Ｐゴシック" panose="020B0600070205080204" pitchFamily="34" charset="-128"/>
               </a:rPr>
-              <a:t>’</a:t>
+              <a:t>“</a:t>
             </a:r>
             <a:r>
               <a:rPr lang="en-US" altLang="sk-SK" dirty="0">
                 <a:ea typeface="ＭＳ Ｐゴシック" panose="020B0600070205080204" pitchFamily="34" charset="-128"/>
               </a:rPr>
-              <a:t>s page-table state</a:t>
-            </a:r>
-          </a:p>
-          <a:p>
-            <a:pPr lvl="2"/>
-            <a:r>
-              <a:rPr lang="en-US" altLang="sk-SK" dirty="0">
-                <a:ea typeface="ＭＳ Ｐゴシック" panose="020B0600070205080204" pitchFamily="34" charset="-128"/>
-              </a:rPr>
-              <a:t>Just as VCPU stores guest CPU state</a:t>
-            </a:r>
-          </a:p>
-          <a:p>
-            <a:pPr lvl="1"/>
-            <a:r>
-              <a:rPr lang="en-US" altLang="sk-SK" dirty="0">
-                <a:ea typeface="ＭＳ Ｐゴシック" panose="020B0600070205080204" pitchFamily="34" charset="-128"/>
-              </a:rPr>
-              <a:t>When guest on CPU -&gt; VMM makes that guest</a:t>
+              <a:t>host</a:t>
             </a:r>
             <a:r>
               <a:rPr lang="en-US" altLang="en-US" dirty="0">
                 <a:ea typeface="ＭＳ Ｐゴシック" panose="020B0600070205080204" pitchFamily="34" charset="-128"/>
               </a:rPr>
-              <a:t>’</a:t>
-            </a:r>
-            <a:r>
-              <a:rPr lang="en-US" altLang="sk-SK" dirty="0">
-                <a:ea typeface="ＭＳ Ｐゴシック" panose="020B0600070205080204" pitchFamily="34" charset="-128"/>
-              </a:rPr>
-              <a:t>s NPTs the active system page tables</a:t>
-            </a:r>
-          </a:p>
-          <a:p>
-            <a:pPr lvl="1"/>
-            <a:r>
-              <a:rPr lang="en-US" altLang="sk-SK" dirty="0">
-                <a:ea typeface="ＭＳ Ｐゴシック" panose="020B0600070205080204" pitchFamily="34" charset="-128"/>
-              </a:rPr>
-              <a:t>Guest tries to change page table -&gt; VMM makes equivalent change to NPTs and its own page tables</a:t>
-            </a:r>
-          </a:p>
-          <a:p>
-            <a:pPr lvl="1"/>
-            <a:r>
-              <a:rPr lang="en-US" altLang="sk-SK" dirty="0">
-                <a:ea typeface="ＭＳ Ｐゴシック" panose="020B0600070205080204" pitchFamily="34" charset="-128"/>
-              </a:rPr>
-              <a:t>Can </a:t>
-            </a:r>
-            <a:r>
-              <a:rPr lang="en-US" altLang="sk-SK" u="sng" dirty="0">
-                <a:ea typeface="ＭＳ Ｐゴシック" panose="020B0600070205080204" pitchFamily="34" charset="-128"/>
-              </a:rPr>
-              <a:t>cause many more TLB misses </a:t>
-            </a:r>
-            <a:r>
-              <a:rPr lang="en-US" altLang="sk-SK" dirty="0">
-                <a:ea typeface="ＭＳ Ｐゴシック" panose="020B0600070205080204" pitchFamily="34" charset="-128"/>
-              </a:rPr>
-              <a:t>-&gt; much slower performance</a:t>
-            </a:r>
-          </a:p>
-          <a:p>
-            <a:pPr lvl="1"/>
+              <a:t>”</a:t>
+            </a:r>
             <a:endParaRPr lang="en-US" altLang="sk-SK" dirty="0">
               <a:ea typeface="ＭＳ Ｐゴシック" panose="020B0600070205080204" pitchFamily="34" charset="-128"/>
             </a:endParaRPr>
+          </a:p>
+          <a:p>
+            <a:pPr lvl="1"/>
+            <a:r>
+              <a:rPr lang="en-US" altLang="sk-SK" dirty="0">
+                <a:ea typeface="ＭＳ Ｐゴシック" panose="020B0600070205080204" pitchFamily="34" charset="-128"/>
+              </a:rPr>
+              <a:t>VMM can enable host mode, define characteristics of each guest VM, switch to guest mode and guest(s) on CPU(s)</a:t>
+            </a:r>
+          </a:p>
+          <a:p>
+            <a:pPr lvl="1"/>
+            <a:r>
+              <a:rPr lang="en-US" altLang="sk-SK" dirty="0">
+                <a:ea typeface="ＭＳ Ｐゴシック" panose="020B0600070205080204" pitchFamily="34" charset="-128"/>
+              </a:rPr>
+              <a:t>In guest mode, guest OS thinks it is running natively, sees devices (as defined by VMM for that guest) </a:t>
+            </a:r>
+          </a:p>
+          <a:p>
+            <a:pPr lvl="2"/>
+            <a:r>
+              <a:rPr lang="en-US" altLang="sk-SK" dirty="0">
+                <a:ea typeface="ＭＳ Ｐゴシック" panose="020B0600070205080204" pitchFamily="34" charset="-128"/>
+              </a:rPr>
+              <a:t>Access to virtualized device, </a:t>
+            </a:r>
+            <a:r>
+              <a:rPr lang="en-US" altLang="sk-SK" dirty="0" err="1">
+                <a:ea typeface="ＭＳ Ｐゴシック" panose="020B0600070205080204" pitchFamily="34" charset="-128"/>
+              </a:rPr>
+              <a:t>priv</a:t>
+            </a:r>
+            <a:r>
+              <a:rPr lang="en-US" altLang="sk-SK" dirty="0">
+                <a:ea typeface="ＭＳ Ｐゴシック" panose="020B0600070205080204" pitchFamily="34" charset="-128"/>
+              </a:rPr>
+              <a:t> instructions cause trap to VMM</a:t>
+            </a:r>
+          </a:p>
+          <a:p>
+            <a:pPr lvl="2"/>
+            <a:r>
+              <a:rPr lang="en-US" altLang="sk-SK" dirty="0">
+                <a:ea typeface="ＭＳ Ｐゴシック" panose="020B0600070205080204" pitchFamily="34" charset="-128"/>
+              </a:rPr>
+              <a:t>CPU maintains VCPU, context switches it as needed</a:t>
+            </a:r>
+          </a:p>
+          <a:p>
+            <a:r>
+              <a:rPr lang="en-US" altLang="sk-SK" u="sng" dirty="0">
+                <a:ea typeface="ＭＳ Ｐゴシック" panose="020B0600070205080204" pitchFamily="34" charset="-128"/>
+              </a:rPr>
+              <a:t>HW support for Nested Page Tables, DMA, interrupts as well over time</a:t>
+            </a:r>
           </a:p>
           <a:p>
             <a:pPr lvl="1"/>
@@ -8496,15 +8660,15 @@
       </p:grpSpPr>
       <p:sp>
         <p:nvSpPr>
-          <p:cNvPr id="25601" name="Title 1">
+          <p:cNvPr id="2" name="Nadpis 1">
             <a:extLst>
               <a:ext uri="{FF2B5EF4-FFF2-40B4-BE49-F238E27FC236}">
-                <a16:creationId xmlns:a16="http://schemas.microsoft.com/office/drawing/2014/main" id="{13FD7147-FD8A-D73A-EC49-36473585A431}"/>
+                <a16:creationId xmlns:a16="http://schemas.microsoft.com/office/drawing/2014/main" id="{94E4D1C3-CB83-D9F2-6F7E-9A6BA25C159A}"/>
               </a:ext>
             </a:extLst>
           </p:cNvPr>
           <p:cNvSpPr>
-            <a:spLocks noGrp="1" noChangeArrowheads="1"/>
+            <a:spLocks noGrp="1"/>
           </p:cNvSpPr>
           <p:nvPr>
             <p:ph type="title"/>
@@ -8516,239 +8680,584 @@
           <a:lstStyle/>
           <a:p>
             <a:r>
-              <a:rPr lang="en-US" altLang="sk-SK" sz="2800">
-                <a:ea typeface="ＭＳ Ｐゴシック" panose="020B0600070205080204" pitchFamily="34" charset="-128"/>
-              </a:rPr>
-              <a:t>Building Blocks – Hardware Assistance</a:t>
-            </a:r>
+              <a:rPr lang="sk-SK" dirty="0"/>
+              <a:t>Nové CPU módy – </a:t>
+            </a:r>
+            <a:r>
+              <a:rPr lang="sk-SK" dirty="0" err="1"/>
+              <a:t>root</a:t>
+            </a:r>
+            <a:r>
+              <a:rPr lang="sk-SK" dirty="0"/>
+              <a:t> a </a:t>
+            </a:r>
+            <a:r>
+              <a:rPr lang="sk-SK" dirty="0" err="1"/>
+              <a:t>non-root</a:t>
+            </a:r>
+            <a:r>
+              <a:rPr lang="sk-SK" dirty="0"/>
+              <a:t> </a:t>
+            </a:r>
+            <a:r>
+              <a:rPr lang="sk-SK" dirty="0" err="1"/>
+              <a:t>mode</a:t>
+            </a:r>
+            <a:endParaRPr lang="sk-SK" dirty="0"/>
           </a:p>
         </p:txBody>
       </p:sp>
       <p:sp>
         <p:nvSpPr>
-          <p:cNvPr id="25602" name="Content Placeholder 2">
+          <p:cNvPr id="3" name="Zástupný objekt pre obsah 2">
             <a:extLst>
               <a:ext uri="{FF2B5EF4-FFF2-40B4-BE49-F238E27FC236}">
-                <a16:creationId xmlns:a16="http://schemas.microsoft.com/office/drawing/2014/main" id="{C932231D-95C7-3623-5E09-EE7804FC2405}"/>
+                <a16:creationId xmlns:a16="http://schemas.microsoft.com/office/drawing/2014/main" id="{72F1F2BC-3F11-9FAB-1422-7BBD39C77C03}"/>
               </a:ext>
             </a:extLst>
           </p:cNvPr>
           <p:cNvSpPr>
-            <a:spLocks noGrp="1" noChangeArrowheads="1"/>
+            <a:spLocks noGrp="1"/>
           </p:cNvSpPr>
           <p:nvPr>
-            <p:ph idx="1"/>
+            <p:ph sz="half" idx="1"/>
           </p:nvPr>
         </p:nvSpPr>
         <p:spPr/>
         <p:txBody>
-          <a:bodyPr/>
+          <a:bodyPr>
+            <a:normAutofit/>
+          </a:bodyPr>
           <a:lstStyle/>
           <a:p>
-            <a:r>
-              <a:rPr lang="en-US" altLang="sk-SK" dirty="0">
-                <a:ea typeface="ＭＳ Ｐゴシック" panose="020B0600070205080204" pitchFamily="34" charset="-128"/>
-              </a:rPr>
-              <a:t>All virtualization needs some HW support</a:t>
-            </a:r>
-          </a:p>
-          <a:p>
-            <a:r>
-              <a:rPr lang="en-US" altLang="sk-SK" dirty="0">
-                <a:ea typeface="ＭＳ Ｐゴシック" panose="020B0600070205080204" pitchFamily="34" charset="-128"/>
-              </a:rPr>
-              <a:t>More support -&gt; more feature rich, stable, better performance of guests</a:t>
-            </a:r>
-          </a:p>
-          <a:p>
-            <a:r>
-              <a:rPr lang="en-US" altLang="sk-SK" dirty="0">
-                <a:ea typeface="ＭＳ Ｐゴシック" panose="020B0600070205080204" pitchFamily="34" charset="-128"/>
-              </a:rPr>
-              <a:t>Intel added new </a:t>
-            </a:r>
-            <a:r>
-              <a:rPr lang="en-US" altLang="sk-SK" b="1" dirty="0">
-                <a:solidFill>
-                  <a:srgbClr val="3366FF"/>
-                </a:solidFill>
-                <a:ea typeface="ＭＳ Ｐゴシック" panose="020B0600070205080204" pitchFamily="34" charset="-128"/>
-              </a:rPr>
-              <a:t>VT-x</a:t>
-            </a:r>
-            <a:r>
-              <a:rPr lang="en-US" altLang="sk-SK" dirty="0">
-                <a:ea typeface="ＭＳ Ｐゴシック" panose="020B0600070205080204" pitchFamily="34" charset="-128"/>
-              </a:rPr>
-              <a:t> instructions in 2005 and AMD the </a:t>
-            </a:r>
-            <a:r>
-              <a:rPr lang="en-US" altLang="sk-SK" b="1" dirty="0">
-                <a:solidFill>
-                  <a:srgbClr val="3366FF"/>
-                </a:solidFill>
-                <a:ea typeface="ＭＳ Ｐゴシック" panose="020B0600070205080204" pitchFamily="34" charset="-128"/>
-              </a:rPr>
-              <a:t>AMD-V </a:t>
-            </a:r>
-            <a:r>
-              <a:rPr lang="en-US" altLang="sk-SK" dirty="0">
-                <a:ea typeface="ＭＳ Ｐゴシック" panose="020B0600070205080204" pitchFamily="34" charset="-128"/>
-              </a:rPr>
-              <a:t>instructions in 2006</a:t>
+            <a:pPr marL="0" indent="0">
+              <a:buNone/>
+            </a:pPr>
+            <a:r>
+              <a:rPr lang="sk-SK" sz="1200" b="1" dirty="0"/>
+              <a:t>Intel VMX (VT‑x)</a:t>
+            </a:r>
+          </a:p>
+          <a:p>
+            <a:r>
+              <a:rPr lang="sk-SK" sz="1200" dirty="0"/>
+              <a:t>Dva režimy</a:t>
             </a:r>
           </a:p>
           <a:p>
             <a:pPr lvl="1"/>
             <a:r>
-              <a:rPr lang="en-US" altLang="sk-SK" dirty="0">
-                <a:ea typeface="ＭＳ Ｐゴシック" panose="020B0600070205080204" pitchFamily="34" charset="-128"/>
-              </a:rPr>
-              <a:t>CPUs with these instructions </a:t>
-            </a:r>
-            <a:r>
-              <a:rPr lang="en-US" altLang="sk-SK" b="1" dirty="0">
-                <a:ea typeface="ＭＳ Ｐゴシック" panose="020B0600070205080204" pitchFamily="34" charset="-128"/>
-              </a:rPr>
-              <a:t>remove need for binary translation</a:t>
+              <a:rPr lang="sk-SK" sz="1200" dirty="0"/>
+              <a:t>VMX </a:t>
+            </a:r>
+            <a:r>
+              <a:rPr lang="sk-SK" sz="1200" dirty="0" err="1"/>
+              <a:t>Root</a:t>
+            </a:r>
+            <a:r>
+              <a:rPr lang="sk-SK" sz="1200" dirty="0"/>
+              <a:t> </a:t>
+            </a:r>
+            <a:r>
+              <a:rPr lang="sk-SK" sz="1200" dirty="0" err="1"/>
+              <a:t>Operation</a:t>
+            </a:r>
+            <a:r>
+              <a:rPr lang="sk-SK" sz="1200" dirty="0"/>
+              <a:t> (</a:t>
+            </a:r>
+            <a:r>
+              <a:rPr lang="sk-SK" sz="1200" dirty="0" err="1"/>
+              <a:t>hypervízor</a:t>
+            </a:r>
+            <a:r>
+              <a:rPr lang="sk-SK" sz="1200" dirty="0"/>
+              <a:t>)</a:t>
             </a:r>
           </a:p>
           <a:p>
             <a:pPr lvl="1"/>
             <a:r>
-              <a:rPr lang="en-US" altLang="sk-SK" dirty="0">
-                <a:ea typeface="ＭＳ Ｐゴシック" panose="020B0600070205080204" pitchFamily="34" charset="-128"/>
-              </a:rPr>
-              <a:t>Generally define more CPU modes – </a:t>
-            </a:r>
-            <a:r>
-              <a:rPr lang="en-US" altLang="en-US" dirty="0">
-                <a:ea typeface="ＭＳ Ｐゴシック" panose="020B0600070205080204" pitchFamily="34" charset="-128"/>
-              </a:rPr>
+              <a:rPr lang="sk-SK" sz="1200" dirty="0"/>
+              <a:t>VMX </a:t>
+            </a:r>
+            <a:r>
+              <a:rPr lang="sk-SK" sz="1200" dirty="0" err="1"/>
+              <a:t>Non‑Root</a:t>
+            </a:r>
+            <a:r>
+              <a:rPr lang="sk-SK" sz="1200" dirty="0"/>
+              <a:t> </a:t>
+            </a:r>
+            <a:r>
+              <a:rPr lang="sk-SK" sz="1200" dirty="0" err="1"/>
+              <a:t>Operation</a:t>
+            </a:r>
+            <a:r>
+              <a:rPr lang="sk-SK" sz="1200" dirty="0"/>
+              <a:t> (virtuálny OS)</a:t>
+            </a:r>
+          </a:p>
+          <a:p>
+            <a:r>
+              <a:rPr lang="sk-SK" sz="1200" dirty="0"/>
+              <a:t>Kľúčové mechanizmy</a:t>
+            </a:r>
+          </a:p>
+          <a:p>
+            <a:r>
+              <a:rPr lang="sk-SK" sz="1200" dirty="0"/>
+              <a:t>1. VMCS (</a:t>
+            </a:r>
+            <a:r>
+              <a:rPr lang="sk-SK" sz="1200" dirty="0" err="1"/>
+              <a:t>Virtual</a:t>
+            </a:r>
+            <a:r>
+              <a:rPr lang="sk-SK" sz="1200" dirty="0"/>
+              <a:t> </a:t>
+            </a:r>
+            <a:r>
+              <a:rPr lang="sk-SK" sz="1200" dirty="0" err="1"/>
+              <a:t>Machine</a:t>
+            </a:r>
+            <a:r>
+              <a:rPr lang="sk-SK" sz="1200" dirty="0"/>
+              <a:t> </a:t>
+            </a:r>
+            <a:r>
+              <a:rPr lang="sk-SK" sz="1200" dirty="0" err="1"/>
+              <a:t>Control</a:t>
+            </a:r>
+            <a:r>
+              <a:rPr lang="sk-SK" sz="1200" dirty="0"/>
+              <a:t> </a:t>
+            </a:r>
+            <a:r>
+              <a:rPr lang="sk-SK" sz="1200" dirty="0" err="1"/>
+              <a:t>Structure</a:t>
+            </a:r>
+            <a:r>
+              <a:rPr lang="sk-SK" sz="1200" dirty="0"/>
+              <a:t>)</a:t>
+            </a:r>
+          </a:p>
+          <a:p>
+            <a:pPr marL="0" indent="0">
+              <a:buNone/>
+            </a:pPr>
+            <a:r>
+              <a:rPr lang="sk-SK" sz="1200" dirty="0"/>
+              <a:t>Špeciálna dátová štruktúra v pamäti obsahujúca:</a:t>
+            </a:r>
+          </a:p>
+          <a:p>
+            <a:pPr lvl="1"/>
+            <a:r>
+              <a:rPr lang="sk-SK" sz="1200" dirty="0"/>
+              <a:t>stav CPU hosťa</a:t>
+            </a:r>
+          </a:p>
+          <a:p>
+            <a:pPr lvl="1"/>
+            <a:r>
+              <a:rPr lang="sk-SK" sz="1200" dirty="0"/>
+              <a:t>pravidlá, čo má vyvolať „VM‑</a:t>
+            </a:r>
+            <a:r>
+              <a:rPr lang="sk-SK" sz="1200" dirty="0" err="1"/>
+              <a:t>exit</a:t>
+            </a:r>
+            <a:r>
+              <a:rPr lang="sk-SK" sz="1200" dirty="0"/>
               <a:t>“</a:t>
             </a:r>
-            <a:r>
-              <a:rPr lang="en-US" altLang="sk-SK" dirty="0">
-                <a:ea typeface="ＭＳ Ｐゴシック" panose="020B0600070205080204" pitchFamily="34" charset="-128"/>
-              </a:rPr>
-              <a:t>guest</a:t>
-            </a:r>
-            <a:r>
-              <a:rPr lang="en-US" altLang="en-US" dirty="0">
-                <a:ea typeface="ＭＳ Ｐゴシック" panose="020B0600070205080204" pitchFamily="34" charset="-128"/>
-              </a:rPr>
-              <a:t>”</a:t>
-            </a:r>
-            <a:r>
-              <a:rPr lang="en-US" altLang="sk-SK" dirty="0">
-                <a:ea typeface="ＭＳ Ｐゴシック" panose="020B0600070205080204" pitchFamily="34" charset="-128"/>
-              </a:rPr>
-              <a:t> and </a:t>
-            </a:r>
-            <a:r>
-              <a:rPr lang="en-US" altLang="en-US" dirty="0">
-                <a:ea typeface="ＭＳ Ｐゴシック" panose="020B0600070205080204" pitchFamily="34" charset="-128"/>
-              </a:rPr>
+          </a:p>
+          <a:p>
+            <a:pPr lvl="1"/>
+            <a:r>
+              <a:rPr lang="sk-SK" sz="1200" dirty="0"/>
+              <a:t>stav hostiteľa</a:t>
+            </a:r>
+          </a:p>
+          <a:p>
+            <a:endParaRPr lang="sk-SK" sz="1200" dirty="0"/>
+          </a:p>
+          <a:p>
+            <a:r>
+              <a:rPr lang="sk-SK" sz="1200" dirty="0"/>
+              <a:t>2. VM‑</a:t>
+            </a:r>
+            <a:r>
+              <a:rPr lang="sk-SK" sz="1200" dirty="0" err="1"/>
+              <a:t>entry</a:t>
+            </a:r>
+            <a:r>
+              <a:rPr lang="sk-SK" sz="1200" dirty="0"/>
+              <a:t> / VM‑</a:t>
+            </a:r>
+            <a:r>
+              <a:rPr lang="sk-SK" sz="1200" dirty="0" err="1"/>
+              <a:t>exit</a:t>
+            </a:r>
+            <a:endParaRPr lang="sk-SK" sz="1200" dirty="0"/>
+          </a:p>
+          <a:p>
+            <a:pPr lvl="1"/>
+            <a:r>
+              <a:rPr lang="sk-SK" sz="1200" dirty="0"/>
+              <a:t>VM‑</a:t>
+            </a:r>
+            <a:r>
+              <a:rPr lang="sk-SK" sz="1200" dirty="0" err="1"/>
+              <a:t>entry</a:t>
+            </a:r>
+            <a:r>
+              <a:rPr lang="sk-SK" sz="1200" dirty="0"/>
+              <a:t>: prechod do virtuálneho stroja</a:t>
+            </a:r>
+          </a:p>
+          <a:p>
+            <a:pPr lvl="1"/>
+            <a:r>
+              <a:rPr lang="sk-SK" sz="1200" dirty="0"/>
+              <a:t>VM‑</a:t>
+            </a:r>
+            <a:r>
+              <a:rPr lang="sk-SK" sz="1200" dirty="0" err="1"/>
+              <a:t>exit</a:t>
+            </a:r>
+            <a:r>
+              <a:rPr lang="sk-SK" sz="1200" dirty="0"/>
+              <a:t>: návrat do </a:t>
+            </a:r>
+            <a:r>
+              <a:rPr lang="sk-SK" sz="1200" dirty="0" err="1"/>
+              <a:t>hypervízora</a:t>
+            </a:r>
+            <a:endParaRPr lang="sk-SK" sz="1200" dirty="0"/>
+          </a:p>
+          <a:p>
+            <a:endParaRPr lang="sk-SK" sz="1200" dirty="0"/>
+          </a:p>
+          <a:p>
+            <a:r>
+              <a:rPr lang="sk-SK" sz="1200" dirty="0"/>
+              <a:t>CPU automaticky:</a:t>
+            </a:r>
+          </a:p>
+          <a:p>
+            <a:pPr lvl="1"/>
+            <a:r>
+              <a:rPr lang="sk-SK" sz="1200" dirty="0"/>
+              <a:t> uloží stav hosťa</a:t>
+            </a:r>
+          </a:p>
+          <a:p>
+            <a:pPr lvl="1"/>
+            <a:r>
+              <a:rPr lang="sk-SK" sz="1200" dirty="0"/>
+              <a:t> obnoví stav </a:t>
+            </a:r>
+            <a:r>
+              <a:rPr lang="sk-SK" sz="1200" dirty="0" err="1"/>
+              <a:t>hypervízora</a:t>
+            </a:r>
+            <a:endParaRPr lang="sk-SK" sz="1200" dirty="0"/>
+          </a:p>
+        </p:txBody>
+      </p:sp>
+      <p:sp>
+        <p:nvSpPr>
+          <p:cNvPr id="4" name="Zástupný objekt pre obsah 3">
+            <a:extLst>
+              <a:ext uri="{FF2B5EF4-FFF2-40B4-BE49-F238E27FC236}">
+                <a16:creationId xmlns:a16="http://schemas.microsoft.com/office/drawing/2014/main" id="{2F6E88E2-87C3-25BE-7606-C73EDBD2CC72}"/>
+              </a:ext>
+            </a:extLst>
+          </p:cNvPr>
+          <p:cNvSpPr>
+            <a:spLocks noGrp="1"/>
+          </p:cNvSpPr>
+          <p:nvPr>
+            <p:ph sz="half" idx="2"/>
+          </p:nvPr>
+        </p:nvSpPr>
+        <p:spPr>
+          <a:xfrm>
+            <a:off x="4997450" y="1233488"/>
+            <a:ext cx="4038600" cy="4955439"/>
+          </a:xfrm>
+        </p:spPr>
+        <p:txBody>
+          <a:bodyPr>
+            <a:normAutofit lnSpcReduction="10000"/>
+          </a:bodyPr>
+          <a:lstStyle/>
+          <a:p>
+            <a:pPr marL="0" indent="0">
+              <a:buNone/>
+            </a:pPr>
+            <a:r>
+              <a:rPr lang="sk-SK" sz="1100" b="1" dirty="0"/>
+              <a:t>AMD SVM (AMD‑V)</a:t>
+            </a:r>
+          </a:p>
+          <a:p>
+            <a:pPr marL="0" indent="0">
+              <a:buNone/>
+            </a:pPr>
+            <a:r>
+              <a:rPr lang="sk-SK" sz="1100" dirty="0"/>
+              <a:t>AMD používa takmer rovnaký koncept, len s inými názvami.</a:t>
+            </a:r>
+          </a:p>
+          <a:p>
+            <a:r>
+              <a:rPr lang="sk-SK" sz="1100" dirty="0"/>
+              <a:t>Kľúčové prvky</a:t>
+            </a:r>
+          </a:p>
+          <a:p>
+            <a:r>
+              <a:rPr lang="sk-SK" sz="1100" dirty="0"/>
+              <a:t>1. VMCB (</a:t>
+            </a:r>
+            <a:r>
+              <a:rPr lang="sk-SK" sz="1100" dirty="0" err="1"/>
+              <a:t>Virtual</a:t>
+            </a:r>
+            <a:r>
+              <a:rPr lang="sk-SK" sz="1100" dirty="0"/>
+              <a:t> </a:t>
+            </a:r>
+            <a:r>
+              <a:rPr lang="sk-SK" sz="1100" dirty="0" err="1"/>
+              <a:t>Machine</a:t>
+            </a:r>
+            <a:r>
+              <a:rPr lang="sk-SK" sz="1100" dirty="0"/>
+              <a:t> </a:t>
+            </a:r>
+            <a:r>
+              <a:rPr lang="sk-SK" sz="1100" dirty="0" err="1"/>
+              <a:t>Control</a:t>
+            </a:r>
+            <a:r>
+              <a:rPr lang="sk-SK" sz="1100" dirty="0"/>
+              <a:t> </a:t>
+            </a:r>
+            <a:r>
+              <a:rPr lang="sk-SK" sz="1100" dirty="0" err="1"/>
+              <a:t>Block</a:t>
+            </a:r>
+            <a:r>
+              <a:rPr lang="sk-SK" sz="1100" dirty="0"/>
+              <a:t>)</a:t>
+            </a:r>
+          </a:p>
+          <a:p>
+            <a:pPr marL="0" indent="0">
+              <a:buNone/>
+            </a:pPr>
+            <a:r>
+              <a:rPr lang="sk-SK" sz="1100" dirty="0"/>
+              <a:t>Ekvivalent VMCS:</a:t>
+            </a:r>
+          </a:p>
+          <a:p>
+            <a:pPr lvl="1"/>
+            <a:r>
+              <a:rPr lang="sk-SK" sz="1100" dirty="0"/>
+              <a:t>stav CPU</a:t>
+            </a:r>
+          </a:p>
+          <a:p>
+            <a:pPr lvl="1"/>
+            <a:r>
+              <a:rPr lang="sk-SK" sz="1100" dirty="0" err="1"/>
+              <a:t>intercepty</a:t>
+            </a:r>
+            <a:endParaRPr lang="sk-SK" sz="1100" dirty="0"/>
+          </a:p>
+          <a:p>
+            <a:pPr lvl="1"/>
+            <a:r>
+              <a:rPr lang="sk-SK" sz="1100" dirty="0"/>
+              <a:t>konfigurácia VM</a:t>
+            </a:r>
+          </a:p>
+          <a:p>
+            <a:pPr lvl="1"/>
+            <a:endParaRPr lang="sk-SK" sz="1100" dirty="0"/>
+          </a:p>
+          <a:p>
+            <a:r>
+              <a:rPr lang="sk-SK" sz="1100" dirty="0"/>
+              <a:t>2. </a:t>
+            </a:r>
+            <a:r>
+              <a:rPr lang="sk-SK" sz="1100" dirty="0" err="1"/>
+              <a:t>Host</a:t>
+            </a:r>
+            <a:r>
+              <a:rPr lang="sk-SK" sz="1100" dirty="0"/>
+              <a:t>/</a:t>
+            </a:r>
+            <a:r>
+              <a:rPr lang="sk-SK" sz="1100" dirty="0" err="1"/>
+              <a:t>Guest</a:t>
+            </a:r>
+            <a:r>
+              <a:rPr lang="sk-SK" sz="1100" dirty="0"/>
+              <a:t> módy</a:t>
+            </a:r>
+          </a:p>
+          <a:p>
+            <a:pPr lvl="1"/>
+            <a:r>
+              <a:rPr lang="sk-SK" sz="1100" dirty="0" err="1"/>
+              <a:t>Host</a:t>
+            </a:r>
+            <a:r>
+              <a:rPr lang="sk-SK" sz="1100" dirty="0"/>
+              <a:t> </a:t>
+            </a:r>
+            <a:r>
+              <a:rPr lang="sk-SK" sz="1100" dirty="0" err="1"/>
+              <a:t>mode</a:t>
+            </a:r>
+            <a:r>
+              <a:rPr lang="sk-SK" sz="1100" dirty="0"/>
+              <a:t> → </a:t>
+            </a:r>
+            <a:r>
+              <a:rPr lang="sk-SK" sz="1100" dirty="0" err="1"/>
+              <a:t>hypervízor</a:t>
+            </a:r>
+            <a:endParaRPr lang="sk-SK" sz="1100" dirty="0"/>
+          </a:p>
+          <a:p>
+            <a:pPr lvl="1"/>
+            <a:r>
+              <a:rPr lang="sk-SK" sz="1100" dirty="0" err="1"/>
+              <a:t>Guest</a:t>
+            </a:r>
+            <a:r>
+              <a:rPr lang="sk-SK" sz="1100" dirty="0"/>
+              <a:t> </a:t>
+            </a:r>
+            <a:r>
+              <a:rPr lang="sk-SK" sz="1100" dirty="0" err="1"/>
+              <a:t>mode</a:t>
+            </a:r>
+            <a:r>
+              <a:rPr lang="sk-SK" sz="1100" dirty="0"/>
+              <a:t> → VM</a:t>
+            </a:r>
+          </a:p>
+          <a:p>
+            <a:pPr marL="0" indent="0">
+              <a:buNone/>
+            </a:pPr>
+            <a:endParaRPr lang="sk-SK" sz="1100" dirty="0"/>
+          </a:p>
+          <a:p>
+            <a:pPr marL="0" indent="0">
+              <a:buNone/>
+            </a:pPr>
+            <a:r>
+              <a:rPr lang="sk-SK" sz="1100" dirty="0" err="1"/>
+              <a:t>Intercept</a:t>
+            </a:r>
+            <a:r>
+              <a:rPr lang="sk-SK" sz="1100" dirty="0"/>
+              <a:t> - CPU vie povedať: „Táto inštrukcia je nebezpečná – idem späť do </a:t>
+            </a:r>
+            <a:r>
+              <a:rPr lang="sk-SK" sz="1100" dirty="0" err="1"/>
+              <a:t>hypervízora</a:t>
+            </a:r>
+            <a:r>
+              <a:rPr lang="sk-SK" sz="1100" dirty="0"/>
               <a:t>“</a:t>
             </a:r>
-            <a:r>
-              <a:rPr lang="en-US" altLang="sk-SK" dirty="0">
-                <a:ea typeface="ＭＳ Ｐゴシック" panose="020B0600070205080204" pitchFamily="34" charset="-128"/>
-              </a:rPr>
-              <a:t>host</a:t>
-            </a:r>
-            <a:r>
-              <a:rPr lang="en-US" altLang="en-US" dirty="0">
-                <a:ea typeface="ＭＳ Ｐゴシック" panose="020B0600070205080204" pitchFamily="34" charset="-128"/>
-              </a:rPr>
-              <a:t>”</a:t>
-            </a:r>
-            <a:endParaRPr lang="en-US" altLang="sk-SK" dirty="0">
-              <a:ea typeface="ＭＳ Ｐゴシック" panose="020B0600070205080204" pitchFamily="34" charset="-128"/>
-            </a:endParaRPr>
-          </a:p>
-          <a:p>
-            <a:pPr lvl="1"/>
-            <a:r>
-              <a:rPr lang="en-US" altLang="sk-SK" dirty="0">
-                <a:ea typeface="ＭＳ Ｐゴシック" panose="020B0600070205080204" pitchFamily="34" charset="-128"/>
-              </a:rPr>
-              <a:t>VMM can enable host mode, define characteristics of each guest VM, switch to guest mode and guest(s) on CPU(s)</a:t>
-            </a:r>
-          </a:p>
-          <a:p>
-            <a:pPr lvl="1"/>
-            <a:r>
-              <a:rPr lang="en-US" altLang="sk-SK" dirty="0">
-                <a:ea typeface="ＭＳ Ｐゴシック" panose="020B0600070205080204" pitchFamily="34" charset="-128"/>
-              </a:rPr>
-              <a:t>In guest mode, guest OS thinks it is running natively, sees devices (as defined by VMM for that guest) </a:t>
-            </a:r>
-          </a:p>
-          <a:p>
-            <a:pPr lvl="2"/>
-            <a:r>
-              <a:rPr lang="en-US" altLang="sk-SK" dirty="0">
-                <a:ea typeface="ＭＳ Ｐゴシック" panose="020B0600070205080204" pitchFamily="34" charset="-128"/>
-              </a:rPr>
-              <a:t>Access to virtualized device, </a:t>
-            </a:r>
-            <a:r>
-              <a:rPr lang="en-US" altLang="sk-SK" dirty="0" err="1">
-                <a:ea typeface="ＭＳ Ｐゴシック" panose="020B0600070205080204" pitchFamily="34" charset="-128"/>
-              </a:rPr>
-              <a:t>priv</a:t>
-            </a:r>
-            <a:r>
-              <a:rPr lang="en-US" altLang="sk-SK" dirty="0">
-                <a:ea typeface="ＭＳ Ｐゴシック" panose="020B0600070205080204" pitchFamily="34" charset="-128"/>
-              </a:rPr>
-              <a:t> instructions cause trap to VMM</a:t>
-            </a:r>
-          </a:p>
-          <a:p>
-            <a:pPr lvl="2"/>
-            <a:r>
-              <a:rPr lang="en-US" altLang="sk-SK" dirty="0">
-                <a:ea typeface="ＭＳ Ｐゴシック" panose="020B0600070205080204" pitchFamily="34" charset="-128"/>
-              </a:rPr>
-              <a:t>CPU maintains VCPU, context switches it as needed</a:t>
-            </a:r>
-          </a:p>
-          <a:p>
-            <a:r>
-              <a:rPr lang="en-US" altLang="sk-SK" u="sng" dirty="0">
-                <a:ea typeface="ＭＳ Ｐゴシック" panose="020B0600070205080204" pitchFamily="34" charset="-128"/>
-              </a:rPr>
-              <a:t>HW support for Nested Page Tables, DMA, interrupts as well over time</a:t>
-            </a:r>
-          </a:p>
-          <a:p>
-            <a:pPr lvl="1"/>
-            <a:endParaRPr lang="en-US" altLang="sk-SK" dirty="0">
-              <a:ea typeface="ＭＳ Ｐゴシック" panose="020B0600070205080204" pitchFamily="34" charset="-128"/>
-            </a:endParaRPr>
-          </a:p>
-          <a:p>
-            <a:pPr lvl="2"/>
-            <a:endParaRPr lang="en-US" altLang="sk-SK" dirty="0">
-              <a:ea typeface="ＭＳ Ｐゴシック" panose="020B0600070205080204" pitchFamily="34" charset="-128"/>
-            </a:endParaRPr>
-          </a:p>
-          <a:p>
-            <a:pPr>
-              <a:buFont typeface="Monotype Sorts" pitchFamily="2" charset="2"/>
+          </a:p>
+          <a:p>
+            <a:pPr marL="0" indent="0">
               <a:buNone/>
             </a:pPr>
-            <a:endParaRPr lang="en-US" altLang="sk-SK" dirty="0">
-              <a:latin typeface="Courier New" panose="02070309020205020404" pitchFamily="49" charset="0"/>
-              <a:ea typeface="ＭＳ Ｐゴシック" panose="020B0600070205080204" pitchFamily="34" charset="-128"/>
-              <a:cs typeface="Courier New" panose="02070309020205020404" pitchFamily="49" charset="0"/>
-            </a:endParaRPr>
+            <a:endParaRPr lang="sk-SK" sz="1100" dirty="0"/>
+          </a:p>
+          <a:p>
+            <a:pPr marL="0" indent="0">
+              <a:buNone/>
+            </a:pPr>
+            <a:r>
+              <a:rPr lang="sk-SK" sz="1100" dirty="0"/>
+              <a:t>Typické </a:t>
+            </a:r>
+            <a:r>
+              <a:rPr lang="sk-SK" sz="1100" dirty="0" err="1"/>
+              <a:t>intercepty</a:t>
+            </a:r>
+            <a:r>
+              <a:rPr lang="sk-SK" sz="1100" dirty="0"/>
+              <a:t>:</a:t>
+            </a:r>
+          </a:p>
+          <a:p>
+            <a:pPr marL="0" indent="0">
+              <a:buNone/>
+            </a:pPr>
+            <a:endParaRPr lang="sk-SK" sz="1100" dirty="0"/>
+          </a:p>
+          <a:p>
+            <a:r>
+              <a:rPr lang="sk-SK" sz="1100" dirty="0"/>
+              <a:t>prístup k I/O portom</a:t>
+            </a:r>
+          </a:p>
+          <a:p>
+            <a:r>
+              <a:rPr lang="sk-SK" sz="1100" dirty="0"/>
+              <a:t>manipulácia s registrami CR0–CR4</a:t>
+            </a:r>
+          </a:p>
+          <a:p>
+            <a:r>
+              <a:rPr lang="sk-SK" sz="1100" dirty="0"/>
+              <a:t>prerušenia</a:t>
+            </a:r>
+          </a:p>
+          <a:p>
+            <a:r>
+              <a:rPr lang="sk-SK" sz="1100" dirty="0"/>
+              <a:t>HLT</a:t>
+            </a:r>
+          </a:p>
+          <a:p>
+            <a:r>
+              <a:rPr lang="sk-SK" sz="1100" dirty="0"/>
+              <a:t>prístup k MSR – model-</a:t>
+            </a:r>
+            <a:r>
+              <a:rPr lang="sk-SK" sz="1100" dirty="0" err="1"/>
+              <a:t>specific</a:t>
+            </a:r>
+            <a:r>
+              <a:rPr lang="sk-SK" sz="1100" dirty="0"/>
+              <a:t> register</a:t>
+            </a:r>
           </a:p>
         </p:txBody>
       </p:sp>
     </p:spTree>
+    <p:extLst>
+      <p:ext uri="{BB962C8B-B14F-4D97-AF65-F5344CB8AC3E}">
+        <p14:creationId xmlns:p14="http://schemas.microsoft.com/office/powerpoint/2010/main" val="2092384274"/>
+      </p:ext>
+    </p:extLst>
   </p:cSld>
   <p:clrMapOvr>
     <a:masterClrMapping/>
@@ -8919,6 +9428,271 @@
       </p:grpSpPr>
       <p:sp>
         <p:nvSpPr>
+          <p:cNvPr id="24577" name="Title 1">
+            <a:extLst>
+              <a:ext uri="{FF2B5EF4-FFF2-40B4-BE49-F238E27FC236}">
+                <a16:creationId xmlns:a16="http://schemas.microsoft.com/office/drawing/2014/main" id="{A87FF3B3-BB8C-0961-E38A-9ECEE8F66166}"/>
+              </a:ext>
+            </a:extLst>
+          </p:cNvPr>
+          <p:cNvSpPr>
+            <a:spLocks noGrp="1" noChangeArrowheads="1"/>
+          </p:cNvSpPr>
+          <p:nvPr>
+            <p:ph type="title"/>
+          </p:nvPr>
+        </p:nvSpPr>
+        <p:spPr/>
+        <p:txBody>
+          <a:bodyPr/>
+          <a:lstStyle/>
+          <a:p>
+            <a:r>
+              <a:rPr lang="en-US" altLang="sk-SK">
+                <a:ea typeface="ＭＳ Ｐゴシック" panose="020B0600070205080204" pitchFamily="34" charset="-128"/>
+              </a:rPr>
+              <a:t>Nested Page Tables</a:t>
+            </a:r>
+          </a:p>
+        </p:txBody>
+      </p:sp>
+      <p:sp>
+        <p:nvSpPr>
+          <p:cNvPr id="24578" name="Content Placeholder 2">
+            <a:extLst>
+              <a:ext uri="{FF2B5EF4-FFF2-40B4-BE49-F238E27FC236}">
+                <a16:creationId xmlns:a16="http://schemas.microsoft.com/office/drawing/2014/main" id="{B4400930-85F5-5A0D-D973-27F9B6852FD2}"/>
+              </a:ext>
+            </a:extLst>
+          </p:cNvPr>
+          <p:cNvSpPr>
+            <a:spLocks noGrp="1" noChangeArrowheads="1"/>
+          </p:cNvSpPr>
+          <p:nvPr>
+            <p:ph idx="1"/>
+          </p:nvPr>
+        </p:nvSpPr>
+        <p:spPr/>
+        <p:txBody>
+          <a:bodyPr/>
+          <a:lstStyle/>
+          <a:p>
+            <a:r>
+              <a:rPr lang="en-US" altLang="sk-SK" dirty="0">
+                <a:ea typeface="ＭＳ Ｐゴシック" panose="020B0600070205080204" pitchFamily="34" charset="-128"/>
+              </a:rPr>
+              <a:t>Memory management another general challenge to VMM implementations</a:t>
+            </a:r>
+          </a:p>
+          <a:p>
+            <a:r>
+              <a:rPr lang="en-US" altLang="sk-SK" dirty="0">
+                <a:ea typeface="ＭＳ Ｐゴシック" panose="020B0600070205080204" pitchFamily="34" charset="-128"/>
+              </a:rPr>
+              <a:t>How can VMM keep page-table state for both guests believing they control the page tables and VMM that does control the tables?</a:t>
+            </a:r>
+          </a:p>
+          <a:p>
+            <a:r>
+              <a:rPr lang="en-US" altLang="sk-SK" dirty="0">
+                <a:ea typeface="ＭＳ Ｐゴシック" panose="020B0600070205080204" pitchFamily="34" charset="-128"/>
+              </a:rPr>
+              <a:t>Common method (for trap-and-emulate and binary translation) is </a:t>
+            </a:r>
+            <a:r>
+              <a:rPr lang="en-US" altLang="sk-SK" b="1" dirty="0">
+                <a:solidFill>
+                  <a:srgbClr val="3366FF"/>
+                </a:solidFill>
+                <a:ea typeface="ＭＳ Ｐゴシック" panose="020B0600070205080204" pitchFamily="34" charset="-128"/>
+              </a:rPr>
+              <a:t>nested page</a:t>
+            </a:r>
+            <a:r>
+              <a:rPr lang="en-US" altLang="sk-SK" dirty="0">
+                <a:ea typeface="ＭＳ Ｐゴシック" panose="020B0600070205080204" pitchFamily="34" charset="-128"/>
+              </a:rPr>
+              <a:t> </a:t>
+            </a:r>
+            <a:r>
+              <a:rPr lang="en-US" altLang="sk-SK" b="1" dirty="0">
+                <a:solidFill>
+                  <a:srgbClr val="3366FF"/>
+                </a:solidFill>
+                <a:ea typeface="ＭＳ Ｐゴシック" panose="020B0600070205080204" pitchFamily="34" charset="-128"/>
+              </a:rPr>
+              <a:t>tables</a:t>
+            </a:r>
+            <a:r>
+              <a:rPr lang="en-US" altLang="sk-SK" dirty="0">
+                <a:ea typeface="ＭＳ Ｐゴシック" panose="020B0600070205080204" pitchFamily="34" charset="-128"/>
+              </a:rPr>
+              <a:t> (</a:t>
+            </a:r>
+            <a:r>
+              <a:rPr lang="en-US" altLang="sk-SK" b="1" dirty="0">
+                <a:solidFill>
+                  <a:srgbClr val="3366FF"/>
+                </a:solidFill>
+                <a:ea typeface="ＭＳ Ｐゴシック" panose="020B0600070205080204" pitchFamily="34" charset="-128"/>
+              </a:rPr>
+              <a:t>NPTs</a:t>
+            </a:r>
+            <a:r>
+              <a:rPr lang="en-US" altLang="sk-SK" dirty="0">
+                <a:ea typeface="ＭＳ Ｐゴシック" panose="020B0600070205080204" pitchFamily="34" charset="-128"/>
+              </a:rPr>
+              <a:t>) </a:t>
+            </a:r>
+          </a:p>
+          <a:p>
+            <a:pPr lvl="1"/>
+            <a:r>
+              <a:rPr lang="en-US" altLang="sk-SK" dirty="0">
+                <a:ea typeface="ＭＳ Ｐゴシック" panose="020B0600070205080204" pitchFamily="34" charset="-128"/>
+              </a:rPr>
+              <a:t>Each guest maintains page tables to translate virtual to physical addresses</a:t>
+            </a:r>
+          </a:p>
+          <a:p>
+            <a:pPr lvl="1"/>
+            <a:r>
+              <a:rPr lang="en-US" altLang="sk-SK" dirty="0">
+                <a:ea typeface="ＭＳ Ｐゴシック" panose="020B0600070205080204" pitchFamily="34" charset="-128"/>
+              </a:rPr>
+              <a:t>VMM maintains per guest NPTs to represent guest</a:t>
+            </a:r>
+            <a:r>
+              <a:rPr lang="en-US" altLang="en-US" dirty="0">
+                <a:ea typeface="ＭＳ Ｐゴシック" panose="020B0600070205080204" pitchFamily="34" charset="-128"/>
+              </a:rPr>
+              <a:t>’</a:t>
+            </a:r>
+            <a:r>
+              <a:rPr lang="en-US" altLang="sk-SK" dirty="0">
+                <a:ea typeface="ＭＳ Ｐゴシック" panose="020B0600070205080204" pitchFamily="34" charset="-128"/>
+              </a:rPr>
+              <a:t>s page-table state</a:t>
+            </a:r>
+          </a:p>
+          <a:p>
+            <a:pPr lvl="2"/>
+            <a:r>
+              <a:rPr lang="en-US" altLang="sk-SK" dirty="0">
+                <a:ea typeface="ＭＳ Ｐゴシック" panose="020B0600070205080204" pitchFamily="34" charset="-128"/>
+              </a:rPr>
+              <a:t>Just as VCPU stores guest CPU state</a:t>
+            </a:r>
+          </a:p>
+          <a:p>
+            <a:pPr lvl="1"/>
+            <a:r>
+              <a:rPr lang="en-US" altLang="sk-SK" dirty="0">
+                <a:ea typeface="ＭＳ Ｐゴシック" panose="020B0600070205080204" pitchFamily="34" charset="-128"/>
+              </a:rPr>
+              <a:t>When guest on CPU -&gt; VMM makes that guest</a:t>
+            </a:r>
+            <a:r>
+              <a:rPr lang="en-US" altLang="en-US" dirty="0">
+                <a:ea typeface="ＭＳ Ｐゴシック" panose="020B0600070205080204" pitchFamily="34" charset="-128"/>
+              </a:rPr>
+              <a:t>’</a:t>
+            </a:r>
+            <a:r>
+              <a:rPr lang="en-US" altLang="sk-SK" dirty="0">
+                <a:ea typeface="ＭＳ Ｐゴシック" panose="020B0600070205080204" pitchFamily="34" charset="-128"/>
+              </a:rPr>
+              <a:t>s NPTs the active system page tables</a:t>
+            </a:r>
+          </a:p>
+          <a:p>
+            <a:pPr lvl="1"/>
+            <a:r>
+              <a:rPr lang="en-US" altLang="sk-SK" dirty="0">
+                <a:ea typeface="ＭＳ Ｐゴシック" panose="020B0600070205080204" pitchFamily="34" charset="-128"/>
+              </a:rPr>
+              <a:t>Guest tries to change page table -&gt; VMM makes equivalent change to NPTs and its own page tables</a:t>
+            </a:r>
+          </a:p>
+          <a:p>
+            <a:pPr lvl="1"/>
+            <a:r>
+              <a:rPr lang="en-US" altLang="sk-SK" dirty="0">
+                <a:ea typeface="ＭＳ Ｐゴシック" panose="020B0600070205080204" pitchFamily="34" charset="-128"/>
+              </a:rPr>
+              <a:t>Can </a:t>
+            </a:r>
+            <a:r>
+              <a:rPr lang="en-US" altLang="sk-SK" u="sng" dirty="0">
+                <a:ea typeface="ＭＳ Ｐゴシック" panose="020B0600070205080204" pitchFamily="34" charset="-128"/>
+              </a:rPr>
+              <a:t>cause many more TLB misses </a:t>
+            </a:r>
+            <a:r>
+              <a:rPr lang="en-US" altLang="sk-SK" dirty="0">
+                <a:ea typeface="ＭＳ Ｐゴシック" panose="020B0600070205080204" pitchFamily="34" charset="-128"/>
+              </a:rPr>
+              <a:t>-&gt; much slower performance</a:t>
+            </a:r>
+          </a:p>
+          <a:p>
+            <a:pPr lvl="1"/>
+            <a:endParaRPr lang="en-US" altLang="sk-SK" dirty="0">
+              <a:ea typeface="ＭＳ Ｐゴシック" panose="020B0600070205080204" pitchFamily="34" charset="-128"/>
+            </a:endParaRPr>
+          </a:p>
+          <a:p>
+            <a:pPr lvl="1"/>
+            <a:endParaRPr lang="en-US" altLang="sk-SK" dirty="0">
+              <a:ea typeface="ＭＳ Ｐゴシック" panose="020B0600070205080204" pitchFamily="34" charset="-128"/>
+            </a:endParaRPr>
+          </a:p>
+          <a:p>
+            <a:pPr lvl="2"/>
+            <a:endParaRPr lang="en-US" altLang="sk-SK" dirty="0">
+              <a:ea typeface="ＭＳ Ｐゴシック" panose="020B0600070205080204" pitchFamily="34" charset="-128"/>
+            </a:endParaRPr>
+          </a:p>
+          <a:p>
+            <a:pPr>
+              <a:buFont typeface="Monotype Sorts" pitchFamily="2" charset="2"/>
+              <a:buNone/>
+            </a:pPr>
+            <a:endParaRPr lang="en-US" altLang="sk-SK" dirty="0">
+              <a:latin typeface="Courier New" panose="02070309020205020404" pitchFamily="49" charset="0"/>
+              <a:ea typeface="ＭＳ Ｐゴシック" panose="020B0600070205080204" pitchFamily="34" charset="-128"/>
+              <a:cs typeface="Courier New" panose="02070309020205020404" pitchFamily="49" charset="0"/>
+            </a:endParaRPr>
+          </a:p>
+        </p:txBody>
+      </p:sp>
+    </p:spTree>
+  </p:cSld>
+  <p:clrMapOvr>
+    <a:masterClrMapping/>
+  </p:clrMapOvr>
+</p:sld>
+</file>
+
+<file path=ppt/slides/slide21.xml><?xml version="1.0" encoding="utf-8"?>
+<p:sld xmlns:a="http://schemas.openxmlformats.org/drawingml/2006/main" xmlns:r="http://schemas.openxmlformats.org/officeDocument/2006/relationships" xmlns:p="http://schemas.openxmlformats.org/presentationml/2006/main">
+  <p:cSld>
+    <p:spTree>
+      <p:nvGrpSpPr>
+        <p:cNvPr id="1" name=""/>
+        <p:cNvGrpSpPr/>
+        <p:nvPr/>
+      </p:nvGrpSpPr>
+      <p:grpSpPr>
+        <a:xfrm>
+          <a:off x="0" y="0"/>
+          <a:ext cx="0" cy="0"/>
+          <a:chOff x="0" y="0"/>
+          <a:chExt cx="0" cy="0"/>
+        </a:xfrm>
+      </p:grpSpPr>
+      <p:sp>
+        <p:nvSpPr>
           <p:cNvPr id="26625" name="Title 1">
             <a:extLst>
               <a:ext uri="{FF2B5EF4-FFF2-40B4-BE49-F238E27FC236}">
@@ -8963,7 +9737,7 @@
             <p:ph idx="1"/>
           </p:nvPr>
         </p:nvPicPr>
-        <p:blipFill>
+        <p:blipFill rotWithShape="1">
           <a:blip r:embed="rId2">
             <a:extLst>
               <a:ext uri="{28A0092B-C50C-407E-A947-70E740481C1C}">
@@ -8971,18 +9745,128 @@
               </a:ext>
             </a:extLst>
           </a:blip>
-          <a:srcRect l="-65543" r="-65543"/>
+          <a:srcRect l="-1378" t="-405" r="-6049" b="405"/>
           <a:stretch>
             <a:fillRect/>
           </a:stretch>
         </p:blipFill>
         <p:spPr>
           <a:xfrm>
-            <a:off x="515938" y="958850"/>
-            <a:ext cx="8275637" cy="5513388"/>
+            <a:off x="591015" y="981152"/>
+            <a:ext cx="3847172" cy="5513388"/>
           </a:xfrm>
         </p:spPr>
       </p:pic>
+      <p:sp>
+        <p:nvSpPr>
+          <p:cNvPr id="2" name="BlokTextu 1">
+            <a:extLst>
+              <a:ext uri="{FF2B5EF4-FFF2-40B4-BE49-F238E27FC236}">
+                <a16:creationId xmlns:a16="http://schemas.microsoft.com/office/drawing/2014/main" id="{83D4EE32-F5FB-3E13-F118-F95C26593B4F}"/>
+              </a:ext>
+            </a:extLst>
+          </p:cNvPr>
+          <p:cNvSpPr txBox="1"/>
+          <p:nvPr/>
+        </p:nvSpPr>
+        <p:spPr>
+          <a:xfrm>
+            <a:off x="4572000" y="1260088"/>
+            <a:ext cx="4228145" cy="1754326"/>
+          </a:xfrm>
+          <a:prstGeom prst="rect">
+            <a:avLst/>
+          </a:prstGeom>
+          <a:noFill/>
+        </p:spPr>
+        <p:txBody>
+          <a:bodyPr wrap="none" rtlCol="0">
+            <a:spAutoFit/>
+          </a:bodyPr>
+          <a:lstStyle/>
+          <a:p>
+            <a:r>
+              <a:rPr lang="sk-SK" dirty="0"/>
+              <a:t>Pamäťová virtualizácia (EPT / NPT)</a:t>
+            </a:r>
+          </a:p>
+          <a:p>
+            <a:r>
+              <a:rPr lang="sk-SK" dirty="0"/>
+              <a:t>Bez podpory → pomalé</a:t>
+            </a:r>
+          </a:p>
+          <a:p>
+            <a:r>
+              <a:rPr lang="sk-SK" dirty="0"/>
+              <a:t>S podporou → rýchle</a:t>
+            </a:r>
+          </a:p>
+          <a:p>
+            <a:endParaRPr lang="sk-SK" dirty="0"/>
+          </a:p>
+          <a:p>
+            <a:r>
+              <a:rPr lang="sk-SK" dirty="0"/>
+              <a:t>Intel: EPT (</a:t>
+            </a:r>
+            <a:r>
+              <a:rPr lang="sk-SK" dirty="0" err="1"/>
+              <a:t>Extended</a:t>
+            </a:r>
+            <a:r>
+              <a:rPr lang="sk-SK" dirty="0"/>
+              <a:t> </a:t>
+            </a:r>
+            <a:r>
+              <a:rPr lang="sk-SK" dirty="0" err="1"/>
+              <a:t>Page</a:t>
+            </a:r>
+            <a:r>
+              <a:rPr lang="sk-SK" dirty="0"/>
+              <a:t> </a:t>
+            </a:r>
+            <a:r>
+              <a:rPr lang="sk-SK" dirty="0" err="1"/>
+              <a:t>Tables</a:t>
+            </a:r>
+            <a:r>
+              <a:rPr lang="sk-SK" dirty="0"/>
+              <a:t>)</a:t>
+            </a:r>
+          </a:p>
+          <a:p>
+            <a:r>
+              <a:rPr lang="sk-SK" dirty="0"/>
+              <a:t>AMD: NPT (</a:t>
+            </a:r>
+            <a:r>
+              <a:rPr lang="sk-SK" dirty="0" err="1"/>
+              <a:t>Nested</a:t>
+            </a:r>
+            <a:r>
+              <a:rPr lang="sk-SK" dirty="0"/>
+              <a:t> </a:t>
+            </a:r>
+            <a:r>
+              <a:rPr lang="sk-SK" dirty="0" err="1"/>
+              <a:t>Page</a:t>
+            </a:r>
+            <a:r>
+              <a:rPr lang="sk-SK" dirty="0"/>
+              <a:t> </a:t>
+            </a:r>
+            <a:r>
+              <a:rPr lang="sk-SK" dirty="0" err="1"/>
+              <a:t>Tables</a:t>
+            </a:r>
+            <a:r>
+              <a:rPr lang="sk-SK" dirty="0"/>
+              <a:t>)</a:t>
+            </a:r>
+          </a:p>
+        </p:txBody>
+      </p:sp>
     </p:spTree>
   </p:cSld>
   <p:clrMapOvr>
@@ -8991,7 +9875,7 @@
 </p:sld>
 </file>
 
-<file path=ppt/slides/slide21.xml><?xml version="1.0" encoding="utf-8"?>
+<file path=ppt/slides/slide22.xml><?xml version="1.0" encoding="utf-8"?>
 <p:sld xmlns:a="http://schemas.openxmlformats.org/drawingml/2006/main" xmlns:r="http://schemas.openxmlformats.org/officeDocument/2006/relationships" xmlns:p="http://schemas.openxmlformats.org/presentationml/2006/main">
   <p:cSld>
     <p:spTree>
@@ -9263,7 +10147,7 @@
 </p:sld>
 </file>
 
-<file path=ppt/slides/slide22.xml><?xml version="1.0" encoding="utf-8"?>
+<file path=ppt/slides/slide23.xml><?xml version="1.0" encoding="utf-8"?>
 <p:sld xmlns:a="http://schemas.openxmlformats.org/drawingml/2006/main" xmlns:r="http://schemas.openxmlformats.org/officeDocument/2006/relationships" xmlns:p="http://schemas.openxmlformats.org/presentationml/2006/main">
   <p:cSld>
     <p:spTree>
@@ -9514,7 +10398,7 @@
 </p:sld>
 </file>
 
-<file path=ppt/slides/slide23.xml><?xml version="1.0" encoding="utf-8"?>
+<file path=ppt/slides/slide24.xml><?xml version="1.0" encoding="utf-8"?>
 <p:sld xmlns:a="http://schemas.openxmlformats.org/drawingml/2006/main" xmlns:r="http://schemas.openxmlformats.org/officeDocument/2006/relationships" xmlns:p="http://schemas.openxmlformats.org/presentationml/2006/main">
   <p:cSld>
     <p:spTree>
@@ -9605,7 +10489,7 @@
 </p:sld>
 </file>
 
-<file path=ppt/slides/slide24.xml><?xml version="1.0" encoding="utf-8"?>
+<file path=ppt/slides/slide25.xml><?xml version="1.0" encoding="utf-8"?>
 <p:sld xmlns:a="http://schemas.openxmlformats.org/drawingml/2006/main" xmlns:r="http://schemas.openxmlformats.org/officeDocument/2006/relationships" xmlns:p="http://schemas.openxmlformats.org/presentationml/2006/main">
   <p:cSld>
     <p:spTree>
@@ -9888,7 +10772,7 @@
 </p:sld>
 </file>
 
-<file path=ppt/slides/slide25.xml><?xml version="1.0" encoding="utf-8"?>
+<file path=ppt/slides/slide26.xml><?xml version="1.0" encoding="utf-8"?>
 <p:sld xmlns:a="http://schemas.openxmlformats.org/drawingml/2006/main" xmlns:r="http://schemas.openxmlformats.org/officeDocument/2006/relationships" xmlns:p="http://schemas.openxmlformats.org/presentationml/2006/main">
   <p:cSld>
     <p:spTree>
@@ -10490,7 +11374,7 @@
 </p:sld>
 </file>
 
-<file path=ppt/slides/slide26.xml><?xml version="1.0" encoding="utf-8"?>
+<file path=ppt/slides/slide27.xml><?xml version="1.0" encoding="utf-8"?>
 <p:sld xmlns:a="http://schemas.openxmlformats.org/drawingml/2006/main" xmlns:r="http://schemas.openxmlformats.org/officeDocument/2006/relationships" xmlns:p="http://schemas.openxmlformats.org/presentationml/2006/main">
   <p:cSld>
     <p:spTree>
@@ -10711,7 +11595,7 @@
 </p:sld>
 </file>
 
-<file path=ppt/slides/slide27.xml><?xml version="1.0" encoding="utf-8"?>
+<file path=ppt/slides/slide28.xml><?xml version="1.0" encoding="utf-8"?>
 <p:sld xmlns:a="http://schemas.openxmlformats.org/drawingml/2006/main" xmlns:r="http://schemas.openxmlformats.org/officeDocument/2006/relationships" xmlns:p="http://schemas.openxmlformats.org/presentationml/2006/main">
   <p:cSld>
     <p:spTree>
@@ -10922,7 +11806,7 @@
 </p:sld>
 </file>
 
-<file path=ppt/slides/slide28.xml><?xml version="1.0" encoding="utf-8"?>
+<file path=ppt/slides/slide29.xml><?xml version="1.0" encoding="utf-8"?>
 <p:sld xmlns:a="http://schemas.openxmlformats.org/drawingml/2006/main" xmlns:r="http://schemas.openxmlformats.org/officeDocument/2006/relationships" xmlns:p="http://schemas.openxmlformats.org/presentationml/2006/main">
   <p:cSld>
     <p:spTree>
@@ -11013,7 +11897,282 @@
 </p:sld>
 </file>
 
-<file path=ppt/slides/slide29.xml><?xml version="1.0" encoding="utf-8"?>
+<file path=ppt/slides/slide3.xml><?xml version="1.0" encoding="utf-8"?>
+<p:sld xmlns:a="http://schemas.openxmlformats.org/drawingml/2006/main" xmlns:r="http://schemas.openxmlformats.org/officeDocument/2006/relationships" xmlns:p="http://schemas.openxmlformats.org/presentationml/2006/main">
+  <p:cSld>
+    <p:spTree>
+      <p:nvGrpSpPr>
+        <p:cNvPr id="1" name=""/>
+        <p:cNvGrpSpPr/>
+        <p:nvPr/>
+      </p:nvGrpSpPr>
+      <p:grpSpPr>
+        <a:xfrm>
+          <a:off x="0" y="0"/>
+          <a:ext cx="0" cy="0"/>
+          <a:chOff x="0" y="0"/>
+          <a:chExt cx="0" cy="0"/>
+        </a:xfrm>
+      </p:grpSpPr>
+      <p:sp>
+        <p:nvSpPr>
+          <p:cNvPr id="9217" name="Title 1">
+            <a:extLst>
+              <a:ext uri="{FF2B5EF4-FFF2-40B4-BE49-F238E27FC236}">
+                <a16:creationId xmlns:a16="http://schemas.microsoft.com/office/drawing/2014/main" id="{A027E010-3CF8-2080-829B-CAEEEB369070}"/>
+              </a:ext>
+            </a:extLst>
+          </p:cNvPr>
+          <p:cNvSpPr>
+            <a:spLocks noGrp="1" noChangeArrowheads="1"/>
+          </p:cNvSpPr>
+          <p:nvPr>
+            <p:ph type="title"/>
+          </p:nvPr>
+        </p:nvSpPr>
+        <p:spPr/>
+        <p:txBody>
+          <a:bodyPr/>
+          <a:lstStyle/>
+          <a:p>
+            <a:r>
+              <a:rPr lang="en-US" altLang="sk-SK">
+                <a:ea typeface="ＭＳ Ｐゴシック" panose="020B0600070205080204" pitchFamily="34" charset="-128"/>
+              </a:rPr>
+              <a:t>Overview</a:t>
+            </a:r>
+          </a:p>
+        </p:txBody>
+      </p:sp>
+      <p:sp>
+        <p:nvSpPr>
+          <p:cNvPr id="9218" name="Content Placeholder 2">
+            <a:extLst>
+              <a:ext uri="{FF2B5EF4-FFF2-40B4-BE49-F238E27FC236}">
+                <a16:creationId xmlns:a16="http://schemas.microsoft.com/office/drawing/2014/main" id="{EED285DA-1876-63CE-DFD6-8B559DC81572}"/>
+              </a:ext>
+            </a:extLst>
+          </p:cNvPr>
+          <p:cNvSpPr>
+            <a:spLocks noGrp="1" noChangeArrowheads="1"/>
+          </p:cNvSpPr>
+          <p:nvPr>
+            <p:ph idx="1"/>
+          </p:nvPr>
+        </p:nvSpPr>
+        <p:spPr/>
+        <p:txBody>
+          <a:bodyPr/>
+          <a:lstStyle/>
+          <a:p>
+            <a:r>
+              <a:rPr lang="en-US" altLang="sk-SK">
+                <a:ea typeface="ＭＳ Ｐゴシック" panose="020B0600070205080204" pitchFamily="34" charset="-128"/>
+              </a:rPr>
+              <a:t>Fundamental idea – abstract hardware of a single computer into several different execution environments</a:t>
+            </a:r>
+          </a:p>
+          <a:p>
+            <a:pPr lvl="1"/>
+            <a:r>
+              <a:rPr lang="en-US" altLang="sk-SK">
+                <a:ea typeface="ＭＳ Ｐゴシック" panose="020B0600070205080204" pitchFamily="34" charset="-128"/>
+              </a:rPr>
+              <a:t>Similar to layered approach</a:t>
+            </a:r>
+          </a:p>
+          <a:p>
+            <a:pPr lvl="1"/>
+            <a:r>
+              <a:rPr lang="en-US" altLang="sk-SK">
+                <a:ea typeface="ＭＳ Ｐゴシック" panose="020B0600070205080204" pitchFamily="34" charset="-128"/>
+              </a:rPr>
+              <a:t>But layer creates virtual system (</a:t>
+            </a:r>
+            <a:r>
+              <a:rPr lang="en-US" altLang="sk-SK" b="1">
+                <a:solidFill>
+                  <a:srgbClr val="3366FF"/>
+                </a:solidFill>
+                <a:ea typeface="ＭＳ Ｐゴシック" panose="020B0600070205080204" pitchFamily="34" charset="-128"/>
+              </a:rPr>
+              <a:t>virtual machine</a:t>
+            </a:r>
+            <a:r>
+              <a:rPr lang="en-US" altLang="sk-SK">
+                <a:ea typeface="ＭＳ Ｐゴシック" panose="020B0600070205080204" pitchFamily="34" charset="-128"/>
+              </a:rPr>
+              <a:t>, or </a:t>
+            </a:r>
+            <a:r>
+              <a:rPr lang="en-US" altLang="sk-SK" b="1">
+                <a:solidFill>
+                  <a:srgbClr val="3366FF"/>
+                </a:solidFill>
+                <a:ea typeface="ＭＳ Ｐゴシック" panose="020B0600070205080204" pitchFamily="34" charset="-128"/>
+              </a:rPr>
+              <a:t>VM</a:t>
+            </a:r>
+            <a:r>
+              <a:rPr lang="en-US" altLang="sk-SK">
+                <a:ea typeface="ＭＳ Ｐゴシック" panose="020B0600070205080204" pitchFamily="34" charset="-128"/>
+              </a:rPr>
+              <a:t>) on which operation systems or applications can run</a:t>
+            </a:r>
+          </a:p>
+          <a:p>
+            <a:r>
+              <a:rPr lang="en-US" altLang="sk-SK">
+                <a:ea typeface="ＭＳ Ｐゴシック" panose="020B0600070205080204" pitchFamily="34" charset="-128"/>
+              </a:rPr>
+              <a:t>Several components</a:t>
+            </a:r>
+          </a:p>
+          <a:p>
+            <a:pPr lvl="1"/>
+            <a:r>
+              <a:rPr lang="en-US" altLang="sk-SK" b="1">
+                <a:solidFill>
+                  <a:srgbClr val="3366FF"/>
+                </a:solidFill>
+                <a:ea typeface="ＭＳ Ｐゴシック" panose="020B0600070205080204" pitchFamily="34" charset="-128"/>
+              </a:rPr>
+              <a:t>Host</a:t>
+            </a:r>
+            <a:r>
+              <a:rPr lang="en-US" altLang="sk-SK">
+                <a:ea typeface="ＭＳ Ｐゴシック" panose="020B0600070205080204" pitchFamily="34" charset="-128"/>
+              </a:rPr>
+              <a:t> – underlying hardware system</a:t>
+            </a:r>
+          </a:p>
+          <a:p>
+            <a:pPr lvl="1"/>
+            <a:r>
+              <a:rPr lang="en-US" altLang="sk-SK" b="1">
+                <a:solidFill>
+                  <a:srgbClr val="3366FF"/>
+                </a:solidFill>
+                <a:ea typeface="ＭＳ Ｐゴシック" panose="020B0600070205080204" pitchFamily="34" charset="-128"/>
+              </a:rPr>
+              <a:t>Virtual machine manager </a:t>
+            </a:r>
+            <a:r>
+              <a:rPr lang="en-US" altLang="sk-SK">
+                <a:ea typeface="ＭＳ Ｐゴシック" panose="020B0600070205080204" pitchFamily="34" charset="-128"/>
+              </a:rPr>
+              <a:t>(</a:t>
+            </a:r>
+            <a:r>
+              <a:rPr lang="en-US" altLang="sk-SK" b="1">
+                <a:solidFill>
+                  <a:srgbClr val="3366FF"/>
+                </a:solidFill>
+                <a:ea typeface="ＭＳ Ｐゴシック" panose="020B0600070205080204" pitchFamily="34" charset="-128"/>
+              </a:rPr>
+              <a:t>VMM</a:t>
+            </a:r>
+            <a:r>
+              <a:rPr lang="en-US" altLang="sk-SK">
+                <a:ea typeface="ＭＳ Ｐゴシック" panose="020B0600070205080204" pitchFamily="34" charset="-128"/>
+              </a:rPr>
+              <a:t>) or </a:t>
+            </a:r>
+            <a:r>
+              <a:rPr lang="en-US" altLang="sk-SK" b="1">
+                <a:solidFill>
+                  <a:srgbClr val="3366FF"/>
+                </a:solidFill>
+                <a:ea typeface="ＭＳ Ｐゴシック" panose="020B0600070205080204" pitchFamily="34" charset="-128"/>
+              </a:rPr>
+              <a:t>hypervisor</a:t>
+            </a:r>
+            <a:r>
+              <a:rPr lang="en-US" altLang="sk-SK">
+                <a:ea typeface="ＭＳ Ｐゴシック" panose="020B0600070205080204" pitchFamily="34" charset="-128"/>
+              </a:rPr>
+              <a:t> – creates and runs virtual machines by providing interface that is </a:t>
+            </a:r>
+            <a:r>
+              <a:rPr lang="en-US" altLang="sk-SK" b="1" i="1">
+                <a:ea typeface="ＭＳ Ｐゴシック" panose="020B0600070205080204" pitchFamily="34" charset="-128"/>
+              </a:rPr>
+              <a:t>identical</a:t>
+            </a:r>
+            <a:r>
+              <a:rPr lang="en-US" altLang="sk-SK">
+                <a:ea typeface="ＭＳ Ｐゴシック" panose="020B0600070205080204" pitchFamily="34" charset="-128"/>
+              </a:rPr>
+              <a:t> to the host</a:t>
+            </a:r>
+          </a:p>
+          <a:p>
+            <a:pPr lvl="2"/>
+            <a:r>
+              <a:rPr lang="en-US" altLang="sk-SK">
+                <a:ea typeface="ＭＳ Ｐゴシック" panose="020B0600070205080204" pitchFamily="34" charset="-128"/>
+              </a:rPr>
+              <a:t>(Except in the case of paravirtualization)</a:t>
+            </a:r>
+          </a:p>
+          <a:p>
+            <a:pPr lvl="1"/>
+            <a:r>
+              <a:rPr lang="en-US" altLang="sk-SK" b="1">
+                <a:solidFill>
+                  <a:srgbClr val="3366FF"/>
+                </a:solidFill>
+                <a:ea typeface="ＭＳ Ｐゴシック" panose="020B0600070205080204" pitchFamily="34" charset="-128"/>
+              </a:rPr>
+              <a:t>Guest</a:t>
+            </a:r>
+            <a:r>
+              <a:rPr lang="en-US" altLang="sk-SK">
+                <a:ea typeface="ＭＳ Ｐゴシック" panose="020B0600070205080204" pitchFamily="34" charset="-128"/>
+              </a:rPr>
+              <a:t> – process provided with virtual copy of the host</a:t>
+            </a:r>
+          </a:p>
+          <a:p>
+            <a:pPr lvl="2"/>
+            <a:r>
+              <a:rPr lang="en-US" altLang="sk-SK">
+                <a:ea typeface="ＭＳ Ｐゴシック" panose="020B0600070205080204" pitchFamily="34" charset="-128"/>
+              </a:rPr>
+              <a:t>Usually an operating system</a:t>
+            </a:r>
+          </a:p>
+          <a:p>
+            <a:r>
+              <a:rPr lang="en-US" altLang="sk-SK">
+                <a:ea typeface="ＭＳ Ｐゴシック" panose="020B0600070205080204" pitchFamily="34" charset="-128"/>
+              </a:rPr>
+              <a:t>Single physical machine can run multiple operating systems concurrently, each in its own virtual machine</a:t>
+            </a:r>
+          </a:p>
+          <a:p>
+            <a:pPr lvl="2">
+              <a:buFont typeface="Webdings" pitchFamily="2" charset="2"/>
+              <a:buNone/>
+            </a:pPr>
+            <a:r>
+              <a:rPr lang="en-US" altLang="sk-SK">
+                <a:ea typeface="ＭＳ Ｐゴシック" panose="020B0600070205080204" pitchFamily="34" charset="-128"/>
+              </a:rPr>
+              <a:t>	</a:t>
+            </a:r>
+          </a:p>
+        </p:txBody>
+      </p:sp>
+    </p:spTree>
+  </p:cSld>
+  <p:clrMapOvr>
+    <a:masterClrMapping/>
+  </p:clrMapOvr>
+</p:sld>
+</file>
+
+<file path=ppt/slides/slide30.xml><?xml version="1.0" encoding="utf-8"?>
 <p:sld xmlns:a="http://schemas.openxmlformats.org/drawingml/2006/main" xmlns:r="http://schemas.openxmlformats.org/officeDocument/2006/relationships" xmlns:p="http://schemas.openxmlformats.org/presentationml/2006/main">
   <p:cSld>
     <p:spTree>
@@ -11170,282 +12329,7 @@
 </p:sld>
 </file>
 
-<file path=ppt/slides/slide3.xml><?xml version="1.0" encoding="utf-8"?>
-<p:sld xmlns:a="http://schemas.openxmlformats.org/drawingml/2006/main" xmlns:r="http://schemas.openxmlformats.org/officeDocument/2006/relationships" xmlns:p="http://schemas.openxmlformats.org/presentationml/2006/main">
-  <p:cSld>
-    <p:spTree>
-      <p:nvGrpSpPr>
-        <p:cNvPr id="1" name=""/>
-        <p:cNvGrpSpPr/>
-        <p:nvPr/>
-      </p:nvGrpSpPr>
-      <p:grpSpPr>
-        <a:xfrm>
-          <a:off x="0" y="0"/>
-          <a:ext cx="0" cy="0"/>
-          <a:chOff x="0" y="0"/>
-          <a:chExt cx="0" cy="0"/>
-        </a:xfrm>
-      </p:grpSpPr>
-      <p:sp>
-        <p:nvSpPr>
-          <p:cNvPr id="9217" name="Title 1">
-            <a:extLst>
-              <a:ext uri="{FF2B5EF4-FFF2-40B4-BE49-F238E27FC236}">
-                <a16:creationId xmlns:a16="http://schemas.microsoft.com/office/drawing/2014/main" id="{A027E010-3CF8-2080-829B-CAEEEB369070}"/>
-              </a:ext>
-            </a:extLst>
-          </p:cNvPr>
-          <p:cNvSpPr>
-            <a:spLocks noGrp="1" noChangeArrowheads="1"/>
-          </p:cNvSpPr>
-          <p:nvPr>
-            <p:ph type="title"/>
-          </p:nvPr>
-        </p:nvSpPr>
-        <p:spPr/>
-        <p:txBody>
-          <a:bodyPr/>
-          <a:lstStyle/>
-          <a:p>
-            <a:r>
-              <a:rPr lang="en-US" altLang="sk-SK">
-                <a:ea typeface="ＭＳ Ｐゴシック" panose="020B0600070205080204" pitchFamily="34" charset="-128"/>
-              </a:rPr>
-              <a:t>Overview</a:t>
-            </a:r>
-          </a:p>
-        </p:txBody>
-      </p:sp>
-      <p:sp>
-        <p:nvSpPr>
-          <p:cNvPr id="9218" name="Content Placeholder 2">
-            <a:extLst>
-              <a:ext uri="{FF2B5EF4-FFF2-40B4-BE49-F238E27FC236}">
-                <a16:creationId xmlns:a16="http://schemas.microsoft.com/office/drawing/2014/main" id="{EED285DA-1876-63CE-DFD6-8B559DC81572}"/>
-              </a:ext>
-            </a:extLst>
-          </p:cNvPr>
-          <p:cNvSpPr>
-            <a:spLocks noGrp="1" noChangeArrowheads="1"/>
-          </p:cNvSpPr>
-          <p:nvPr>
-            <p:ph idx="1"/>
-          </p:nvPr>
-        </p:nvSpPr>
-        <p:spPr/>
-        <p:txBody>
-          <a:bodyPr/>
-          <a:lstStyle/>
-          <a:p>
-            <a:r>
-              <a:rPr lang="en-US" altLang="sk-SK">
-                <a:ea typeface="ＭＳ Ｐゴシック" panose="020B0600070205080204" pitchFamily="34" charset="-128"/>
-              </a:rPr>
-              <a:t>Fundamental idea – abstract hardware of a single computer into several different execution environments</a:t>
-            </a:r>
-          </a:p>
-          <a:p>
-            <a:pPr lvl="1"/>
-            <a:r>
-              <a:rPr lang="en-US" altLang="sk-SK">
-                <a:ea typeface="ＭＳ Ｐゴシック" panose="020B0600070205080204" pitchFamily="34" charset="-128"/>
-              </a:rPr>
-              <a:t>Similar to layered approach</a:t>
-            </a:r>
-          </a:p>
-          <a:p>
-            <a:pPr lvl="1"/>
-            <a:r>
-              <a:rPr lang="en-US" altLang="sk-SK">
-                <a:ea typeface="ＭＳ Ｐゴシック" panose="020B0600070205080204" pitchFamily="34" charset="-128"/>
-              </a:rPr>
-              <a:t>But layer creates virtual system (</a:t>
-            </a:r>
-            <a:r>
-              <a:rPr lang="en-US" altLang="sk-SK" b="1">
-                <a:solidFill>
-                  <a:srgbClr val="3366FF"/>
-                </a:solidFill>
-                <a:ea typeface="ＭＳ Ｐゴシック" panose="020B0600070205080204" pitchFamily="34" charset="-128"/>
-              </a:rPr>
-              <a:t>virtual machine</a:t>
-            </a:r>
-            <a:r>
-              <a:rPr lang="en-US" altLang="sk-SK">
-                <a:ea typeface="ＭＳ Ｐゴシック" panose="020B0600070205080204" pitchFamily="34" charset="-128"/>
-              </a:rPr>
-              <a:t>, or </a:t>
-            </a:r>
-            <a:r>
-              <a:rPr lang="en-US" altLang="sk-SK" b="1">
-                <a:solidFill>
-                  <a:srgbClr val="3366FF"/>
-                </a:solidFill>
-                <a:ea typeface="ＭＳ Ｐゴシック" panose="020B0600070205080204" pitchFamily="34" charset="-128"/>
-              </a:rPr>
-              <a:t>VM</a:t>
-            </a:r>
-            <a:r>
-              <a:rPr lang="en-US" altLang="sk-SK">
-                <a:ea typeface="ＭＳ Ｐゴシック" panose="020B0600070205080204" pitchFamily="34" charset="-128"/>
-              </a:rPr>
-              <a:t>) on which operation systems or applications can run</a:t>
-            </a:r>
-          </a:p>
-          <a:p>
-            <a:r>
-              <a:rPr lang="en-US" altLang="sk-SK">
-                <a:ea typeface="ＭＳ Ｐゴシック" panose="020B0600070205080204" pitchFamily="34" charset="-128"/>
-              </a:rPr>
-              <a:t>Several components</a:t>
-            </a:r>
-          </a:p>
-          <a:p>
-            <a:pPr lvl="1"/>
-            <a:r>
-              <a:rPr lang="en-US" altLang="sk-SK" b="1">
-                <a:solidFill>
-                  <a:srgbClr val="3366FF"/>
-                </a:solidFill>
-                <a:ea typeface="ＭＳ Ｐゴシック" panose="020B0600070205080204" pitchFamily="34" charset="-128"/>
-              </a:rPr>
-              <a:t>Host</a:t>
-            </a:r>
-            <a:r>
-              <a:rPr lang="en-US" altLang="sk-SK">
-                <a:ea typeface="ＭＳ Ｐゴシック" panose="020B0600070205080204" pitchFamily="34" charset="-128"/>
-              </a:rPr>
-              <a:t> – underlying hardware system</a:t>
-            </a:r>
-          </a:p>
-          <a:p>
-            <a:pPr lvl="1"/>
-            <a:r>
-              <a:rPr lang="en-US" altLang="sk-SK" b="1">
-                <a:solidFill>
-                  <a:srgbClr val="3366FF"/>
-                </a:solidFill>
-                <a:ea typeface="ＭＳ Ｐゴシック" panose="020B0600070205080204" pitchFamily="34" charset="-128"/>
-              </a:rPr>
-              <a:t>Virtual machine manager </a:t>
-            </a:r>
-            <a:r>
-              <a:rPr lang="en-US" altLang="sk-SK">
-                <a:ea typeface="ＭＳ Ｐゴシック" panose="020B0600070205080204" pitchFamily="34" charset="-128"/>
-              </a:rPr>
-              <a:t>(</a:t>
-            </a:r>
-            <a:r>
-              <a:rPr lang="en-US" altLang="sk-SK" b="1">
-                <a:solidFill>
-                  <a:srgbClr val="3366FF"/>
-                </a:solidFill>
-                <a:ea typeface="ＭＳ Ｐゴシック" panose="020B0600070205080204" pitchFamily="34" charset="-128"/>
-              </a:rPr>
-              <a:t>VMM</a:t>
-            </a:r>
-            <a:r>
-              <a:rPr lang="en-US" altLang="sk-SK">
-                <a:ea typeface="ＭＳ Ｐゴシック" panose="020B0600070205080204" pitchFamily="34" charset="-128"/>
-              </a:rPr>
-              <a:t>) or </a:t>
-            </a:r>
-            <a:r>
-              <a:rPr lang="en-US" altLang="sk-SK" b="1">
-                <a:solidFill>
-                  <a:srgbClr val="3366FF"/>
-                </a:solidFill>
-                <a:ea typeface="ＭＳ Ｐゴシック" panose="020B0600070205080204" pitchFamily="34" charset="-128"/>
-              </a:rPr>
-              <a:t>hypervisor</a:t>
-            </a:r>
-            <a:r>
-              <a:rPr lang="en-US" altLang="sk-SK">
-                <a:ea typeface="ＭＳ Ｐゴシック" panose="020B0600070205080204" pitchFamily="34" charset="-128"/>
-              </a:rPr>
-              <a:t> – creates and runs virtual machines by providing interface that is </a:t>
-            </a:r>
-            <a:r>
-              <a:rPr lang="en-US" altLang="sk-SK" b="1" i="1">
-                <a:ea typeface="ＭＳ Ｐゴシック" panose="020B0600070205080204" pitchFamily="34" charset="-128"/>
-              </a:rPr>
-              <a:t>identical</a:t>
-            </a:r>
-            <a:r>
-              <a:rPr lang="en-US" altLang="sk-SK">
-                <a:ea typeface="ＭＳ Ｐゴシック" panose="020B0600070205080204" pitchFamily="34" charset="-128"/>
-              </a:rPr>
-              <a:t> to the host</a:t>
-            </a:r>
-          </a:p>
-          <a:p>
-            <a:pPr lvl="2"/>
-            <a:r>
-              <a:rPr lang="en-US" altLang="sk-SK">
-                <a:ea typeface="ＭＳ Ｐゴシック" panose="020B0600070205080204" pitchFamily="34" charset="-128"/>
-              </a:rPr>
-              <a:t>(Except in the case of paravirtualization)</a:t>
-            </a:r>
-          </a:p>
-          <a:p>
-            <a:pPr lvl="1"/>
-            <a:r>
-              <a:rPr lang="en-US" altLang="sk-SK" b="1">
-                <a:solidFill>
-                  <a:srgbClr val="3366FF"/>
-                </a:solidFill>
-                <a:ea typeface="ＭＳ Ｐゴシック" panose="020B0600070205080204" pitchFamily="34" charset="-128"/>
-              </a:rPr>
-              <a:t>Guest</a:t>
-            </a:r>
-            <a:r>
-              <a:rPr lang="en-US" altLang="sk-SK">
-                <a:ea typeface="ＭＳ Ｐゴシック" panose="020B0600070205080204" pitchFamily="34" charset="-128"/>
-              </a:rPr>
-              <a:t> – process provided with virtual copy of the host</a:t>
-            </a:r>
-          </a:p>
-          <a:p>
-            <a:pPr lvl="2"/>
-            <a:r>
-              <a:rPr lang="en-US" altLang="sk-SK">
-                <a:ea typeface="ＭＳ Ｐゴシック" panose="020B0600070205080204" pitchFamily="34" charset="-128"/>
-              </a:rPr>
-              <a:t>Usually an operating system</a:t>
-            </a:r>
-          </a:p>
-          <a:p>
-            <a:r>
-              <a:rPr lang="en-US" altLang="sk-SK">
-                <a:ea typeface="ＭＳ Ｐゴシック" panose="020B0600070205080204" pitchFamily="34" charset="-128"/>
-              </a:rPr>
-              <a:t>Single physical machine can run multiple operating systems concurrently, each in its own virtual machine</a:t>
-            </a:r>
-          </a:p>
-          <a:p>
-            <a:pPr lvl="2">
-              <a:buFont typeface="Webdings" pitchFamily="2" charset="2"/>
-              <a:buNone/>
-            </a:pPr>
-            <a:r>
-              <a:rPr lang="en-US" altLang="sk-SK">
-                <a:ea typeface="ＭＳ Ｐゴシック" panose="020B0600070205080204" pitchFamily="34" charset="-128"/>
-              </a:rPr>
-              <a:t>	</a:t>
-            </a:r>
-          </a:p>
-        </p:txBody>
-      </p:sp>
-    </p:spTree>
-  </p:cSld>
-  <p:clrMapOvr>
-    <a:masterClrMapping/>
-  </p:clrMapOvr>
-</p:sld>
-</file>
-
-<file path=ppt/slides/slide30.xml><?xml version="1.0" encoding="utf-8"?>
+<file path=ppt/slides/slide31.xml><?xml version="1.0" encoding="utf-8"?>
 <p:sld xmlns:a="http://schemas.openxmlformats.org/drawingml/2006/main" xmlns:r="http://schemas.openxmlformats.org/officeDocument/2006/relationships" xmlns:p="http://schemas.openxmlformats.org/presentationml/2006/main">
   <p:cSld>
     <p:spTree>
@@ -11689,7 +12573,7 @@
 </p:sld>
 </file>
 
-<file path=ppt/slides/slide31.xml><?xml version="1.0" encoding="utf-8"?>
+<file path=ppt/slides/slide32.xml><?xml version="1.0" encoding="utf-8"?>
 <p:sld xmlns:a="http://schemas.openxmlformats.org/drawingml/2006/main" xmlns:r="http://schemas.openxmlformats.org/officeDocument/2006/relationships" xmlns:p="http://schemas.openxmlformats.org/presentationml/2006/main">
   <p:cSld>
     <p:spTree>
@@ -11882,7 +12766,7 @@
 </p:sld>
 </file>
 
-<file path=ppt/slides/slide32.xml><?xml version="1.0" encoding="utf-8"?>
+<file path=ppt/slides/slide33.xml><?xml version="1.0" encoding="utf-8"?>
 <p:sld xmlns:a="http://schemas.openxmlformats.org/drawingml/2006/main" xmlns:r="http://schemas.openxmlformats.org/officeDocument/2006/relationships" xmlns:p="http://schemas.openxmlformats.org/presentationml/2006/main">
   <p:cSld>
     <p:spTree>
@@ -12125,7 +13009,7 @@
 </p:sld>
 </file>
 
-<file path=ppt/slides/slide33.xml><?xml version="1.0" encoding="utf-8"?>
+<file path=ppt/slides/slide34.xml><?xml version="1.0" encoding="utf-8"?>
 <p:sld xmlns:a="http://schemas.openxmlformats.org/drawingml/2006/main" xmlns:r="http://schemas.openxmlformats.org/officeDocument/2006/relationships" xmlns:p="http://schemas.openxmlformats.org/presentationml/2006/main">
   <p:cSld>
     <p:spTree>
@@ -12216,7 +13100,7 @@
 </p:sld>
 </file>
 
-<file path=ppt/slides/slide34.xml><?xml version="1.0" encoding="utf-8"?>
+<file path=ppt/slides/slide35.xml><?xml version="1.0" encoding="utf-8"?>
 <p:sld xmlns:a="http://schemas.openxmlformats.org/drawingml/2006/main" xmlns:r="http://schemas.openxmlformats.org/officeDocument/2006/relationships" xmlns:p="http://schemas.openxmlformats.org/presentationml/2006/main">
   <p:cSld>
     <p:spTree>
@@ -12402,7 +13286,7 @@
 </p:sld>
 </file>
 
-<file path=ppt/slides/slide35.xml><?xml version="1.0" encoding="utf-8"?>
+<file path=ppt/slides/slide36.xml><?xml version="1.0" encoding="utf-8"?>
 <p:sld xmlns:a="http://schemas.openxmlformats.org/drawingml/2006/main" xmlns:r="http://schemas.openxmlformats.org/officeDocument/2006/relationships" xmlns:p="http://schemas.openxmlformats.org/presentationml/2006/main">
   <p:cSld>
     <p:spTree>
@@ -12640,7 +13524,7 @@
 </p:sld>
 </file>
 
-<file path=ppt/slides/slide36.xml><?xml version="1.0" encoding="utf-8"?>
+<file path=ppt/slides/slide37.xml><?xml version="1.0" encoding="utf-8"?>
 <p:sld xmlns:a="http://schemas.openxmlformats.org/drawingml/2006/main" xmlns:r="http://schemas.openxmlformats.org/officeDocument/2006/relationships" xmlns:p="http://schemas.openxmlformats.org/presentationml/2006/main">
   <p:cSld>
     <p:spTree>
@@ -12790,6 +13674,15 @@
                 <a:ea typeface="ＭＳ Ｐゴシック" panose="020B0600070205080204" pitchFamily="34" charset="-128"/>
               </a:rPr>
               <a:t>provide other integration features</a:t>
+            </a:r>
+          </a:p>
+          <a:p>
+            <a:pPr lvl="2"/>
+            <a:r>
+              <a:rPr lang="en-US" altLang="sk-SK" b="1" dirty="0">
+                <a:ea typeface="ＭＳ Ｐゴシック" panose="020B0600070205080204" pitchFamily="34" charset="-128"/>
+              </a:rPr>
+              <a:t>Oracle Virtual Box extensions …</a:t>
             </a:r>
           </a:p>
         </p:txBody>
@@ -12873,7 +13766,7 @@
 </p:sld>
 </file>
 
-<file path=ppt/slides/slide37.xml><?xml version="1.0" encoding="utf-8"?>
+<file path=ppt/slides/slide38.xml><?xml version="1.0" encoding="utf-8"?>
 <p:sld xmlns:a="http://schemas.openxmlformats.org/drawingml/2006/main" xmlns:r="http://schemas.openxmlformats.org/officeDocument/2006/relationships" xmlns:p="http://schemas.openxmlformats.org/presentationml/2006/main">
   <p:cSld>
     <p:spTree>
@@ -13119,7 +14012,7 @@
 </p:sld>
 </file>
 
-<file path=ppt/slides/slide38.xml><?xml version="1.0" encoding="utf-8"?>
+<file path=ppt/slides/slide39.xml><?xml version="1.0" encoding="utf-8"?>
 <p:sld xmlns:a="http://schemas.openxmlformats.org/drawingml/2006/main" xmlns:r="http://schemas.openxmlformats.org/officeDocument/2006/relationships" xmlns:p="http://schemas.openxmlformats.org/presentationml/2006/main">
   <p:cSld>
     <p:spTree>
@@ -13424,243 +14317,6 @@
               <a:latin typeface="Courier New"/>
               <a:ea typeface="ＭＳ Ｐゴシック" charset="0"/>
               <a:cs typeface="Courier New"/>
-            </a:endParaRPr>
-          </a:p>
-        </p:txBody>
-      </p:sp>
-    </p:spTree>
-  </p:cSld>
-  <p:clrMapOvr>
-    <a:masterClrMapping/>
-  </p:clrMapOvr>
-</p:sld>
-</file>
-
-<file path=ppt/slides/slide39.xml><?xml version="1.0" encoding="utf-8"?>
-<p:sld xmlns:a="http://schemas.openxmlformats.org/drawingml/2006/main" xmlns:r="http://schemas.openxmlformats.org/officeDocument/2006/relationships" xmlns:p="http://schemas.openxmlformats.org/presentationml/2006/main">
-  <p:cSld>
-    <p:spTree>
-      <p:nvGrpSpPr>
-        <p:cNvPr id="1" name=""/>
-        <p:cNvGrpSpPr/>
-        <p:nvPr/>
-      </p:nvGrpSpPr>
-      <p:grpSpPr>
-        <a:xfrm>
-          <a:off x="0" y="0"/>
-          <a:ext cx="0" cy="0"/>
-          <a:chOff x="0" y="0"/>
-          <a:chExt cx="0" cy="0"/>
-        </a:xfrm>
-      </p:grpSpPr>
-      <p:sp>
-        <p:nvSpPr>
-          <p:cNvPr id="46081" name="Title 1">
-            <a:extLst>
-              <a:ext uri="{FF2B5EF4-FFF2-40B4-BE49-F238E27FC236}">
-                <a16:creationId xmlns:a16="http://schemas.microsoft.com/office/drawing/2014/main" id="{2BF321BF-584F-53C8-2B85-9D77C2A2F2D6}"/>
-              </a:ext>
-            </a:extLst>
-          </p:cNvPr>
-          <p:cNvSpPr>
-            <a:spLocks noGrp="1" noChangeArrowheads="1"/>
-          </p:cNvSpPr>
-          <p:nvPr>
-            <p:ph type="title"/>
-          </p:nvPr>
-        </p:nvSpPr>
-        <p:spPr>
-          <a:xfrm>
-            <a:off x="671513" y="277813"/>
-            <a:ext cx="8229600" cy="576262"/>
-          </a:xfrm>
-        </p:spPr>
-        <p:txBody>
-          <a:bodyPr/>
-          <a:lstStyle/>
-          <a:p>
-            <a:r>
-              <a:rPr lang="en-US" altLang="sk-SK" sz="2400">
-                <a:ea typeface="ＭＳ Ｐゴシック" panose="020B0600070205080204" pitchFamily="34" charset="-128"/>
-              </a:rPr>
-              <a:t>OS Component – Storage Management</a:t>
-            </a:r>
-          </a:p>
-        </p:txBody>
-      </p:sp>
-      <p:sp>
-        <p:nvSpPr>
-          <p:cNvPr id="46082" name="Content Placeholder 2">
-            <a:extLst>
-              <a:ext uri="{FF2B5EF4-FFF2-40B4-BE49-F238E27FC236}">
-                <a16:creationId xmlns:a16="http://schemas.microsoft.com/office/drawing/2014/main" id="{2CF04D7C-020E-B1B7-D42A-C40AF80EB94C}"/>
-              </a:ext>
-            </a:extLst>
-          </p:cNvPr>
-          <p:cNvSpPr>
-            <a:spLocks noGrp="1" noChangeArrowheads="1"/>
-          </p:cNvSpPr>
-          <p:nvPr>
-            <p:ph idx="1"/>
-          </p:nvPr>
-        </p:nvSpPr>
-        <p:spPr/>
-        <p:txBody>
-          <a:bodyPr/>
-          <a:lstStyle/>
-          <a:p>
-            <a:r>
-              <a:rPr lang="en-US" altLang="sk-SK">
-                <a:ea typeface="ＭＳ Ｐゴシック" panose="020B0600070205080204" pitchFamily="34" charset="-128"/>
-              </a:rPr>
-              <a:t>Both boot disk and general data access need  be provided by VMM</a:t>
-            </a:r>
-          </a:p>
-          <a:p>
-            <a:r>
-              <a:rPr lang="en-US" altLang="sk-SK">
-                <a:ea typeface="ＭＳ Ｐゴシック" panose="020B0600070205080204" pitchFamily="34" charset="-128"/>
-              </a:rPr>
-              <a:t>Need to support potentially dozens of guests per VMM (so standard disk partitioning not sufficient)</a:t>
-            </a:r>
-          </a:p>
-          <a:p>
-            <a:r>
-              <a:rPr lang="en-US" altLang="sk-SK">
-                <a:ea typeface="ＭＳ Ｐゴシック" panose="020B0600070205080204" pitchFamily="34" charset="-128"/>
-              </a:rPr>
-              <a:t>Type 1 – storage guest root disks and config information within file system provided by VMM as a </a:t>
-            </a:r>
-            <a:r>
-              <a:rPr lang="en-US" altLang="sk-SK" b="1">
-                <a:solidFill>
-                  <a:srgbClr val="3366FF"/>
-                </a:solidFill>
-                <a:ea typeface="ＭＳ Ｐゴシック" panose="020B0600070205080204" pitchFamily="34" charset="-128"/>
-              </a:rPr>
-              <a:t>disk image</a:t>
-            </a:r>
-          </a:p>
-          <a:p>
-            <a:r>
-              <a:rPr lang="en-US" altLang="sk-SK">
-                <a:ea typeface="ＭＳ Ｐゴシック" panose="020B0600070205080204" pitchFamily="34" charset="-128"/>
-              </a:rPr>
-              <a:t>Type 2 – store as files in file system provided by host OS</a:t>
-            </a:r>
-          </a:p>
-          <a:p>
-            <a:r>
-              <a:rPr lang="en-US" altLang="sk-SK">
-                <a:ea typeface="ＭＳ Ｐゴシック" panose="020B0600070205080204" pitchFamily="34" charset="-128"/>
-              </a:rPr>
-              <a:t>Duplicate file -&gt; create new guest</a:t>
-            </a:r>
-          </a:p>
-          <a:p>
-            <a:r>
-              <a:rPr lang="en-US" altLang="sk-SK">
-                <a:ea typeface="ＭＳ Ｐゴシック" panose="020B0600070205080204" pitchFamily="34" charset="-128"/>
-              </a:rPr>
-              <a:t>Move file to another system -&gt; move guest</a:t>
-            </a:r>
-          </a:p>
-          <a:p>
-            <a:r>
-              <a:rPr lang="en-US" altLang="sk-SK" b="1">
-                <a:solidFill>
-                  <a:srgbClr val="3366FF"/>
-                </a:solidFill>
-                <a:ea typeface="ＭＳ Ｐゴシック" panose="020B0600070205080204" pitchFamily="34" charset="-128"/>
-              </a:rPr>
-              <a:t>Physical-to-virtual </a:t>
-            </a:r>
-            <a:r>
-              <a:rPr lang="en-US" altLang="sk-SK">
-                <a:ea typeface="ＭＳ Ｐゴシック" panose="020B0600070205080204" pitchFamily="34" charset="-128"/>
-              </a:rPr>
-              <a:t>(</a:t>
-            </a:r>
-            <a:r>
-              <a:rPr lang="en-US" altLang="sk-SK" b="1">
-                <a:solidFill>
-                  <a:srgbClr val="3366FF"/>
-                </a:solidFill>
-                <a:ea typeface="ＭＳ Ｐゴシック" panose="020B0600070205080204" pitchFamily="34" charset="-128"/>
-              </a:rPr>
-              <a:t>P-to-V</a:t>
-            </a:r>
-            <a:r>
-              <a:rPr lang="en-US" altLang="sk-SK">
-                <a:ea typeface="ＭＳ Ｐゴシック" panose="020B0600070205080204" pitchFamily="34" charset="-128"/>
-              </a:rPr>
-              <a:t>) convert native disk blocks into VMM format</a:t>
-            </a:r>
-          </a:p>
-          <a:p>
-            <a:r>
-              <a:rPr lang="en-US" altLang="sk-SK" b="1">
-                <a:solidFill>
-                  <a:srgbClr val="3366FF"/>
-                </a:solidFill>
-                <a:ea typeface="ＭＳ Ｐゴシック" panose="020B0600070205080204" pitchFamily="34" charset="-128"/>
-              </a:rPr>
-              <a:t>Virtual-to-physical </a:t>
-            </a:r>
-            <a:r>
-              <a:rPr lang="en-US" altLang="sk-SK">
-                <a:ea typeface="ＭＳ Ｐゴシック" panose="020B0600070205080204" pitchFamily="34" charset="-128"/>
-              </a:rPr>
-              <a:t>(</a:t>
-            </a:r>
-            <a:r>
-              <a:rPr lang="en-US" altLang="sk-SK" b="1">
-                <a:solidFill>
-                  <a:srgbClr val="3366FF"/>
-                </a:solidFill>
-                <a:ea typeface="ＭＳ Ｐゴシック" panose="020B0600070205080204" pitchFamily="34" charset="-128"/>
-              </a:rPr>
-              <a:t>V-to-P</a:t>
-            </a:r>
-            <a:r>
-              <a:rPr lang="en-US" altLang="sk-SK">
-                <a:ea typeface="ＭＳ Ｐゴシック" panose="020B0600070205080204" pitchFamily="34" charset="-128"/>
-              </a:rPr>
-              <a:t>) convert from virtual format to native or disk format</a:t>
-            </a:r>
-          </a:p>
-          <a:p>
-            <a:r>
-              <a:rPr lang="en-US" altLang="sk-SK">
-                <a:ea typeface="ＭＳ Ｐゴシック" panose="020B0600070205080204" pitchFamily="34" charset="-128"/>
-              </a:rPr>
-              <a:t>VMM also needs to provide access to network attached storage (just networking) and other disk images, disk partitions, disks, etc</a:t>
-            </a:r>
-          </a:p>
-          <a:p>
-            <a:pPr marL="457200" lvl="1" indent="0">
-              <a:buFont typeface="Monotype Sorts" pitchFamily="2" charset="2"/>
-              <a:buNone/>
-            </a:pPr>
-            <a:endParaRPr lang="en-US" altLang="sk-SK">
-              <a:ea typeface="ＭＳ Ｐゴシック" panose="020B0600070205080204" pitchFamily="34" charset="-128"/>
-            </a:endParaRPr>
-          </a:p>
-          <a:p>
-            <a:pPr lvl="2"/>
-            <a:endParaRPr lang="en-US" altLang="sk-SK">
-              <a:ea typeface="ＭＳ Ｐゴシック" panose="020B0600070205080204" pitchFamily="34" charset="-128"/>
-            </a:endParaRPr>
-          </a:p>
-          <a:p>
-            <a:pPr>
-              <a:buFont typeface="Monotype Sorts" pitchFamily="2" charset="2"/>
-              <a:buNone/>
-            </a:pPr>
-            <a:endParaRPr lang="en-US" altLang="sk-SK">
-              <a:latin typeface="Courier New" panose="02070309020205020404" pitchFamily="49" charset="0"/>
-              <a:ea typeface="ＭＳ Ｐゴシック" panose="020B0600070205080204" pitchFamily="34" charset="-128"/>
-              <a:cs typeface="Courier New" panose="02070309020205020404" pitchFamily="49" charset="0"/>
             </a:endParaRPr>
           </a:p>
         </p:txBody>
@@ -14261,6 +14917,243 @@
       </p:grpSpPr>
       <p:sp>
         <p:nvSpPr>
+          <p:cNvPr id="46081" name="Title 1">
+            <a:extLst>
+              <a:ext uri="{FF2B5EF4-FFF2-40B4-BE49-F238E27FC236}">
+                <a16:creationId xmlns:a16="http://schemas.microsoft.com/office/drawing/2014/main" id="{2BF321BF-584F-53C8-2B85-9D77C2A2F2D6}"/>
+              </a:ext>
+            </a:extLst>
+          </p:cNvPr>
+          <p:cNvSpPr>
+            <a:spLocks noGrp="1" noChangeArrowheads="1"/>
+          </p:cNvSpPr>
+          <p:nvPr>
+            <p:ph type="title"/>
+          </p:nvPr>
+        </p:nvSpPr>
+        <p:spPr>
+          <a:xfrm>
+            <a:off x="671513" y="277813"/>
+            <a:ext cx="8229600" cy="576262"/>
+          </a:xfrm>
+        </p:spPr>
+        <p:txBody>
+          <a:bodyPr/>
+          <a:lstStyle/>
+          <a:p>
+            <a:r>
+              <a:rPr lang="en-US" altLang="sk-SK" sz="2400">
+                <a:ea typeface="ＭＳ Ｐゴシック" panose="020B0600070205080204" pitchFamily="34" charset="-128"/>
+              </a:rPr>
+              <a:t>OS Component – Storage Management</a:t>
+            </a:r>
+          </a:p>
+        </p:txBody>
+      </p:sp>
+      <p:sp>
+        <p:nvSpPr>
+          <p:cNvPr id="46082" name="Content Placeholder 2">
+            <a:extLst>
+              <a:ext uri="{FF2B5EF4-FFF2-40B4-BE49-F238E27FC236}">
+                <a16:creationId xmlns:a16="http://schemas.microsoft.com/office/drawing/2014/main" id="{2CF04D7C-020E-B1B7-D42A-C40AF80EB94C}"/>
+              </a:ext>
+            </a:extLst>
+          </p:cNvPr>
+          <p:cNvSpPr>
+            <a:spLocks noGrp="1" noChangeArrowheads="1"/>
+          </p:cNvSpPr>
+          <p:nvPr>
+            <p:ph idx="1"/>
+          </p:nvPr>
+        </p:nvSpPr>
+        <p:spPr/>
+        <p:txBody>
+          <a:bodyPr/>
+          <a:lstStyle/>
+          <a:p>
+            <a:r>
+              <a:rPr lang="en-US" altLang="sk-SK">
+                <a:ea typeface="ＭＳ Ｐゴシック" panose="020B0600070205080204" pitchFamily="34" charset="-128"/>
+              </a:rPr>
+              <a:t>Both boot disk and general data access need  be provided by VMM</a:t>
+            </a:r>
+          </a:p>
+          <a:p>
+            <a:r>
+              <a:rPr lang="en-US" altLang="sk-SK">
+                <a:ea typeface="ＭＳ Ｐゴシック" panose="020B0600070205080204" pitchFamily="34" charset="-128"/>
+              </a:rPr>
+              <a:t>Need to support potentially dozens of guests per VMM (so standard disk partitioning not sufficient)</a:t>
+            </a:r>
+          </a:p>
+          <a:p>
+            <a:r>
+              <a:rPr lang="en-US" altLang="sk-SK">
+                <a:ea typeface="ＭＳ Ｐゴシック" panose="020B0600070205080204" pitchFamily="34" charset="-128"/>
+              </a:rPr>
+              <a:t>Type 1 – storage guest root disks and config information within file system provided by VMM as a </a:t>
+            </a:r>
+            <a:r>
+              <a:rPr lang="en-US" altLang="sk-SK" b="1">
+                <a:solidFill>
+                  <a:srgbClr val="3366FF"/>
+                </a:solidFill>
+                <a:ea typeface="ＭＳ Ｐゴシック" panose="020B0600070205080204" pitchFamily="34" charset="-128"/>
+              </a:rPr>
+              <a:t>disk image</a:t>
+            </a:r>
+          </a:p>
+          <a:p>
+            <a:r>
+              <a:rPr lang="en-US" altLang="sk-SK">
+                <a:ea typeface="ＭＳ Ｐゴシック" panose="020B0600070205080204" pitchFamily="34" charset="-128"/>
+              </a:rPr>
+              <a:t>Type 2 – store as files in file system provided by host OS</a:t>
+            </a:r>
+          </a:p>
+          <a:p>
+            <a:r>
+              <a:rPr lang="en-US" altLang="sk-SK">
+                <a:ea typeface="ＭＳ Ｐゴシック" panose="020B0600070205080204" pitchFamily="34" charset="-128"/>
+              </a:rPr>
+              <a:t>Duplicate file -&gt; create new guest</a:t>
+            </a:r>
+          </a:p>
+          <a:p>
+            <a:r>
+              <a:rPr lang="en-US" altLang="sk-SK">
+                <a:ea typeface="ＭＳ Ｐゴシック" panose="020B0600070205080204" pitchFamily="34" charset="-128"/>
+              </a:rPr>
+              <a:t>Move file to another system -&gt; move guest</a:t>
+            </a:r>
+          </a:p>
+          <a:p>
+            <a:r>
+              <a:rPr lang="en-US" altLang="sk-SK" b="1">
+                <a:solidFill>
+                  <a:srgbClr val="3366FF"/>
+                </a:solidFill>
+                <a:ea typeface="ＭＳ Ｐゴシック" panose="020B0600070205080204" pitchFamily="34" charset="-128"/>
+              </a:rPr>
+              <a:t>Physical-to-virtual </a:t>
+            </a:r>
+            <a:r>
+              <a:rPr lang="en-US" altLang="sk-SK">
+                <a:ea typeface="ＭＳ Ｐゴシック" panose="020B0600070205080204" pitchFamily="34" charset="-128"/>
+              </a:rPr>
+              <a:t>(</a:t>
+            </a:r>
+            <a:r>
+              <a:rPr lang="en-US" altLang="sk-SK" b="1">
+                <a:solidFill>
+                  <a:srgbClr val="3366FF"/>
+                </a:solidFill>
+                <a:ea typeface="ＭＳ Ｐゴシック" panose="020B0600070205080204" pitchFamily="34" charset="-128"/>
+              </a:rPr>
+              <a:t>P-to-V</a:t>
+            </a:r>
+            <a:r>
+              <a:rPr lang="en-US" altLang="sk-SK">
+                <a:ea typeface="ＭＳ Ｐゴシック" panose="020B0600070205080204" pitchFamily="34" charset="-128"/>
+              </a:rPr>
+              <a:t>) convert native disk blocks into VMM format</a:t>
+            </a:r>
+          </a:p>
+          <a:p>
+            <a:r>
+              <a:rPr lang="en-US" altLang="sk-SK" b="1">
+                <a:solidFill>
+                  <a:srgbClr val="3366FF"/>
+                </a:solidFill>
+                <a:ea typeface="ＭＳ Ｐゴシック" panose="020B0600070205080204" pitchFamily="34" charset="-128"/>
+              </a:rPr>
+              <a:t>Virtual-to-physical </a:t>
+            </a:r>
+            <a:r>
+              <a:rPr lang="en-US" altLang="sk-SK">
+                <a:ea typeface="ＭＳ Ｐゴシック" panose="020B0600070205080204" pitchFamily="34" charset="-128"/>
+              </a:rPr>
+              <a:t>(</a:t>
+            </a:r>
+            <a:r>
+              <a:rPr lang="en-US" altLang="sk-SK" b="1">
+                <a:solidFill>
+                  <a:srgbClr val="3366FF"/>
+                </a:solidFill>
+                <a:ea typeface="ＭＳ Ｐゴシック" panose="020B0600070205080204" pitchFamily="34" charset="-128"/>
+              </a:rPr>
+              <a:t>V-to-P</a:t>
+            </a:r>
+            <a:r>
+              <a:rPr lang="en-US" altLang="sk-SK">
+                <a:ea typeface="ＭＳ Ｐゴシック" panose="020B0600070205080204" pitchFamily="34" charset="-128"/>
+              </a:rPr>
+              <a:t>) convert from virtual format to native or disk format</a:t>
+            </a:r>
+          </a:p>
+          <a:p>
+            <a:r>
+              <a:rPr lang="en-US" altLang="sk-SK">
+                <a:ea typeface="ＭＳ Ｐゴシック" panose="020B0600070205080204" pitchFamily="34" charset="-128"/>
+              </a:rPr>
+              <a:t>VMM also needs to provide access to network attached storage (just networking) and other disk images, disk partitions, disks, etc</a:t>
+            </a:r>
+          </a:p>
+          <a:p>
+            <a:pPr marL="457200" lvl="1" indent="0">
+              <a:buFont typeface="Monotype Sorts" pitchFamily="2" charset="2"/>
+              <a:buNone/>
+            </a:pPr>
+            <a:endParaRPr lang="en-US" altLang="sk-SK">
+              <a:ea typeface="ＭＳ Ｐゴシック" panose="020B0600070205080204" pitchFamily="34" charset="-128"/>
+            </a:endParaRPr>
+          </a:p>
+          <a:p>
+            <a:pPr lvl="2"/>
+            <a:endParaRPr lang="en-US" altLang="sk-SK">
+              <a:ea typeface="ＭＳ Ｐゴシック" panose="020B0600070205080204" pitchFamily="34" charset="-128"/>
+            </a:endParaRPr>
+          </a:p>
+          <a:p>
+            <a:pPr>
+              <a:buFont typeface="Monotype Sorts" pitchFamily="2" charset="2"/>
+              <a:buNone/>
+            </a:pPr>
+            <a:endParaRPr lang="en-US" altLang="sk-SK">
+              <a:latin typeface="Courier New" panose="02070309020205020404" pitchFamily="49" charset="0"/>
+              <a:ea typeface="ＭＳ Ｐゴシック" panose="020B0600070205080204" pitchFamily="34" charset="-128"/>
+              <a:cs typeface="Courier New" panose="02070309020205020404" pitchFamily="49" charset="0"/>
+            </a:endParaRPr>
+          </a:p>
+        </p:txBody>
+      </p:sp>
+    </p:spTree>
+  </p:cSld>
+  <p:clrMapOvr>
+    <a:masterClrMapping/>
+  </p:clrMapOvr>
+</p:sld>
+</file>
+
+<file path=ppt/slides/slide41.xml><?xml version="1.0" encoding="utf-8"?>
+<p:sld xmlns:a="http://schemas.openxmlformats.org/drawingml/2006/main" xmlns:r="http://schemas.openxmlformats.org/officeDocument/2006/relationships" xmlns:p="http://schemas.openxmlformats.org/presentationml/2006/main">
+  <p:cSld>
+    <p:spTree>
+      <p:nvGrpSpPr>
+        <p:cNvPr id="1" name=""/>
+        <p:cNvGrpSpPr/>
+        <p:nvPr/>
+      </p:nvGrpSpPr>
+      <p:grpSpPr>
+        <a:xfrm>
+          <a:off x="0" y="0"/>
+          <a:ext cx="0" cy="0"/>
+          <a:chOff x="0" y="0"/>
+          <a:chExt cx="0" cy="0"/>
+        </a:xfrm>
+      </p:grpSpPr>
+      <p:sp>
+        <p:nvSpPr>
           <p:cNvPr id="47105" name="Title 1">
             <a:extLst>
               <a:ext uri="{FF2B5EF4-FFF2-40B4-BE49-F238E27FC236}">
@@ -14458,7 +15351,7 @@
 </p:sld>
 </file>
 
-<file path=ppt/slides/slide41.xml><?xml version="1.0" encoding="utf-8"?>
+<file path=ppt/slides/slide42.xml><?xml version="1.0" encoding="utf-8"?>
 <p:sld xmlns:a="http://schemas.openxmlformats.org/drawingml/2006/main" xmlns:r="http://schemas.openxmlformats.org/officeDocument/2006/relationships" xmlns:p="http://schemas.openxmlformats.org/presentationml/2006/main">
   <p:cSld>
     <p:spTree>
@@ -14554,7 +15447,7 @@
 </p:sld>
 </file>
 
-<file path=ppt/slides/slide42.xml><?xml version="1.0" encoding="utf-8"?>
+<file path=ppt/slides/slide43.xml><?xml version="1.0" encoding="utf-8"?>
 <p:sld xmlns:a="http://schemas.openxmlformats.org/drawingml/2006/main" xmlns:r="http://schemas.openxmlformats.org/officeDocument/2006/relationships" xmlns:p="http://schemas.openxmlformats.org/presentationml/2006/main">
   <p:cSld>
     <p:spTree>
@@ -14659,8 +15552,17 @@
               <a:rPr lang="en-US" dirty="0">
                 <a:ea typeface="ＭＳ Ｐゴシック" charset="0"/>
               </a:rPr>
-              <a:t>Runs as application on other native, installed host operating system -&gt; Type 2</a:t>
-            </a:r>
+              <a:t>Runs as application on other native, installed host operating system -&gt; Type </a:t>
+            </a:r>
+            <a:r>
+              <a:rPr lang="en-US">
+                <a:ea typeface="ＭＳ Ｐゴシック" charset="0"/>
+              </a:rPr>
+              <a:t>2 hypervisor</a:t>
+            </a:r>
+            <a:endParaRPr lang="en-US" dirty="0">
+              <a:ea typeface="ＭＳ Ｐゴシック" charset="0"/>
+            </a:endParaRPr>
           </a:p>
           <a:p>
             <a:pPr>
@@ -14774,7 +15676,7 @@
 </p:sld>
 </file>
 
-<file path=ppt/slides/slide43.xml><?xml version="1.0" encoding="utf-8"?>
+<file path=ppt/slides/slide44.xml><?xml version="1.0" encoding="utf-8"?>
 <p:sld xmlns:a="http://schemas.openxmlformats.org/drawingml/2006/main" xmlns:r="http://schemas.openxmlformats.org/officeDocument/2006/relationships" xmlns:p="http://schemas.openxmlformats.org/presentationml/2006/main">
   <p:cSld>
     <p:spTree>
@@ -14865,7 +15767,7 @@
 </p:sld>
 </file>
 
-<file path=ppt/slides/slide44.xml><?xml version="1.0" encoding="utf-8"?>
+<file path=ppt/slides/slide45.xml><?xml version="1.0" encoding="utf-8"?>
 <p:sld xmlns:a="http://schemas.openxmlformats.org/drawingml/2006/main" xmlns:r="http://schemas.openxmlformats.org/officeDocument/2006/relationships" xmlns:p="http://schemas.openxmlformats.org/presentationml/2006/main">
   <p:cSld>
     <p:spTree>
@@ -15219,7 +16121,7 @@
 </p:sld>
 </file>
 
-<file path=ppt/slides/slide45.xml><?xml version="1.0" encoding="utf-8"?>
+<file path=ppt/slides/slide46.xml><?xml version="1.0" encoding="utf-8"?>
 <p:sld xmlns:a="http://schemas.openxmlformats.org/drawingml/2006/main" xmlns:r="http://schemas.openxmlformats.org/officeDocument/2006/relationships" xmlns:p="http://schemas.openxmlformats.org/presentationml/2006/main">
   <p:cSld>
     <p:spTree>
@@ -15310,7 +16212,7 @@
 </p:sld>
 </file>
 
-<file path=ppt/slides/slide46.xml><?xml version="1.0" encoding="utf-8"?>
+<file path=ppt/slides/slide47.xml><?xml version="1.0" encoding="utf-8"?>
 <p:sld xmlns:a="http://schemas.openxmlformats.org/drawingml/2006/main" xmlns:r="http://schemas.openxmlformats.org/officeDocument/2006/relationships" xmlns:p="http://schemas.openxmlformats.org/presentationml/2006/main">
   <p:cSld>
     <p:spTree>
@@ -15507,7 +16409,7 @@
 </p:sld>
 </file>
 
-<file path=ppt/slides/slide47.xml><?xml version="1.0" encoding="utf-8"?>
+<file path=ppt/slides/slide48.xml><?xml version="1.0" encoding="utf-8"?>
 <p:sld xmlns:a="http://schemas.openxmlformats.org/drawingml/2006/main" xmlns:r="http://schemas.openxmlformats.org/officeDocument/2006/relationships" xmlns:p="http://schemas.openxmlformats.org/presentationml/2006/main">
   <p:cSld>
     <p:spTree>
@@ -15761,7 +16663,7 @@
 </p:sld>
 </file>
 
-<file path=ppt/slides/slide48.xml><?xml version="1.0" encoding="utf-8"?>
+<file path=ppt/slides/slide49.xml><?xml version="1.0" encoding="utf-8"?>
 <p:sld xmlns:a="http://schemas.openxmlformats.org/drawingml/2006/main" xmlns:r="http://schemas.openxmlformats.org/officeDocument/2006/relationships" xmlns:p="http://schemas.openxmlformats.org/presentationml/2006/main">
   <p:cSld>
     <p:spTree>
@@ -15979,7 +16881,654 @@
 </p:sld>
 </file>
 
-<file path=ppt/slides/slide49.xml><?xml version="1.0" encoding="utf-8"?>
+<file path=ppt/slides/slide5.xml><?xml version="1.0" encoding="utf-8"?>
+<p:sld xmlns:a="http://schemas.openxmlformats.org/drawingml/2006/main" xmlns:r="http://schemas.openxmlformats.org/officeDocument/2006/relationships" xmlns:p="http://schemas.openxmlformats.org/presentationml/2006/main">
+  <p:cSld>
+    <p:spTree>
+      <p:nvGrpSpPr>
+        <p:cNvPr id="1" name=""/>
+        <p:cNvGrpSpPr/>
+        <p:nvPr/>
+      </p:nvGrpSpPr>
+      <p:grpSpPr>
+        <a:xfrm>
+          <a:off x="0" y="0"/>
+          <a:ext cx="0" cy="0"/>
+          <a:chOff x="0" y="0"/>
+          <a:chExt cx="0" cy="0"/>
+        </a:xfrm>
+      </p:grpSpPr>
+      <p:sp>
+        <p:nvSpPr>
+          <p:cNvPr id="11265" name="Ovál 1">
+            <a:extLst>
+              <a:ext uri="{FF2B5EF4-FFF2-40B4-BE49-F238E27FC236}">
+                <a16:creationId xmlns:a16="http://schemas.microsoft.com/office/drawing/2014/main" id="{9C1D8EC6-EBD7-0B54-3744-1FECC1D097DC}"/>
+              </a:ext>
+            </a:extLst>
+          </p:cNvPr>
+          <p:cNvSpPr>
+            <a:spLocks noChangeArrowheads="1"/>
+          </p:cNvSpPr>
+          <p:nvPr/>
+        </p:nvSpPr>
+        <p:spPr bwMode="auto">
+          <a:xfrm>
+            <a:off x="754063" y="2336800"/>
+            <a:ext cx="542925" cy="1604963"/>
+          </a:xfrm>
+          <a:prstGeom prst="ellipse">
+            <a:avLst/>
+          </a:prstGeom>
+          <a:solidFill>
+            <a:schemeClr val="accent1"/>
+          </a:solidFill>
+          <a:ln w="9525" algn="ctr">
+            <a:solidFill>
+              <a:schemeClr val="accent1"/>
+            </a:solidFill>
+            <a:round/>
+            <a:headEnd/>
+            <a:tailEnd/>
+          </a:ln>
+        </p:spPr>
+        <p:txBody>
+          <a:bodyPr wrap="none"/>
+          <a:lstStyle>
+            <a:lvl1pPr>
+              <a:spcBef>
+                <a:spcPct val="35000"/>
+              </a:spcBef>
+              <a:buClr>
+                <a:srgbClr val="993300"/>
+              </a:buClr>
+              <a:buSzPct val="90000"/>
+              <a:buFont typeface="Monotype Sorts" pitchFamily="2" charset="2"/>
+              <a:buChar char="n"/>
+              <a:defRPr kumimoji="1">
+                <a:solidFill>
+                  <a:schemeClr val="tx1"/>
+                </a:solidFill>
+                <a:latin typeface="Helvetica" pitchFamily="2" charset="0"/>
+                <a:ea typeface="ＭＳ Ｐゴシック" panose="020B0600070205080204" pitchFamily="34" charset="-128"/>
+              </a:defRPr>
+            </a:lvl1pPr>
+            <a:lvl2pPr marL="742950" indent="-285750">
+              <a:spcBef>
+                <a:spcPct val="35000"/>
+              </a:spcBef>
+              <a:buClr>
+                <a:srgbClr val="CC6600"/>
+              </a:buClr>
+              <a:buSzPct val="80000"/>
+              <a:buFont typeface="Monotype Sorts" pitchFamily="2" charset="2"/>
+              <a:buChar char="l"/>
+              <a:defRPr kumimoji="1">
+                <a:solidFill>
+                  <a:schemeClr val="tx1"/>
+                </a:solidFill>
+                <a:latin typeface="Helvetica" pitchFamily="2" charset="0"/>
+                <a:ea typeface="ＭＳ Ｐゴシック" panose="020B0600070205080204" pitchFamily="34" charset="-128"/>
+              </a:defRPr>
+            </a:lvl2pPr>
+            <a:lvl3pPr marL="1143000" indent="-228600">
+              <a:spcBef>
+                <a:spcPct val="35000"/>
+              </a:spcBef>
+              <a:buClr>
+                <a:srgbClr val="009900"/>
+              </a:buClr>
+              <a:buSzPct val="75000"/>
+              <a:buFont typeface="Webdings" pitchFamily="2" charset="2"/>
+              <a:buChar char="4"/>
+              <a:defRPr kumimoji="1">
+                <a:solidFill>
+                  <a:schemeClr val="tx1"/>
+                </a:solidFill>
+                <a:latin typeface="Helvetica" pitchFamily="2" charset="0"/>
+                <a:ea typeface="ＭＳ Ｐゴシック" panose="020B0600070205080204" pitchFamily="34" charset="-128"/>
+              </a:defRPr>
+            </a:lvl3pPr>
+            <a:lvl4pPr marL="1600200" indent="-228600">
+              <a:spcBef>
+                <a:spcPct val="35000"/>
+              </a:spcBef>
+              <a:buClr>
+                <a:schemeClr val="hlink"/>
+              </a:buClr>
+              <a:buSzPct val="75000"/>
+              <a:buChar char="–"/>
+              <a:defRPr kumimoji="1">
+                <a:solidFill>
+                  <a:schemeClr val="tx1"/>
+                </a:solidFill>
+                <a:latin typeface="Helvetica" pitchFamily="2" charset="0"/>
+                <a:ea typeface="ＭＳ Ｐゴシック" panose="020B0600070205080204" pitchFamily="34" charset="-128"/>
+              </a:defRPr>
+            </a:lvl4pPr>
+            <a:lvl5pPr marL="2057400" indent="-228600">
+              <a:spcBef>
+                <a:spcPct val="35000"/>
+              </a:spcBef>
+              <a:buClr>
+                <a:srgbClr val="FF0066"/>
+              </a:buClr>
+              <a:buSzPct val="75000"/>
+              <a:buChar char="»"/>
+              <a:defRPr kumimoji="1">
+                <a:solidFill>
+                  <a:schemeClr val="tx1"/>
+                </a:solidFill>
+                <a:latin typeface="Helvetica" pitchFamily="2" charset="0"/>
+                <a:ea typeface="ＭＳ Ｐゴシック" panose="020B0600070205080204" pitchFamily="34" charset="-128"/>
+              </a:defRPr>
+            </a:lvl5pPr>
+            <a:lvl6pPr marL="2514600" indent="-228600" eaLnBrk="0" fontAlgn="base" hangingPunct="0">
+              <a:spcBef>
+                <a:spcPct val="35000"/>
+              </a:spcBef>
+              <a:spcAft>
+                <a:spcPct val="0"/>
+              </a:spcAft>
+              <a:buClr>
+                <a:srgbClr val="FF0066"/>
+              </a:buClr>
+              <a:buSzPct val="75000"/>
+              <a:buChar char="»"/>
+              <a:defRPr kumimoji="1">
+                <a:solidFill>
+                  <a:schemeClr val="tx1"/>
+                </a:solidFill>
+                <a:latin typeface="Helvetica" pitchFamily="2" charset="0"/>
+                <a:ea typeface="ＭＳ Ｐゴシック" panose="020B0600070205080204" pitchFamily="34" charset="-128"/>
+              </a:defRPr>
+            </a:lvl6pPr>
+            <a:lvl7pPr marL="2971800" indent="-228600" eaLnBrk="0" fontAlgn="base" hangingPunct="0">
+              <a:spcBef>
+                <a:spcPct val="35000"/>
+              </a:spcBef>
+              <a:spcAft>
+                <a:spcPct val="0"/>
+              </a:spcAft>
+              <a:buClr>
+                <a:srgbClr val="FF0066"/>
+              </a:buClr>
+              <a:buSzPct val="75000"/>
+              <a:buChar char="»"/>
+              <a:defRPr kumimoji="1">
+                <a:solidFill>
+                  <a:schemeClr val="tx1"/>
+                </a:solidFill>
+                <a:latin typeface="Helvetica" pitchFamily="2" charset="0"/>
+                <a:ea typeface="ＭＳ Ｐゴシック" panose="020B0600070205080204" pitchFamily="34" charset="-128"/>
+              </a:defRPr>
+            </a:lvl7pPr>
+            <a:lvl8pPr marL="3429000" indent="-228600" eaLnBrk="0" fontAlgn="base" hangingPunct="0">
+              <a:spcBef>
+                <a:spcPct val="35000"/>
+              </a:spcBef>
+              <a:spcAft>
+                <a:spcPct val="0"/>
+              </a:spcAft>
+              <a:buClr>
+                <a:srgbClr val="FF0066"/>
+              </a:buClr>
+              <a:buSzPct val="75000"/>
+              <a:buChar char="»"/>
+              <a:defRPr kumimoji="1">
+                <a:solidFill>
+                  <a:schemeClr val="tx1"/>
+                </a:solidFill>
+                <a:latin typeface="Helvetica" pitchFamily="2" charset="0"/>
+                <a:ea typeface="ＭＳ Ｐゴシック" panose="020B0600070205080204" pitchFamily="34" charset="-128"/>
+              </a:defRPr>
+            </a:lvl8pPr>
+            <a:lvl9pPr marL="3886200" indent="-228600" eaLnBrk="0" fontAlgn="base" hangingPunct="0">
+              <a:spcBef>
+                <a:spcPct val="35000"/>
+              </a:spcBef>
+              <a:spcAft>
+                <a:spcPct val="0"/>
+              </a:spcAft>
+              <a:buClr>
+                <a:srgbClr val="FF0066"/>
+              </a:buClr>
+              <a:buSzPct val="75000"/>
+              <a:buChar char="»"/>
+              <a:defRPr kumimoji="1">
+                <a:solidFill>
+                  <a:schemeClr val="tx1"/>
+                </a:solidFill>
+                <a:latin typeface="Helvetica" pitchFamily="2" charset="0"/>
+                <a:ea typeface="ＭＳ Ｐゴシック" panose="020B0600070205080204" pitchFamily="34" charset="-128"/>
+              </a:defRPr>
+            </a:lvl9pPr>
+          </a:lstStyle>
+          <a:p>
+            <a:pPr>
+              <a:spcBef>
+                <a:spcPct val="0"/>
+              </a:spcBef>
+              <a:buClrTx/>
+              <a:buSzTx/>
+              <a:buFontTx/>
+              <a:buNone/>
+            </a:pPr>
+            <a:endParaRPr kumimoji="0" lang="sk-SK" altLang="sk-SK">
+              <a:latin typeface="Verdana" panose="020B0604030504040204" pitchFamily="34" charset="0"/>
+            </a:endParaRPr>
+          </a:p>
+        </p:txBody>
+      </p:sp>
+      <p:sp>
+        <p:nvSpPr>
+          <p:cNvPr id="11266" name="Title 1">
+            <a:extLst>
+              <a:ext uri="{FF2B5EF4-FFF2-40B4-BE49-F238E27FC236}">
+                <a16:creationId xmlns:a16="http://schemas.microsoft.com/office/drawing/2014/main" id="{7B06A379-B64F-47DE-564C-698DDA899F2B}"/>
+              </a:ext>
+            </a:extLst>
+          </p:cNvPr>
+          <p:cNvSpPr>
+            <a:spLocks noGrp="1" noChangeArrowheads="1"/>
+          </p:cNvSpPr>
+          <p:nvPr>
+            <p:ph type="title"/>
+          </p:nvPr>
+        </p:nvSpPr>
+        <p:spPr>
+          <a:xfrm>
+            <a:off x="457200" y="287338"/>
+            <a:ext cx="8229600" cy="576262"/>
+          </a:xfrm>
+        </p:spPr>
+        <p:txBody>
+          <a:bodyPr/>
+          <a:lstStyle/>
+          <a:p>
+            <a:r>
+              <a:rPr lang="en-US" altLang="sk-SK">
+                <a:ea typeface="ＭＳ Ｐゴシック" panose="020B0600070205080204" pitchFamily="34" charset="-128"/>
+              </a:rPr>
+              <a:t>Implementation of VMMs</a:t>
+            </a:r>
+          </a:p>
+        </p:txBody>
+      </p:sp>
+      <p:sp>
+        <p:nvSpPr>
+          <p:cNvPr id="13315" name="Content Placeholder 2">
+            <a:extLst>
+              <a:ext uri="{FF2B5EF4-FFF2-40B4-BE49-F238E27FC236}">
+                <a16:creationId xmlns:a16="http://schemas.microsoft.com/office/drawing/2014/main" id="{0A471A76-63AA-6EA7-0D1A-0FDFC7E57021}"/>
+              </a:ext>
+            </a:extLst>
+          </p:cNvPr>
+          <p:cNvSpPr>
+            <a:spLocks noGrp="1" noChangeArrowheads="1"/>
+          </p:cNvSpPr>
+          <p:nvPr>
+            <p:ph idx="1"/>
+          </p:nvPr>
+        </p:nvSpPr>
+        <p:spPr>
+          <a:xfrm>
+            <a:off x="457200" y="1336675"/>
+            <a:ext cx="8229600" cy="4530725"/>
+          </a:xfrm>
+        </p:spPr>
+        <p:txBody>
+          <a:bodyPr>
+            <a:normAutofit fontScale="92500" lnSpcReduction="10000"/>
+          </a:bodyPr>
+          <a:lstStyle/>
+          <a:p>
+            <a:pPr>
+              <a:defRPr/>
+            </a:pPr>
+            <a:r>
+              <a:rPr lang="en-US" altLang="sk-SK" dirty="0">
+                <a:ea typeface="ＭＳ Ｐゴシック" panose="020B0600070205080204" pitchFamily="34" charset="-128"/>
+              </a:rPr>
+              <a:t>Vary greatly, with options including:</a:t>
+            </a:r>
+          </a:p>
+          <a:p>
+            <a:pPr lvl="1">
+              <a:defRPr/>
+            </a:pPr>
+            <a:r>
+              <a:rPr lang="en-US" altLang="sk-SK" b="1" dirty="0">
+                <a:solidFill>
+                  <a:srgbClr val="3366FF"/>
+                </a:solidFill>
+                <a:ea typeface="ＭＳ Ｐゴシック" panose="020B0600070205080204" pitchFamily="34" charset="-128"/>
+              </a:rPr>
+              <a:t>Type 0 hypervisors </a:t>
+            </a:r>
+            <a:r>
+              <a:rPr lang="en-US" altLang="sk-SK" b="1" dirty="0">
+                <a:ea typeface="ＭＳ Ｐゴシック" panose="020B0600070205080204" pitchFamily="34" charset="-128"/>
+              </a:rPr>
+              <a:t>- </a:t>
+            </a:r>
+            <a:r>
+              <a:rPr lang="en-US" altLang="sk-SK" dirty="0">
+                <a:ea typeface="ＭＳ Ｐゴシック" panose="020B0600070205080204" pitchFamily="34" charset="-128"/>
+              </a:rPr>
+              <a:t>Hardware-based solutions that provide support for virtual machine creation and management via firmware</a:t>
+            </a:r>
+          </a:p>
+          <a:p>
+            <a:pPr lvl="2">
+              <a:defRPr/>
+            </a:pPr>
+            <a:r>
+              <a:rPr lang="en-US" altLang="sk-SK" sz="1600" dirty="0">
+                <a:ea typeface="ＭＳ Ｐゴシック" panose="020B0600070205080204" pitchFamily="34" charset="-128"/>
+              </a:rPr>
+              <a:t>IBM LPARs </a:t>
+            </a:r>
+            <a:r>
+              <a:rPr lang="en-US" altLang="sk-SK" dirty="0">
+                <a:ea typeface="ＭＳ Ｐゴシック" panose="020B0600070205080204" pitchFamily="34" charset="-128"/>
+              </a:rPr>
+              <a:t>and Oracle </a:t>
+            </a:r>
+            <a:r>
+              <a:rPr lang="en-US" altLang="sk-SK" sz="1600" dirty="0">
+                <a:ea typeface="ＭＳ Ｐゴシック" panose="020B0600070205080204" pitchFamily="34" charset="-128"/>
+              </a:rPr>
+              <a:t>LDOMs </a:t>
+            </a:r>
+            <a:r>
+              <a:rPr lang="en-US" altLang="sk-SK" dirty="0">
+                <a:ea typeface="ＭＳ Ｐゴシック" panose="020B0600070205080204" pitchFamily="34" charset="-128"/>
+              </a:rPr>
+              <a:t>are examples</a:t>
+            </a:r>
+            <a:endParaRPr lang="en-US" altLang="sk-SK" sz="2800" dirty="0">
+              <a:ea typeface="ＭＳ Ｐゴシック" panose="020B0600070205080204" pitchFamily="34" charset="-128"/>
+            </a:endParaRPr>
+          </a:p>
+          <a:p>
+            <a:pPr lvl="1">
+              <a:defRPr/>
+            </a:pPr>
+            <a:r>
+              <a:rPr lang="en-US" altLang="sk-SK" b="1" dirty="0">
+                <a:solidFill>
+                  <a:srgbClr val="3366FF"/>
+                </a:solidFill>
+                <a:ea typeface="ＭＳ Ｐゴシック" panose="020B0600070205080204" pitchFamily="34" charset="-128"/>
+              </a:rPr>
+              <a:t>Type 1 hypervisors </a:t>
+            </a:r>
+            <a:r>
+              <a:rPr lang="en-US" altLang="sk-SK" b="1" dirty="0">
+                <a:ea typeface="ＭＳ Ｐゴシック" panose="020B0600070205080204" pitchFamily="34" charset="-128"/>
+              </a:rPr>
+              <a:t>- </a:t>
+            </a:r>
+            <a:r>
+              <a:rPr lang="en-US" altLang="sk-SK" dirty="0">
+                <a:ea typeface="ＭＳ Ｐゴシック" panose="020B0600070205080204" pitchFamily="34" charset="-128"/>
+              </a:rPr>
+              <a:t>Operating-system-like software built to provide virtualization</a:t>
+            </a:r>
+          </a:p>
+          <a:p>
+            <a:pPr lvl="2">
+              <a:defRPr/>
+            </a:pPr>
+            <a:r>
+              <a:rPr lang="en-US" altLang="sk-SK" dirty="0">
+                <a:ea typeface="ＭＳ Ｐゴシック" panose="020B0600070205080204" pitchFamily="34" charset="-128"/>
+              </a:rPr>
+              <a:t>Including </a:t>
+            </a:r>
+            <a:r>
+              <a:rPr lang="en-US" altLang="sk-SK" dirty="0">
+                <a:solidFill>
+                  <a:schemeClr val="accent1"/>
+                </a:solidFill>
+                <a:ea typeface="ＭＳ Ｐゴシック" panose="020B0600070205080204" pitchFamily="34" charset="-128"/>
+              </a:rPr>
+              <a:t>VMware ESX</a:t>
+            </a:r>
+            <a:r>
+              <a:rPr lang="en-US" altLang="sk-SK" dirty="0">
+                <a:ea typeface="ＭＳ Ｐゴシック" panose="020B0600070205080204" pitchFamily="34" charset="-128"/>
+              </a:rPr>
+              <a:t>, </a:t>
+            </a:r>
+            <a:r>
+              <a:rPr lang="en-US" altLang="sk-SK" dirty="0" err="1">
+                <a:ea typeface="ＭＳ Ｐゴシック" panose="020B0600070205080204" pitchFamily="34" charset="-128"/>
+              </a:rPr>
+              <a:t>Joyent</a:t>
+            </a:r>
+            <a:r>
+              <a:rPr lang="en-US" altLang="sk-SK" dirty="0">
+                <a:ea typeface="ＭＳ Ｐゴシック" panose="020B0600070205080204" pitchFamily="34" charset="-128"/>
+              </a:rPr>
+              <a:t> </a:t>
+            </a:r>
+            <a:r>
+              <a:rPr lang="en-US" altLang="sk-SK" dirty="0" err="1">
+                <a:ea typeface="ＭＳ Ｐゴシック" panose="020B0600070205080204" pitchFamily="34" charset="-128"/>
+              </a:rPr>
+              <a:t>Smart</a:t>
+            </a:r>
+            <a:r>
+              <a:rPr lang="en-US" altLang="sk-SK" sz="1600" dirty="0" err="1">
+                <a:ea typeface="ＭＳ Ｐゴシック" panose="020B0600070205080204" pitchFamily="34" charset="-128"/>
+              </a:rPr>
+              <a:t>OS</a:t>
+            </a:r>
+            <a:r>
+              <a:rPr lang="en-US" altLang="sk-SK" dirty="0">
+                <a:ea typeface="ＭＳ Ｐゴシック" panose="020B0600070205080204" pitchFamily="34" charset="-128"/>
+              </a:rPr>
+              <a:t>, and </a:t>
+            </a:r>
+            <a:r>
+              <a:rPr lang="en-US" altLang="sk-SK" dirty="0">
+                <a:solidFill>
+                  <a:schemeClr val="accent1"/>
+                </a:solidFill>
+                <a:ea typeface="ＭＳ Ｐゴシック" panose="020B0600070205080204" pitchFamily="34" charset="-128"/>
+              </a:rPr>
+              <a:t>Citrix </a:t>
+            </a:r>
+            <a:r>
+              <a:rPr lang="en-US" altLang="sk-SK" dirty="0" err="1">
+                <a:solidFill>
+                  <a:schemeClr val="accent1"/>
+                </a:solidFill>
+                <a:ea typeface="ＭＳ Ｐゴシック" panose="020B0600070205080204" pitchFamily="34" charset="-128"/>
+              </a:rPr>
+              <a:t>XenServer</a:t>
+            </a:r>
+            <a:r>
+              <a:rPr lang="en-US" altLang="sk-SK" dirty="0">
+                <a:solidFill>
+                  <a:schemeClr val="accent1"/>
+                </a:solidFill>
+                <a:ea typeface="ＭＳ Ｐゴシック" panose="020B0600070205080204" pitchFamily="34" charset="-128"/>
+              </a:rPr>
+              <a:t> </a:t>
+            </a:r>
+          </a:p>
+          <a:p>
+            <a:pPr lvl="1">
+              <a:defRPr/>
+            </a:pPr>
+            <a:r>
+              <a:rPr lang="en-US" altLang="sk-SK" b="1" dirty="0">
+                <a:solidFill>
+                  <a:srgbClr val="3366FF"/>
+                </a:solidFill>
+                <a:ea typeface="ＭＳ Ｐゴシック" panose="020B0600070205080204" pitchFamily="34" charset="-128"/>
+              </a:rPr>
+              <a:t>Type 1 hypervisors </a:t>
+            </a:r>
+            <a:r>
+              <a:rPr lang="en-US" altLang="sk-SK" b="1" dirty="0">
+                <a:ea typeface="ＭＳ Ｐゴシック" panose="020B0600070205080204" pitchFamily="34" charset="-128"/>
+              </a:rPr>
+              <a:t>– </a:t>
+            </a:r>
+            <a:r>
+              <a:rPr lang="en-US" altLang="sk-SK" dirty="0">
+                <a:ea typeface="ＭＳ Ｐゴシック" panose="020B0600070205080204" pitchFamily="34" charset="-128"/>
+              </a:rPr>
+              <a:t>Also includes general-purpose operating systems that provide standard functions as well as </a:t>
+            </a:r>
+            <a:r>
+              <a:rPr lang="en-US" altLang="sk-SK" sz="1600" dirty="0">
+                <a:ea typeface="ＭＳ Ｐゴシック" panose="020B0600070205080204" pitchFamily="34" charset="-128"/>
+              </a:rPr>
+              <a:t>VMM </a:t>
+            </a:r>
+            <a:r>
+              <a:rPr lang="en-US" altLang="sk-SK" dirty="0">
+                <a:ea typeface="ＭＳ Ｐゴシック" panose="020B0600070205080204" pitchFamily="34" charset="-128"/>
+              </a:rPr>
+              <a:t>functions</a:t>
+            </a:r>
+          </a:p>
+          <a:p>
+            <a:pPr lvl="2">
+              <a:defRPr/>
+            </a:pPr>
+            <a:r>
+              <a:rPr lang="en-US" altLang="sk-SK" dirty="0">
+                <a:ea typeface="ＭＳ Ｐゴシック" panose="020B0600070205080204" pitchFamily="34" charset="-128"/>
+              </a:rPr>
+              <a:t>Including Microsoft Windows Server with </a:t>
+            </a:r>
+            <a:r>
+              <a:rPr lang="en-US" altLang="sk-SK" dirty="0" err="1">
+                <a:solidFill>
+                  <a:schemeClr val="accent1"/>
+                </a:solidFill>
+                <a:ea typeface="ＭＳ Ｐゴシック" panose="020B0600070205080204" pitchFamily="34" charset="-128"/>
+              </a:rPr>
+              <a:t>HyperV</a:t>
+            </a:r>
+            <a:r>
+              <a:rPr lang="en-US" altLang="sk-SK" dirty="0">
+                <a:ea typeface="ＭＳ Ｐゴシック" panose="020B0600070205080204" pitchFamily="34" charset="-128"/>
+              </a:rPr>
+              <a:t> and RedHat Linux with </a:t>
+            </a:r>
+            <a:r>
+              <a:rPr lang="en-US" altLang="sk-SK" dirty="0">
+                <a:solidFill>
+                  <a:schemeClr val="accent1"/>
+                </a:solidFill>
+                <a:ea typeface="ＭＳ Ｐゴシック" panose="020B0600070205080204" pitchFamily="34" charset="-128"/>
+              </a:rPr>
+              <a:t>KVM</a:t>
+            </a:r>
+          </a:p>
+          <a:p>
+            <a:pPr lvl="1">
+              <a:defRPr/>
+            </a:pPr>
+            <a:r>
+              <a:rPr lang="en-US" altLang="sk-SK" b="1" dirty="0">
+                <a:solidFill>
+                  <a:srgbClr val="3366FF"/>
+                </a:solidFill>
+                <a:ea typeface="ＭＳ Ｐゴシック" panose="020B0600070205080204" pitchFamily="34" charset="-128"/>
+              </a:rPr>
+              <a:t>Type 2 hypervisors </a:t>
+            </a:r>
+            <a:r>
+              <a:rPr lang="en-US" altLang="sk-SK" b="1" dirty="0">
+                <a:ea typeface="ＭＳ Ｐゴシック" panose="020B0600070205080204" pitchFamily="34" charset="-128"/>
+              </a:rPr>
+              <a:t>- </a:t>
+            </a:r>
+            <a:r>
+              <a:rPr lang="en-US" altLang="sk-SK" dirty="0">
+                <a:ea typeface="ＭＳ Ｐゴシック" panose="020B0600070205080204" pitchFamily="34" charset="-128"/>
+              </a:rPr>
+              <a:t>Applications that run on standard operating systems but provide </a:t>
+            </a:r>
+            <a:r>
+              <a:rPr lang="en-US" altLang="sk-SK" sz="1600" dirty="0">
+                <a:ea typeface="ＭＳ Ｐゴシック" panose="020B0600070205080204" pitchFamily="34" charset="-128"/>
+              </a:rPr>
+              <a:t>VMM </a:t>
+            </a:r>
+            <a:r>
+              <a:rPr lang="en-US" altLang="sk-SK" dirty="0">
+                <a:ea typeface="ＭＳ Ｐゴシック" panose="020B0600070205080204" pitchFamily="34" charset="-128"/>
+              </a:rPr>
+              <a:t>features to guest operating systems</a:t>
+            </a:r>
+          </a:p>
+          <a:p>
+            <a:pPr lvl="2">
+              <a:defRPr/>
+            </a:pPr>
+            <a:r>
+              <a:rPr lang="en-US" altLang="sk-SK" dirty="0" err="1">
+                <a:ea typeface="ＭＳ Ｐゴシック" panose="020B0600070205080204" pitchFamily="34" charset="-128"/>
+              </a:rPr>
+              <a:t>Includeing</a:t>
+            </a:r>
+            <a:r>
+              <a:rPr lang="en-US" altLang="sk-SK" dirty="0">
+                <a:ea typeface="ＭＳ Ｐゴシック" panose="020B0600070205080204" pitchFamily="34" charset="-128"/>
+              </a:rPr>
+              <a:t> </a:t>
+            </a:r>
+            <a:r>
+              <a:rPr lang="en-US" altLang="sk-SK" dirty="0">
+                <a:solidFill>
+                  <a:schemeClr val="accent1"/>
+                </a:solidFill>
+                <a:ea typeface="ＭＳ Ｐゴシック" panose="020B0600070205080204" pitchFamily="34" charset="-128"/>
+              </a:rPr>
+              <a:t>VMware Workstation </a:t>
+            </a:r>
+            <a:r>
+              <a:rPr lang="en-US" altLang="sk-SK" dirty="0">
+                <a:ea typeface="ＭＳ Ｐゴシック" panose="020B0600070205080204" pitchFamily="34" charset="-128"/>
+              </a:rPr>
+              <a:t>and Fusion, Parallels Desktop, and </a:t>
+            </a:r>
+            <a:r>
+              <a:rPr lang="en-US" altLang="sk-SK" dirty="0">
+                <a:solidFill>
+                  <a:schemeClr val="accent1"/>
+                </a:solidFill>
+                <a:ea typeface="ＭＳ Ｐゴシック" panose="020B0600070205080204" pitchFamily="34" charset="-128"/>
+              </a:rPr>
+              <a:t>Oracle VirtualBox</a:t>
+            </a:r>
+            <a:endParaRPr lang="en-US" altLang="sk-SK" sz="2800" dirty="0">
+              <a:solidFill>
+                <a:schemeClr val="accent1"/>
+              </a:solidFill>
+              <a:ea typeface="ＭＳ Ｐゴシック" panose="020B0600070205080204" pitchFamily="34" charset="-128"/>
+            </a:endParaRPr>
+          </a:p>
+        </p:txBody>
+      </p:sp>
+    </p:spTree>
+  </p:cSld>
+  <p:clrMapOvr>
+    <a:masterClrMapping/>
+  </p:clrMapOvr>
+</p:sld>
+</file>
+
+<file path=ppt/slides/slide50.xml><?xml version="1.0" encoding="utf-8"?>
 <p:sld xmlns:a="http://schemas.openxmlformats.org/drawingml/2006/main" xmlns:r="http://schemas.openxmlformats.org/officeDocument/2006/relationships" xmlns:p="http://schemas.openxmlformats.org/presentationml/2006/main">
   <p:cSld>
     <p:spTree>
@@ -16262,654 +17811,7 @@
 </p:sld>
 </file>
 
-<file path=ppt/slides/slide5.xml><?xml version="1.0" encoding="utf-8"?>
-<p:sld xmlns:a="http://schemas.openxmlformats.org/drawingml/2006/main" xmlns:r="http://schemas.openxmlformats.org/officeDocument/2006/relationships" xmlns:p="http://schemas.openxmlformats.org/presentationml/2006/main">
-  <p:cSld>
-    <p:spTree>
-      <p:nvGrpSpPr>
-        <p:cNvPr id="1" name=""/>
-        <p:cNvGrpSpPr/>
-        <p:nvPr/>
-      </p:nvGrpSpPr>
-      <p:grpSpPr>
-        <a:xfrm>
-          <a:off x="0" y="0"/>
-          <a:ext cx="0" cy="0"/>
-          <a:chOff x="0" y="0"/>
-          <a:chExt cx="0" cy="0"/>
-        </a:xfrm>
-      </p:grpSpPr>
-      <p:sp>
-        <p:nvSpPr>
-          <p:cNvPr id="11265" name="Ovál 1">
-            <a:extLst>
-              <a:ext uri="{FF2B5EF4-FFF2-40B4-BE49-F238E27FC236}">
-                <a16:creationId xmlns:a16="http://schemas.microsoft.com/office/drawing/2014/main" id="{9C1D8EC6-EBD7-0B54-3744-1FECC1D097DC}"/>
-              </a:ext>
-            </a:extLst>
-          </p:cNvPr>
-          <p:cNvSpPr>
-            <a:spLocks noChangeArrowheads="1"/>
-          </p:cNvSpPr>
-          <p:nvPr/>
-        </p:nvSpPr>
-        <p:spPr bwMode="auto">
-          <a:xfrm>
-            <a:off x="754063" y="2336800"/>
-            <a:ext cx="542925" cy="1604963"/>
-          </a:xfrm>
-          <a:prstGeom prst="ellipse">
-            <a:avLst/>
-          </a:prstGeom>
-          <a:solidFill>
-            <a:schemeClr val="accent1"/>
-          </a:solidFill>
-          <a:ln w="9525" algn="ctr">
-            <a:solidFill>
-              <a:schemeClr val="accent1"/>
-            </a:solidFill>
-            <a:round/>
-            <a:headEnd/>
-            <a:tailEnd/>
-          </a:ln>
-        </p:spPr>
-        <p:txBody>
-          <a:bodyPr wrap="none"/>
-          <a:lstStyle>
-            <a:lvl1pPr>
-              <a:spcBef>
-                <a:spcPct val="35000"/>
-              </a:spcBef>
-              <a:buClr>
-                <a:srgbClr val="993300"/>
-              </a:buClr>
-              <a:buSzPct val="90000"/>
-              <a:buFont typeface="Monotype Sorts" pitchFamily="2" charset="2"/>
-              <a:buChar char="n"/>
-              <a:defRPr kumimoji="1">
-                <a:solidFill>
-                  <a:schemeClr val="tx1"/>
-                </a:solidFill>
-                <a:latin typeface="Helvetica" pitchFamily="2" charset="0"/>
-                <a:ea typeface="ＭＳ Ｐゴシック" panose="020B0600070205080204" pitchFamily="34" charset="-128"/>
-              </a:defRPr>
-            </a:lvl1pPr>
-            <a:lvl2pPr marL="742950" indent="-285750">
-              <a:spcBef>
-                <a:spcPct val="35000"/>
-              </a:spcBef>
-              <a:buClr>
-                <a:srgbClr val="CC6600"/>
-              </a:buClr>
-              <a:buSzPct val="80000"/>
-              <a:buFont typeface="Monotype Sorts" pitchFamily="2" charset="2"/>
-              <a:buChar char="l"/>
-              <a:defRPr kumimoji="1">
-                <a:solidFill>
-                  <a:schemeClr val="tx1"/>
-                </a:solidFill>
-                <a:latin typeface="Helvetica" pitchFamily="2" charset="0"/>
-                <a:ea typeface="ＭＳ Ｐゴシック" panose="020B0600070205080204" pitchFamily="34" charset="-128"/>
-              </a:defRPr>
-            </a:lvl2pPr>
-            <a:lvl3pPr marL="1143000" indent="-228600">
-              <a:spcBef>
-                <a:spcPct val="35000"/>
-              </a:spcBef>
-              <a:buClr>
-                <a:srgbClr val="009900"/>
-              </a:buClr>
-              <a:buSzPct val="75000"/>
-              <a:buFont typeface="Webdings" pitchFamily="2" charset="2"/>
-              <a:buChar char="4"/>
-              <a:defRPr kumimoji="1">
-                <a:solidFill>
-                  <a:schemeClr val="tx1"/>
-                </a:solidFill>
-                <a:latin typeface="Helvetica" pitchFamily="2" charset="0"/>
-                <a:ea typeface="ＭＳ Ｐゴシック" panose="020B0600070205080204" pitchFamily="34" charset="-128"/>
-              </a:defRPr>
-            </a:lvl3pPr>
-            <a:lvl4pPr marL="1600200" indent="-228600">
-              <a:spcBef>
-                <a:spcPct val="35000"/>
-              </a:spcBef>
-              <a:buClr>
-                <a:schemeClr val="hlink"/>
-              </a:buClr>
-              <a:buSzPct val="75000"/>
-              <a:buChar char="–"/>
-              <a:defRPr kumimoji="1">
-                <a:solidFill>
-                  <a:schemeClr val="tx1"/>
-                </a:solidFill>
-                <a:latin typeface="Helvetica" pitchFamily="2" charset="0"/>
-                <a:ea typeface="ＭＳ Ｐゴシック" panose="020B0600070205080204" pitchFamily="34" charset="-128"/>
-              </a:defRPr>
-            </a:lvl4pPr>
-            <a:lvl5pPr marL="2057400" indent="-228600">
-              <a:spcBef>
-                <a:spcPct val="35000"/>
-              </a:spcBef>
-              <a:buClr>
-                <a:srgbClr val="FF0066"/>
-              </a:buClr>
-              <a:buSzPct val="75000"/>
-              <a:buChar char="»"/>
-              <a:defRPr kumimoji="1">
-                <a:solidFill>
-                  <a:schemeClr val="tx1"/>
-                </a:solidFill>
-                <a:latin typeface="Helvetica" pitchFamily="2" charset="0"/>
-                <a:ea typeface="ＭＳ Ｐゴシック" panose="020B0600070205080204" pitchFamily="34" charset="-128"/>
-              </a:defRPr>
-            </a:lvl5pPr>
-            <a:lvl6pPr marL="2514600" indent="-228600" eaLnBrk="0" fontAlgn="base" hangingPunct="0">
-              <a:spcBef>
-                <a:spcPct val="35000"/>
-              </a:spcBef>
-              <a:spcAft>
-                <a:spcPct val="0"/>
-              </a:spcAft>
-              <a:buClr>
-                <a:srgbClr val="FF0066"/>
-              </a:buClr>
-              <a:buSzPct val="75000"/>
-              <a:buChar char="»"/>
-              <a:defRPr kumimoji="1">
-                <a:solidFill>
-                  <a:schemeClr val="tx1"/>
-                </a:solidFill>
-                <a:latin typeface="Helvetica" pitchFamily="2" charset="0"/>
-                <a:ea typeface="ＭＳ Ｐゴシック" panose="020B0600070205080204" pitchFamily="34" charset="-128"/>
-              </a:defRPr>
-            </a:lvl6pPr>
-            <a:lvl7pPr marL="2971800" indent="-228600" eaLnBrk="0" fontAlgn="base" hangingPunct="0">
-              <a:spcBef>
-                <a:spcPct val="35000"/>
-              </a:spcBef>
-              <a:spcAft>
-                <a:spcPct val="0"/>
-              </a:spcAft>
-              <a:buClr>
-                <a:srgbClr val="FF0066"/>
-              </a:buClr>
-              <a:buSzPct val="75000"/>
-              <a:buChar char="»"/>
-              <a:defRPr kumimoji="1">
-                <a:solidFill>
-                  <a:schemeClr val="tx1"/>
-                </a:solidFill>
-                <a:latin typeface="Helvetica" pitchFamily="2" charset="0"/>
-                <a:ea typeface="ＭＳ Ｐゴシック" panose="020B0600070205080204" pitchFamily="34" charset="-128"/>
-              </a:defRPr>
-            </a:lvl7pPr>
-            <a:lvl8pPr marL="3429000" indent="-228600" eaLnBrk="0" fontAlgn="base" hangingPunct="0">
-              <a:spcBef>
-                <a:spcPct val="35000"/>
-              </a:spcBef>
-              <a:spcAft>
-                <a:spcPct val="0"/>
-              </a:spcAft>
-              <a:buClr>
-                <a:srgbClr val="FF0066"/>
-              </a:buClr>
-              <a:buSzPct val="75000"/>
-              <a:buChar char="»"/>
-              <a:defRPr kumimoji="1">
-                <a:solidFill>
-                  <a:schemeClr val="tx1"/>
-                </a:solidFill>
-                <a:latin typeface="Helvetica" pitchFamily="2" charset="0"/>
-                <a:ea typeface="ＭＳ Ｐゴシック" panose="020B0600070205080204" pitchFamily="34" charset="-128"/>
-              </a:defRPr>
-            </a:lvl8pPr>
-            <a:lvl9pPr marL="3886200" indent="-228600" eaLnBrk="0" fontAlgn="base" hangingPunct="0">
-              <a:spcBef>
-                <a:spcPct val="35000"/>
-              </a:spcBef>
-              <a:spcAft>
-                <a:spcPct val="0"/>
-              </a:spcAft>
-              <a:buClr>
-                <a:srgbClr val="FF0066"/>
-              </a:buClr>
-              <a:buSzPct val="75000"/>
-              <a:buChar char="»"/>
-              <a:defRPr kumimoji="1">
-                <a:solidFill>
-                  <a:schemeClr val="tx1"/>
-                </a:solidFill>
-                <a:latin typeface="Helvetica" pitchFamily="2" charset="0"/>
-                <a:ea typeface="ＭＳ Ｐゴシック" panose="020B0600070205080204" pitchFamily="34" charset="-128"/>
-              </a:defRPr>
-            </a:lvl9pPr>
-          </a:lstStyle>
-          <a:p>
-            <a:pPr>
-              <a:spcBef>
-                <a:spcPct val="0"/>
-              </a:spcBef>
-              <a:buClrTx/>
-              <a:buSzTx/>
-              <a:buFontTx/>
-              <a:buNone/>
-            </a:pPr>
-            <a:endParaRPr kumimoji="0" lang="sk-SK" altLang="sk-SK">
-              <a:latin typeface="Verdana" panose="020B0604030504040204" pitchFamily="34" charset="0"/>
-            </a:endParaRPr>
-          </a:p>
-        </p:txBody>
-      </p:sp>
-      <p:sp>
-        <p:nvSpPr>
-          <p:cNvPr id="11266" name="Title 1">
-            <a:extLst>
-              <a:ext uri="{FF2B5EF4-FFF2-40B4-BE49-F238E27FC236}">
-                <a16:creationId xmlns:a16="http://schemas.microsoft.com/office/drawing/2014/main" id="{7B06A379-B64F-47DE-564C-698DDA899F2B}"/>
-              </a:ext>
-            </a:extLst>
-          </p:cNvPr>
-          <p:cNvSpPr>
-            <a:spLocks noGrp="1" noChangeArrowheads="1"/>
-          </p:cNvSpPr>
-          <p:nvPr>
-            <p:ph type="title"/>
-          </p:nvPr>
-        </p:nvSpPr>
-        <p:spPr>
-          <a:xfrm>
-            <a:off x="457200" y="287338"/>
-            <a:ext cx="8229600" cy="576262"/>
-          </a:xfrm>
-        </p:spPr>
-        <p:txBody>
-          <a:bodyPr/>
-          <a:lstStyle/>
-          <a:p>
-            <a:r>
-              <a:rPr lang="en-US" altLang="sk-SK">
-                <a:ea typeface="ＭＳ Ｐゴシック" panose="020B0600070205080204" pitchFamily="34" charset="-128"/>
-              </a:rPr>
-              <a:t>Implementation of VMMs</a:t>
-            </a:r>
-          </a:p>
-        </p:txBody>
-      </p:sp>
-      <p:sp>
-        <p:nvSpPr>
-          <p:cNvPr id="13315" name="Content Placeholder 2">
-            <a:extLst>
-              <a:ext uri="{FF2B5EF4-FFF2-40B4-BE49-F238E27FC236}">
-                <a16:creationId xmlns:a16="http://schemas.microsoft.com/office/drawing/2014/main" id="{0A471A76-63AA-6EA7-0D1A-0FDFC7E57021}"/>
-              </a:ext>
-            </a:extLst>
-          </p:cNvPr>
-          <p:cNvSpPr>
-            <a:spLocks noGrp="1" noChangeArrowheads="1"/>
-          </p:cNvSpPr>
-          <p:nvPr>
-            <p:ph idx="1"/>
-          </p:nvPr>
-        </p:nvSpPr>
-        <p:spPr>
-          <a:xfrm>
-            <a:off x="457200" y="1336675"/>
-            <a:ext cx="8229600" cy="4530725"/>
-          </a:xfrm>
-        </p:spPr>
-        <p:txBody>
-          <a:bodyPr>
-            <a:normAutofit fontScale="92500" lnSpcReduction="10000"/>
-          </a:bodyPr>
-          <a:lstStyle/>
-          <a:p>
-            <a:pPr>
-              <a:defRPr/>
-            </a:pPr>
-            <a:r>
-              <a:rPr lang="en-US" altLang="sk-SK" dirty="0">
-                <a:ea typeface="ＭＳ Ｐゴシック" panose="020B0600070205080204" pitchFamily="34" charset="-128"/>
-              </a:rPr>
-              <a:t>Vary greatly, with options including:</a:t>
-            </a:r>
-          </a:p>
-          <a:p>
-            <a:pPr lvl="1">
-              <a:defRPr/>
-            </a:pPr>
-            <a:r>
-              <a:rPr lang="en-US" altLang="sk-SK" b="1" dirty="0">
-                <a:solidFill>
-                  <a:srgbClr val="3366FF"/>
-                </a:solidFill>
-                <a:ea typeface="ＭＳ Ｐゴシック" panose="020B0600070205080204" pitchFamily="34" charset="-128"/>
-              </a:rPr>
-              <a:t>Type 0 hypervisors </a:t>
-            </a:r>
-            <a:r>
-              <a:rPr lang="en-US" altLang="sk-SK" b="1" dirty="0">
-                <a:ea typeface="ＭＳ Ｐゴシック" panose="020B0600070205080204" pitchFamily="34" charset="-128"/>
-              </a:rPr>
-              <a:t>- </a:t>
-            </a:r>
-            <a:r>
-              <a:rPr lang="en-US" altLang="sk-SK" dirty="0">
-                <a:ea typeface="ＭＳ Ｐゴシック" panose="020B0600070205080204" pitchFamily="34" charset="-128"/>
-              </a:rPr>
-              <a:t>Hardware-based solutions that provide support for virtual machine creation and management via firmware</a:t>
-            </a:r>
-          </a:p>
-          <a:p>
-            <a:pPr lvl="2">
-              <a:defRPr/>
-            </a:pPr>
-            <a:r>
-              <a:rPr lang="en-US" altLang="sk-SK" sz="1600" dirty="0">
-                <a:ea typeface="ＭＳ Ｐゴシック" panose="020B0600070205080204" pitchFamily="34" charset="-128"/>
-              </a:rPr>
-              <a:t>IBM LPARs </a:t>
-            </a:r>
-            <a:r>
-              <a:rPr lang="en-US" altLang="sk-SK" dirty="0">
-                <a:ea typeface="ＭＳ Ｐゴシック" panose="020B0600070205080204" pitchFamily="34" charset="-128"/>
-              </a:rPr>
-              <a:t>and Oracle </a:t>
-            </a:r>
-            <a:r>
-              <a:rPr lang="en-US" altLang="sk-SK" sz="1600" dirty="0">
-                <a:ea typeface="ＭＳ Ｐゴシック" panose="020B0600070205080204" pitchFamily="34" charset="-128"/>
-              </a:rPr>
-              <a:t>LDOMs </a:t>
-            </a:r>
-            <a:r>
-              <a:rPr lang="en-US" altLang="sk-SK" dirty="0">
-                <a:ea typeface="ＭＳ Ｐゴシック" panose="020B0600070205080204" pitchFamily="34" charset="-128"/>
-              </a:rPr>
-              <a:t>are examples</a:t>
-            </a:r>
-            <a:endParaRPr lang="en-US" altLang="sk-SK" sz="2800" dirty="0">
-              <a:ea typeface="ＭＳ Ｐゴシック" panose="020B0600070205080204" pitchFamily="34" charset="-128"/>
-            </a:endParaRPr>
-          </a:p>
-          <a:p>
-            <a:pPr lvl="1">
-              <a:defRPr/>
-            </a:pPr>
-            <a:r>
-              <a:rPr lang="en-US" altLang="sk-SK" b="1" dirty="0">
-                <a:solidFill>
-                  <a:srgbClr val="3366FF"/>
-                </a:solidFill>
-                <a:ea typeface="ＭＳ Ｐゴシック" panose="020B0600070205080204" pitchFamily="34" charset="-128"/>
-              </a:rPr>
-              <a:t>Type 1 hypervisors </a:t>
-            </a:r>
-            <a:r>
-              <a:rPr lang="en-US" altLang="sk-SK" b="1" dirty="0">
-                <a:ea typeface="ＭＳ Ｐゴシック" panose="020B0600070205080204" pitchFamily="34" charset="-128"/>
-              </a:rPr>
-              <a:t>- </a:t>
-            </a:r>
-            <a:r>
-              <a:rPr lang="en-US" altLang="sk-SK" dirty="0">
-                <a:ea typeface="ＭＳ Ｐゴシック" panose="020B0600070205080204" pitchFamily="34" charset="-128"/>
-              </a:rPr>
-              <a:t>Operating-system-like software built to provide virtualization</a:t>
-            </a:r>
-          </a:p>
-          <a:p>
-            <a:pPr lvl="2">
-              <a:defRPr/>
-            </a:pPr>
-            <a:r>
-              <a:rPr lang="en-US" altLang="sk-SK" dirty="0">
-                <a:ea typeface="ＭＳ Ｐゴシック" panose="020B0600070205080204" pitchFamily="34" charset="-128"/>
-              </a:rPr>
-              <a:t>Including </a:t>
-            </a:r>
-            <a:r>
-              <a:rPr lang="en-US" altLang="sk-SK" dirty="0">
-                <a:solidFill>
-                  <a:schemeClr val="accent1"/>
-                </a:solidFill>
-                <a:ea typeface="ＭＳ Ｐゴシック" panose="020B0600070205080204" pitchFamily="34" charset="-128"/>
-              </a:rPr>
-              <a:t>VMware ESX</a:t>
-            </a:r>
-            <a:r>
-              <a:rPr lang="en-US" altLang="sk-SK" dirty="0">
-                <a:ea typeface="ＭＳ Ｐゴシック" panose="020B0600070205080204" pitchFamily="34" charset="-128"/>
-              </a:rPr>
-              <a:t>, </a:t>
-            </a:r>
-            <a:r>
-              <a:rPr lang="en-US" altLang="sk-SK" dirty="0" err="1">
-                <a:ea typeface="ＭＳ Ｐゴシック" panose="020B0600070205080204" pitchFamily="34" charset="-128"/>
-              </a:rPr>
-              <a:t>Joyent</a:t>
-            </a:r>
-            <a:r>
-              <a:rPr lang="en-US" altLang="sk-SK" dirty="0">
-                <a:ea typeface="ＭＳ Ｐゴシック" panose="020B0600070205080204" pitchFamily="34" charset="-128"/>
-              </a:rPr>
-              <a:t> </a:t>
-            </a:r>
-            <a:r>
-              <a:rPr lang="en-US" altLang="sk-SK" dirty="0" err="1">
-                <a:ea typeface="ＭＳ Ｐゴシック" panose="020B0600070205080204" pitchFamily="34" charset="-128"/>
-              </a:rPr>
-              <a:t>Smart</a:t>
-            </a:r>
-            <a:r>
-              <a:rPr lang="en-US" altLang="sk-SK" sz="1600" dirty="0" err="1">
-                <a:ea typeface="ＭＳ Ｐゴシック" panose="020B0600070205080204" pitchFamily="34" charset="-128"/>
-              </a:rPr>
-              <a:t>OS</a:t>
-            </a:r>
-            <a:r>
-              <a:rPr lang="en-US" altLang="sk-SK" dirty="0">
-                <a:ea typeface="ＭＳ Ｐゴシック" panose="020B0600070205080204" pitchFamily="34" charset="-128"/>
-              </a:rPr>
-              <a:t>, and </a:t>
-            </a:r>
-            <a:r>
-              <a:rPr lang="en-US" altLang="sk-SK" dirty="0">
-                <a:solidFill>
-                  <a:schemeClr val="accent1"/>
-                </a:solidFill>
-                <a:ea typeface="ＭＳ Ｐゴシック" panose="020B0600070205080204" pitchFamily="34" charset="-128"/>
-              </a:rPr>
-              <a:t>Citrix </a:t>
-            </a:r>
-            <a:r>
-              <a:rPr lang="en-US" altLang="sk-SK" dirty="0" err="1">
-                <a:solidFill>
-                  <a:schemeClr val="accent1"/>
-                </a:solidFill>
-                <a:ea typeface="ＭＳ Ｐゴシック" panose="020B0600070205080204" pitchFamily="34" charset="-128"/>
-              </a:rPr>
-              <a:t>XenServer</a:t>
-            </a:r>
-            <a:r>
-              <a:rPr lang="en-US" altLang="sk-SK" dirty="0">
-                <a:solidFill>
-                  <a:schemeClr val="accent1"/>
-                </a:solidFill>
-                <a:ea typeface="ＭＳ Ｐゴシック" panose="020B0600070205080204" pitchFamily="34" charset="-128"/>
-              </a:rPr>
-              <a:t> </a:t>
-            </a:r>
-          </a:p>
-          <a:p>
-            <a:pPr lvl="1">
-              <a:defRPr/>
-            </a:pPr>
-            <a:r>
-              <a:rPr lang="en-US" altLang="sk-SK" b="1" dirty="0">
-                <a:solidFill>
-                  <a:srgbClr val="3366FF"/>
-                </a:solidFill>
-                <a:ea typeface="ＭＳ Ｐゴシック" panose="020B0600070205080204" pitchFamily="34" charset="-128"/>
-              </a:rPr>
-              <a:t>Type 1 hypervisors </a:t>
-            </a:r>
-            <a:r>
-              <a:rPr lang="en-US" altLang="sk-SK" b="1" dirty="0">
-                <a:ea typeface="ＭＳ Ｐゴシック" panose="020B0600070205080204" pitchFamily="34" charset="-128"/>
-              </a:rPr>
-              <a:t>– </a:t>
-            </a:r>
-            <a:r>
-              <a:rPr lang="en-US" altLang="sk-SK" dirty="0">
-                <a:ea typeface="ＭＳ Ｐゴシック" panose="020B0600070205080204" pitchFamily="34" charset="-128"/>
-              </a:rPr>
-              <a:t>Also includes general-purpose operating systems that provide standard functions as well as </a:t>
-            </a:r>
-            <a:r>
-              <a:rPr lang="en-US" altLang="sk-SK" sz="1600" dirty="0">
-                <a:ea typeface="ＭＳ Ｐゴシック" panose="020B0600070205080204" pitchFamily="34" charset="-128"/>
-              </a:rPr>
-              <a:t>VMM </a:t>
-            </a:r>
-            <a:r>
-              <a:rPr lang="en-US" altLang="sk-SK" dirty="0">
-                <a:ea typeface="ＭＳ Ｐゴシック" panose="020B0600070205080204" pitchFamily="34" charset="-128"/>
-              </a:rPr>
-              <a:t>functions</a:t>
-            </a:r>
-          </a:p>
-          <a:p>
-            <a:pPr lvl="2">
-              <a:defRPr/>
-            </a:pPr>
-            <a:r>
-              <a:rPr lang="en-US" altLang="sk-SK" dirty="0">
-                <a:ea typeface="ＭＳ Ｐゴシック" panose="020B0600070205080204" pitchFamily="34" charset="-128"/>
-              </a:rPr>
-              <a:t>Including Microsoft Windows Server with </a:t>
-            </a:r>
-            <a:r>
-              <a:rPr lang="en-US" altLang="sk-SK" dirty="0" err="1">
-                <a:solidFill>
-                  <a:schemeClr val="accent1"/>
-                </a:solidFill>
-                <a:ea typeface="ＭＳ Ｐゴシック" panose="020B0600070205080204" pitchFamily="34" charset="-128"/>
-              </a:rPr>
-              <a:t>HyperV</a:t>
-            </a:r>
-            <a:r>
-              <a:rPr lang="en-US" altLang="sk-SK" dirty="0">
-                <a:ea typeface="ＭＳ Ｐゴシック" panose="020B0600070205080204" pitchFamily="34" charset="-128"/>
-              </a:rPr>
-              <a:t> and RedHat Linux with </a:t>
-            </a:r>
-            <a:r>
-              <a:rPr lang="en-US" altLang="sk-SK" dirty="0">
-                <a:solidFill>
-                  <a:schemeClr val="accent1"/>
-                </a:solidFill>
-                <a:ea typeface="ＭＳ Ｐゴシック" panose="020B0600070205080204" pitchFamily="34" charset="-128"/>
-              </a:rPr>
-              <a:t>KVM</a:t>
-            </a:r>
-          </a:p>
-          <a:p>
-            <a:pPr lvl="1">
-              <a:defRPr/>
-            </a:pPr>
-            <a:r>
-              <a:rPr lang="en-US" altLang="sk-SK" b="1" dirty="0">
-                <a:solidFill>
-                  <a:srgbClr val="3366FF"/>
-                </a:solidFill>
-                <a:ea typeface="ＭＳ Ｐゴシック" panose="020B0600070205080204" pitchFamily="34" charset="-128"/>
-              </a:rPr>
-              <a:t>Type 2 hypervisors </a:t>
-            </a:r>
-            <a:r>
-              <a:rPr lang="en-US" altLang="sk-SK" b="1" dirty="0">
-                <a:ea typeface="ＭＳ Ｐゴシック" panose="020B0600070205080204" pitchFamily="34" charset="-128"/>
-              </a:rPr>
-              <a:t>- </a:t>
-            </a:r>
-            <a:r>
-              <a:rPr lang="en-US" altLang="sk-SK" dirty="0">
-                <a:ea typeface="ＭＳ Ｐゴシック" panose="020B0600070205080204" pitchFamily="34" charset="-128"/>
-              </a:rPr>
-              <a:t>Applications that run on standard operating systems but provide </a:t>
-            </a:r>
-            <a:r>
-              <a:rPr lang="en-US" altLang="sk-SK" sz="1600" dirty="0">
-                <a:ea typeface="ＭＳ Ｐゴシック" panose="020B0600070205080204" pitchFamily="34" charset="-128"/>
-              </a:rPr>
-              <a:t>VMM </a:t>
-            </a:r>
-            <a:r>
-              <a:rPr lang="en-US" altLang="sk-SK" dirty="0">
-                <a:ea typeface="ＭＳ Ｐゴシック" panose="020B0600070205080204" pitchFamily="34" charset="-128"/>
-              </a:rPr>
-              <a:t>features to guest operating systems</a:t>
-            </a:r>
-          </a:p>
-          <a:p>
-            <a:pPr lvl="2">
-              <a:defRPr/>
-            </a:pPr>
-            <a:r>
-              <a:rPr lang="en-US" altLang="sk-SK" dirty="0" err="1">
-                <a:ea typeface="ＭＳ Ｐゴシック" panose="020B0600070205080204" pitchFamily="34" charset="-128"/>
-              </a:rPr>
-              <a:t>Includeing</a:t>
-            </a:r>
-            <a:r>
-              <a:rPr lang="en-US" altLang="sk-SK" dirty="0">
-                <a:ea typeface="ＭＳ Ｐゴシック" panose="020B0600070205080204" pitchFamily="34" charset="-128"/>
-              </a:rPr>
-              <a:t> </a:t>
-            </a:r>
-            <a:r>
-              <a:rPr lang="en-US" altLang="sk-SK" dirty="0">
-                <a:solidFill>
-                  <a:schemeClr val="accent1"/>
-                </a:solidFill>
-                <a:ea typeface="ＭＳ Ｐゴシック" panose="020B0600070205080204" pitchFamily="34" charset="-128"/>
-              </a:rPr>
-              <a:t>VMware Workstation </a:t>
-            </a:r>
-            <a:r>
-              <a:rPr lang="en-US" altLang="sk-SK" dirty="0">
-                <a:ea typeface="ＭＳ Ｐゴシック" panose="020B0600070205080204" pitchFamily="34" charset="-128"/>
-              </a:rPr>
-              <a:t>and Fusion, Parallels Desktop, and </a:t>
-            </a:r>
-            <a:r>
-              <a:rPr lang="en-US" altLang="sk-SK" dirty="0">
-                <a:solidFill>
-                  <a:schemeClr val="accent1"/>
-                </a:solidFill>
-                <a:ea typeface="ＭＳ Ｐゴシック" panose="020B0600070205080204" pitchFamily="34" charset="-128"/>
-              </a:rPr>
-              <a:t>Oracle VirtualBox</a:t>
-            </a:r>
-            <a:endParaRPr lang="en-US" altLang="sk-SK" sz="2800" dirty="0">
-              <a:solidFill>
-                <a:schemeClr val="accent1"/>
-              </a:solidFill>
-              <a:ea typeface="ＭＳ Ｐゴシック" panose="020B0600070205080204" pitchFamily="34" charset="-128"/>
-            </a:endParaRPr>
-          </a:p>
-        </p:txBody>
-      </p:sp>
-    </p:spTree>
-  </p:cSld>
-  <p:clrMapOvr>
-    <a:masterClrMapping/>
-  </p:clrMapOvr>
-</p:sld>
-</file>
-
-<file path=ppt/slides/slide50.xml><?xml version="1.0" encoding="utf-8"?>
+<file path=ppt/slides/slide51.xml><?xml version="1.0" encoding="utf-8"?>
 <p:sld xmlns:a="http://schemas.openxmlformats.org/drawingml/2006/main" xmlns:r="http://schemas.openxmlformats.org/officeDocument/2006/relationships" xmlns:p="http://schemas.openxmlformats.org/presentationml/2006/main">
   <p:cSld>
     <p:spTree>

</xml_diff>